<commit_message>
Drop unverified MOS results; add baseline vs main mel comparison
</commit_message>
<xml_diff>
--- a/report/Colatron_Slides.pptx
+++ b/report/Colatron_Slides.pptx
@@ -121,14 +121,14 @@
   <p:extLst>
     <p:ext uri="{521415D9-36F7-43E2-AB2F-B90AF26B5E84}">
       <p14:sectionLst xmlns:p14="http://schemas.microsoft.com/office/powerpoint/2010/main">
-        <p14:section name="Introduction" id="{f9dca557-8256-eabf-d2dd-ce3933c1c700}">
+        <p14:section name="Introduction" id="{b0b2da48-93d8-0980-0f25-0c860169c42e}">
           <p14:sldIdLst>
             <p14:sldId id="256"/>
             <p14:sldId id="257"/>
             <p14:sldId id="258"/>
           </p14:sldIdLst>
         </p14:section>
-        <p14:section name="Approach" id="{9db82c45-0e15-9544-812e-9f5666583f01}">
+        <p14:section name="Approach" id="{1bb013b2-cf11-206d-2925-11622d518159}">
           <p14:sldIdLst>
             <p14:sldId id="259"/>
             <p14:sldId id="260"/>
@@ -137,7 +137,7 @@
             <p14:sldId id="263"/>
           </p14:sldIdLst>
         </p14:section>
-        <p14:section name="Results" id="{902313bb-e645-844c-7af4-d3803f313eca}">
+        <p14:section name="Results" id="{db37dcb0-d0b5-cb34-8db7-f3c7cc808f4e}">
           <p14:sldIdLst>
             <p14:sldId id="264"/>
             <p14:sldId id="265"/>
@@ -145,7 +145,7 @@
             <p14:sldId id="267"/>
           </p14:sldIdLst>
         </p14:section>
-        <p14:section name="Wrap-up" id="{adc05812-1360-f13c-ca30-e45bfa484363}">
+        <p14:section name="Wrap-up" id="{4bb81844-af89-40c0-e1ff-5215a861f0ef}">
           <p14:sldIdLst>
             <p14:sldId id="268"/>
             <p14:sldId id="269"/>
@@ -1505,7 +1505,7 @@
           <a:p>
             <a:r>
               <a:rPr lang="en-US" dirty="0"/>
-              <a:t>Replace 'pending' with the real means only once the Google Form responses are in and the table is regenerated with eval/results_table.py --ratings. Do not present numbers without the responses file.</a:t>
+              <a:t>Play samples/baseline/05.wav, then samples/main_hifigan/05.wav. The picture explains the sound: the baseline has no syllable structure at all. With equal time per character, its predictions never line up with real audio, so L1 training pushes it to the average spectrum. That is exactly why attention, or some learned timing, is needed.</a:t>
             </a:r>
             <a:endParaRPr lang="en-US" dirty="0"/>
           </a:p>
@@ -1857,7 +1857,7 @@
           <a:p>
             <a:r>
               <a:rPr lang="en-US" dirty="0"/>
-              <a:t>The 2018 team trained three models on about 200 sentences. Their best, a seq2seq LSTM with attention, scored 2.5 out of 5, well below Tacotron's 3.82. Its output repeated words.</a:t>
+              <a:t>The 2018 team trained three models on about 200 sentences. Their best, a seq2seq LSTM with attention, scored 2.5 out of 5 from 10 listeners, well below Tacotron's 3.82. Its output repeated words.</a:t>
             </a:r>
             <a:endParaRPr lang="en-US" dirty="0"/>
           </a:p>
@@ -2385,7 +2385,7 @@
           <a:p>
             <a:r>
               <a:rPr lang="en-US" dirty="0"/>
-              <a:t>Tacotron 2 is the architecture the paper wanted but could not train. We did not train it either; we use a pretrained checkpoint. Our work is wiring it into a shared mel format so vocoders are interchangeable and the attention can be inspected.</a:t>
+              <a:t>Tacotron 2 is the architecture the paper wanted but could not train: seq2seq with attention, done properly. We did not train it either; we use a pretrained checkpoint. Our work is wiring it into a shared mel format so vocoders are interchangeable and the attention can be inspected.</a:t>
             </a:r>
             <a:endParaRPr lang="en-US" dirty="0"/>
           </a:p>
@@ -5339,1192 +5339,96 @@
                 <a:ea typeface="Arial" pitchFamily="34" charset="-122"/>
                 <a:cs typeface="Arial" pitchFamily="34" charset="-120"/>
               </a:rPr>
-              <a:t>Listening test (MOS)</a:t>
+              <a:t>Why the baseline sounds like noise</a:t>
             </a:r>
             <a:endParaRPr lang="en-US" sz="3000" dirty="0"/>
           </a:p>
         </p:txBody>
       </p:sp>
-      <p:graphicFrame>
-        <p:nvGraphicFramePr>
-          <p:cNvPr id="13" name="MOS table"/>
-          <p:cNvGraphicFramePr>
-            <a:graphicFrameLocks noGrp="1"/>
-          </p:cNvGraphicFramePr>
-          <p:nvPr>
-            <p:extLst>
-              <p:ext uri="{D42A27DB-BD31-4B8C-83A1-F6EECF244321}">
-                <p14:modId xmlns:p14="http://schemas.microsoft.com/office/powerpoint/2010/main" val="1579011935"/>
-              </p:ext>
-            </p:extLst>
-          </p:nvPr>
-        </p:nvGraphicFramePr>
-        <p:xfrm>
-          <a:off x="457200" y="1051560"/>
-          <a:ext cx="4754880" cy="914400"/>
-        </p:xfrm>
-        <a:graphic>
-          <a:graphicData uri="http://schemas.openxmlformats.org/drawingml/2006/table">
-            <a:tbl>
-              <a:tblPr/>
-              <a:tblGrid>
-                <a:gridCol w="3291840"/>
-                <a:gridCol w="1463040"/>
-              </a:tblGrid>
-              <a:tr h="402336">
-                <a:tc>
-                  <a:txBody>
-                    <a:bodyPr/>
-                    <a:lstStyle/>
-                    <a:p>
-                      <a:pPr indent="0" marL="0">
-                        <a:buNone/>
-                      </a:pPr>
-                      <a:r>
-                        <a:rPr lang="en-US" sz="1300" b="1" dirty="0">
-                          <a:solidFill>
-                            <a:srgbClr val="FFFFFF"/>
-                          </a:solidFill>
-                          <a:latin typeface="Calibri" pitchFamily="34" charset="0"/>
-                          <a:ea typeface="Calibri" pitchFamily="34" charset="-122"/>
-                          <a:cs typeface="Calibri" pitchFamily="34" charset="-120"/>
-                        </a:rPr>
-                        <a:t>System</a:t>
-                      </a:r>
-                      <a:endParaRPr lang="en-US" sz="1300" dirty="0">
-                        <a:latin typeface="Calibri" charset="0"/>
-                        <a:ea typeface="Calibri" charset="0"/>
-                        <a:cs typeface="Calibri" charset="0"/>
-                      </a:endParaRPr>
-                    </a:p>
-                  </a:txBody>
-                  <a:tcPr marL="91440" marR="91440" marT="45720" marB="45720" anchor="ctr">
-                    <a:lnL w="9525" cap="flat" cmpd="sng" algn="ctr">
-                      <a:solidFill>
-                        <a:srgbClr val="DDD8EC"/>
-                      </a:solidFill>
-                      <a:prstDash val="solid"/>
-                      <a:round/>
-                      <a:headEnd type="none" w="med" len="med"/>
-                      <a:tailEnd type="none" w="med" len="med"/>
-                    </a:lnL>
-                    <a:lnR w="9525" cap="flat" cmpd="sng" algn="ctr">
-                      <a:solidFill>
-                        <a:srgbClr val="DDD8EC"/>
-                      </a:solidFill>
-                      <a:prstDash val="solid"/>
-                      <a:round/>
-                      <a:headEnd type="none" w="med" len="med"/>
-                      <a:tailEnd type="none" w="med" len="med"/>
-                    </a:lnR>
-                    <a:lnT w="9525" cap="flat" cmpd="sng" algn="ctr">
-                      <a:solidFill>
-                        <a:srgbClr val="DDD8EC"/>
-                      </a:solidFill>
-                      <a:prstDash val="solid"/>
-                      <a:round/>
-                      <a:headEnd type="none" w="med" len="med"/>
-                      <a:tailEnd type="none" w="med" len="med"/>
-                    </a:lnT>
-                    <a:lnB w="9525" cap="flat" cmpd="sng" algn="ctr">
-                      <a:solidFill>
-                        <a:srgbClr val="DDD8EC"/>
-                      </a:solidFill>
-                      <a:prstDash val="solid"/>
-                      <a:round/>
-                      <a:headEnd type="none" w="med" len="med"/>
-                      <a:tailEnd type="none" w="med" len="med"/>
-                    </a:lnB>
-                    <a:solidFill>
-                      <a:srgbClr val="251E52"/>
-                    </a:solidFill>
-                  </a:tcPr>
-                </a:tc>
-                <a:tc>
-                  <a:txBody>
-                    <a:bodyPr/>
-                    <a:lstStyle/>
-                    <a:p>
-                      <a:pPr algn="ctr" indent="0" marL="0">
-                        <a:buNone/>
-                      </a:pPr>
-                      <a:r>
-                        <a:rPr lang="en-US" sz="1300" b="1" dirty="0">
-                          <a:solidFill>
-                            <a:srgbClr val="FFFFFF"/>
-                          </a:solidFill>
-                          <a:latin typeface="Calibri" pitchFamily="34" charset="0"/>
-                          <a:ea typeface="Calibri" pitchFamily="34" charset="-122"/>
-                          <a:cs typeface="Calibri" pitchFamily="34" charset="-120"/>
-                        </a:rPr>
-                        <a:t>MOS (1–5)</a:t>
-                      </a:r>
-                      <a:endParaRPr lang="en-US" sz="1300" dirty="0">
-                        <a:latin typeface="Calibri" charset="0"/>
-                        <a:ea typeface="Calibri" charset="0"/>
-                        <a:cs typeface="Calibri" charset="0"/>
-                      </a:endParaRPr>
-                    </a:p>
-                  </a:txBody>
-                  <a:tcPr marL="91440" marR="91440" marT="45720" marB="45720" anchor="ctr">
-                    <a:lnL w="9525" cap="flat" cmpd="sng" algn="ctr">
-                      <a:solidFill>
-                        <a:srgbClr val="DDD8EC"/>
-                      </a:solidFill>
-                      <a:prstDash val="solid"/>
-                      <a:round/>
-                      <a:headEnd type="none" w="med" len="med"/>
-                      <a:tailEnd type="none" w="med" len="med"/>
-                    </a:lnL>
-                    <a:lnR w="9525" cap="flat" cmpd="sng" algn="ctr">
-                      <a:solidFill>
-                        <a:srgbClr val="DDD8EC"/>
-                      </a:solidFill>
-                      <a:prstDash val="solid"/>
-                      <a:round/>
-                      <a:headEnd type="none" w="med" len="med"/>
-                      <a:tailEnd type="none" w="med" len="med"/>
-                    </a:lnR>
-                    <a:lnT w="9525" cap="flat" cmpd="sng" algn="ctr">
-                      <a:solidFill>
-                        <a:srgbClr val="DDD8EC"/>
-                      </a:solidFill>
-                      <a:prstDash val="solid"/>
-                      <a:round/>
-                      <a:headEnd type="none" w="med" len="med"/>
-                      <a:tailEnd type="none" w="med" len="med"/>
-                    </a:lnT>
-                    <a:lnB w="9525" cap="flat" cmpd="sng" algn="ctr">
-                      <a:solidFill>
-                        <a:srgbClr val="DDD8EC"/>
-                      </a:solidFill>
-                      <a:prstDash val="solid"/>
-                      <a:round/>
-                      <a:headEnd type="none" w="med" len="med"/>
-                      <a:tailEnd type="none" w="med" len="med"/>
-                    </a:lnB>
-                    <a:solidFill>
-                      <a:srgbClr val="251E52"/>
-                    </a:solidFill>
-                  </a:tcPr>
-                </a:tc>
-              </a:tr>
-              <a:tr h="402336">
-                <a:tc>
-                  <a:txBody>
-                    <a:bodyPr/>
-                    <a:lstStyle/>
-                    <a:p>
-                      <a:pPr indent="0" marL="0">
-                        <a:buNone/>
-                      </a:pPr>
-                      <a:r>
-                        <a:rPr lang="en-US" sz="1300" dirty="0">
-                          <a:solidFill>
-                            <a:srgbClr val="1C1A2E"/>
-                          </a:solidFill>
-                          <a:latin typeface="Calibri" pitchFamily="34" charset="0"/>
-                          <a:ea typeface="Calibri" pitchFamily="34" charset="-122"/>
-                          <a:cs typeface="Calibri" pitchFamily="34" charset="-120"/>
-                        </a:rPr>
-                        <a:t>2018: SVR</a:t>
-                      </a:r>
-                      <a:endParaRPr lang="en-US" sz="1300" dirty="0">
-                        <a:latin typeface="Calibri" charset="0"/>
-                        <a:ea typeface="Calibri" charset="0"/>
-                        <a:cs typeface="Calibri" charset="0"/>
-                      </a:endParaRPr>
-                    </a:p>
-                  </a:txBody>
-                  <a:tcPr marL="91440" marR="91440" marT="45720" marB="45720" anchor="ctr">
-                    <a:lnL w="9525" cap="flat" cmpd="sng" algn="ctr">
-                      <a:solidFill>
-                        <a:srgbClr val="DDD8EC"/>
-                      </a:solidFill>
-                      <a:prstDash val="solid"/>
-                      <a:round/>
-                      <a:headEnd type="none" w="med" len="med"/>
-                      <a:tailEnd type="none" w="med" len="med"/>
-                    </a:lnL>
-                    <a:lnR w="9525" cap="flat" cmpd="sng" algn="ctr">
-                      <a:solidFill>
-                        <a:srgbClr val="DDD8EC"/>
-                      </a:solidFill>
-                      <a:prstDash val="solid"/>
-                      <a:round/>
-                      <a:headEnd type="none" w="med" len="med"/>
-                      <a:tailEnd type="none" w="med" len="med"/>
-                    </a:lnR>
-                    <a:lnT w="9525" cap="flat" cmpd="sng" algn="ctr">
-                      <a:solidFill>
-                        <a:srgbClr val="DDD8EC"/>
-                      </a:solidFill>
-                      <a:prstDash val="solid"/>
-                      <a:round/>
-                      <a:headEnd type="none" w="med" len="med"/>
-                      <a:tailEnd type="none" w="med" len="med"/>
-                    </a:lnT>
-                    <a:lnB w="9525" cap="flat" cmpd="sng" algn="ctr">
-                      <a:solidFill>
-                        <a:srgbClr val="DDD8EC"/>
-                      </a:solidFill>
-                      <a:prstDash val="solid"/>
-                      <a:round/>
-                      <a:headEnd type="none" w="med" len="med"/>
-                      <a:tailEnd type="none" w="med" len="med"/>
-                    </a:lnB>
-                    <a:solidFill>
-                      <a:srgbClr val="FFFFFF"/>
-                    </a:solidFill>
-                  </a:tcPr>
-                </a:tc>
-                <a:tc>
-                  <a:txBody>
-                    <a:bodyPr/>
-                    <a:lstStyle/>
-                    <a:p>
-                      <a:pPr algn="ctr" indent="0" marL="0">
-                        <a:buNone/>
-                      </a:pPr>
-                      <a:r>
-                        <a:rPr lang="en-US" sz="1300" dirty="0">
-                          <a:solidFill>
-                            <a:srgbClr val="1C1A2E"/>
-                          </a:solidFill>
-                          <a:latin typeface="Calibri" pitchFamily="34" charset="0"/>
-                          <a:ea typeface="Calibri" pitchFamily="34" charset="-122"/>
-                          <a:cs typeface="Calibri" pitchFamily="34" charset="-120"/>
-                        </a:rPr>
-                        <a:t>1.0</a:t>
-                      </a:r>
-                      <a:endParaRPr lang="en-US" sz="1300" dirty="0">
-                        <a:latin typeface="Calibri" charset="0"/>
-                        <a:ea typeface="Calibri" charset="0"/>
-                        <a:cs typeface="Calibri" charset="0"/>
-                      </a:endParaRPr>
-                    </a:p>
-                  </a:txBody>
-                  <a:tcPr marL="91440" marR="91440" marT="45720" marB="45720" anchor="ctr">
-                    <a:lnL w="9525" cap="flat" cmpd="sng" algn="ctr">
-                      <a:solidFill>
-                        <a:srgbClr val="DDD8EC"/>
-                      </a:solidFill>
-                      <a:prstDash val="solid"/>
-                      <a:round/>
-                      <a:headEnd type="none" w="med" len="med"/>
-                      <a:tailEnd type="none" w="med" len="med"/>
-                    </a:lnL>
-                    <a:lnR w="9525" cap="flat" cmpd="sng" algn="ctr">
-                      <a:solidFill>
-                        <a:srgbClr val="DDD8EC"/>
-                      </a:solidFill>
-                      <a:prstDash val="solid"/>
-                      <a:round/>
-                      <a:headEnd type="none" w="med" len="med"/>
-                      <a:tailEnd type="none" w="med" len="med"/>
-                    </a:lnR>
-                    <a:lnT w="9525" cap="flat" cmpd="sng" algn="ctr">
-                      <a:solidFill>
-                        <a:srgbClr val="DDD8EC"/>
-                      </a:solidFill>
-                      <a:prstDash val="solid"/>
-                      <a:round/>
-                      <a:headEnd type="none" w="med" len="med"/>
-                      <a:tailEnd type="none" w="med" len="med"/>
-                    </a:lnT>
-                    <a:lnB w="9525" cap="flat" cmpd="sng" algn="ctr">
-                      <a:solidFill>
-                        <a:srgbClr val="DDD8EC"/>
-                      </a:solidFill>
-                      <a:prstDash val="solid"/>
-                      <a:round/>
-                      <a:headEnd type="none" w="med" len="med"/>
-                      <a:tailEnd type="none" w="med" len="med"/>
-                    </a:lnB>
-                    <a:solidFill>
-                      <a:srgbClr val="FFFFFF"/>
-                    </a:solidFill>
-                  </a:tcPr>
-                </a:tc>
-              </a:tr>
-              <a:tr h="402336">
-                <a:tc>
-                  <a:txBody>
-                    <a:bodyPr/>
-                    <a:lstStyle/>
-                    <a:p>
-                      <a:pPr indent="0" marL="0">
-                        <a:buNone/>
-                      </a:pPr>
-                      <a:r>
-                        <a:rPr lang="en-US" sz="1300" dirty="0">
-                          <a:solidFill>
-                            <a:srgbClr val="1C1A2E"/>
-                          </a:solidFill>
-                          <a:latin typeface="Calibri" pitchFamily="34" charset="0"/>
-                          <a:ea typeface="Calibri" pitchFamily="34" charset="-122"/>
-                          <a:cs typeface="Calibri" pitchFamily="34" charset="-120"/>
-                        </a:rPr>
-                        <a:t>2018: simple NN</a:t>
-                      </a:r>
-                      <a:endParaRPr lang="en-US" sz="1300" dirty="0">
-                        <a:latin typeface="Calibri" charset="0"/>
-                        <a:ea typeface="Calibri" charset="0"/>
-                        <a:cs typeface="Calibri" charset="0"/>
-                      </a:endParaRPr>
-                    </a:p>
-                  </a:txBody>
-                  <a:tcPr marL="91440" marR="91440" marT="45720" marB="45720" anchor="ctr">
-                    <a:lnL w="9525" cap="flat" cmpd="sng" algn="ctr">
-                      <a:solidFill>
-                        <a:srgbClr val="DDD8EC"/>
-                      </a:solidFill>
-                      <a:prstDash val="solid"/>
-                      <a:round/>
-                      <a:headEnd type="none" w="med" len="med"/>
-                      <a:tailEnd type="none" w="med" len="med"/>
-                    </a:lnL>
-                    <a:lnR w="9525" cap="flat" cmpd="sng" algn="ctr">
-                      <a:solidFill>
-                        <a:srgbClr val="DDD8EC"/>
-                      </a:solidFill>
-                      <a:prstDash val="solid"/>
-                      <a:round/>
-                      <a:headEnd type="none" w="med" len="med"/>
-                      <a:tailEnd type="none" w="med" len="med"/>
-                    </a:lnR>
-                    <a:lnT w="9525" cap="flat" cmpd="sng" algn="ctr">
-                      <a:solidFill>
-                        <a:srgbClr val="DDD8EC"/>
-                      </a:solidFill>
-                      <a:prstDash val="solid"/>
-                      <a:round/>
-                      <a:headEnd type="none" w="med" len="med"/>
-                      <a:tailEnd type="none" w="med" len="med"/>
-                    </a:lnT>
-                    <a:lnB w="9525" cap="flat" cmpd="sng" algn="ctr">
-                      <a:solidFill>
-                        <a:srgbClr val="DDD8EC"/>
-                      </a:solidFill>
-                      <a:prstDash val="solid"/>
-                      <a:round/>
-                      <a:headEnd type="none" w="med" len="med"/>
-                      <a:tailEnd type="none" w="med" len="med"/>
-                    </a:lnB>
-                    <a:solidFill>
-                      <a:srgbClr val="FFFFFF"/>
-                    </a:solidFill>
-                  </a:tcPr>
-                </a:tc>
-                <a:tc>
-                  <a:txBody>
-                    <a:bodyPr/>
-                    <a:lstStyle/>
-                    <a:p>
-                      <a:pPr algn="ctr" indent="0" marL="0">
-                        <a:buNone/>
-                      </a:pPr>
-                      <a:r>
-                        <a:rPr lang="en-US" sz="1300" dirty="0">
-                          <a:solidFill>
-                            <a:srgbClr val="1C1A2E"/>
-                          </a:solidFill>
-                          <a:latin typeface="Calibri" pitchFamily="34" charset="0"/>
-                          <a:ea typeface="Calibri" pitchFamily="34" charset="-122"/>
-                          <a:cs typeface="Calibri" pitchFamily="34" charset="-120"/>
-                        </a:rPr>
-                        <a:t>1.7</a:t>
-                      </a:r>
-                      <a:endParaRPr lang="en-US" sz="1300" dirty="0">
-                        <a:latin typeface="Calibri" charset="0"/>
-                        <a:ea typeface="Calibri" charset="0"/>
-                        <a:cs typeface="Calibri" charset="0"/>
-                      </a:endParaRPr>
-                    </a:p>
-                  </a:txBody>
-                  <a:tcPr marL="91440" marR="91440" marT="45720" marB="45720" anchor="ctr">
-                    <a:lnL w="9525" cap="flat" cmpd="sng" algn="ctr">
-                      <a:solidFill>
-                        <a:srgbClr val="DDD8EC"/>
-                      </a:solidFill>
-                      <a:prstDash val="solid"/>
-                      <a:round/>
-                      <a:headEnd type="none" w="med" len="med"/>
-                      <a:tailEnd type="none" w="med" len="med"/>
-                    </a:lnL>
-                    <a:lnR w="9525" cap="flat" cmpd="sng" algn="ctr">
-                      <a:solidFill>
-                        <a:srgbClr val="DDD8EC"/>
-                      </a:solidFill>
-                      <a:prstDash val="solid"/>
-                      <a:round/>
-                      <a:headEnd type="none" w="med" len="med"/>
-                      <a:tailEnd type="none" w="med" len="med"/>
-                    </a:lnR>
-                    <a:lnT w="9525" cap="flat" cmpd="sng" algn="ctr">
-                      <a:solidFill>
-                        <a:srgbClr val="DDD8EC"/>
-                      </a:solidFill>
-                      <a:prstDash val="solid"/>
-                      <a:round/>
-                      <a:headEnd type="none" w="med" len="med"/>
-                      <a:tailEnd type="none" w="med" len="med"/>
-                    </a:lnT>
-                    <a:lnB w="9525" cap="flat" cmpd="sng" algn="ctr">
-                      <a:solidFill>
-                        <a:srgbClr val="DDD8EC"/>
-                      </a:solidFill>
-                      <a:prstDash val="solid"/>
-                      <a:round/>
-                      <a:headEnd type="none" w="med" len="med"/>
-                      <a:tailEnd type="none" w="med" len="med"/>
-                    </a:lnB>
-                    <a:solidFill>
-                      <a:srgbClr val="FFFFFF"/>
-                    </a:solidFill>
-                  </a:tcPr>
-                </a:tc>
-              </a:tr>
-              <a:tr h="402336">
-                <a:tc>
-                  <a:txBody>
-                    <a:bodyPr/>
-                    <a:lstStyle/>
-                    <a:p>
-                      <a:pPr indent="0" marL="0">
-                        <a:buNone/>
-                      </a:pPr>
-                      <a:r>
-                        <a:rPr lang="en-US" sz="1300" dirty="0">
-                          <a:solidFill>
-                            <a:srgbClr val="1C1A2E"/>
-                          </a:solidFill>
-                          <a:latin typeface="Calibri" pitchFamily="34" charset="0"/>
-                          <a:ea typeface="Calibri" pitchFamily="34" charset="-122"/>
-                          <a:cs typeface="Calibri" pitchFamily="34" charset="-120"/>
-                        </a:rPr>
-                        <a:t>2018: seq2seq + attention</a:t>
-                      </a:r>
-                      <a:endParaRPr lang="en-US" sz="1300" dirty="0">
-                        <a:latin typeface="Calibri" charset="0"/>
-                        <a:ea typeface="Calibri" charset="0"/>
-                        <a:cs typeface="Calibri" charset="0"/>
-                      </a:endParaRPr>
-                    </a:p>
-                  </a:txBody>
-                  <a:tcPr marL="91440" marR="91440" marT="45720" marB="45720" anchor="ctr">
-                    <a:lnL w="9525" cap="flat" cmpd="sng" algn="ctr">
-                      <a:solidFill>
-                        <a:srgbClr val="DDD8EC"/>
-                      </a:solidFill>
-                      <a:prstDash val="solid"/>
-                      <a:round/>
-                      <a:headEnd type="none" w="med" len="med"/>
-                      <a:tailEnd type="none" w="med" len="med"/>
-                    </a:lnL>
-                    <a:lnR w="9525" cap="flat" cmpd="sng" algn="ctr">
-                      <a:solidFill>
-                        <a:srgbClr val="DDD8EC"/>
-                      </a:solidFill>
-                      <a:prstDash val="solid"/>
-                      <a:round/>
-                      <a:headEnd type="none" w="med" len="med"/>
-                      <a:tailEnd type="none" w="med" len="med"/>
-                    </a:lnR>
-                    <a:lnT w="9525" cap="flat" cmpd="sng" algn="ctr">
-                      <a:solidFill>
-                        <a:srgbClr val="DDD8EC"/>
-                      </a:solidFill>
-                      <a:prstDash val="solid"/>
-                      <a:round/>
-                      <a:headEnd type="none" w="med" len="med"/>
-                      <a:tailEnd type="none" w="med" len="med"/>
-                    </a:lnT>
-                    <a:lnB w="9525" cap="flat" cmpd="sng" algn="ctr">
-                      <a:solidFill>
-                        <a:srgbClr val="DDD8EC"/>
-                      </a:solidFill>
-                      <a:prstDash val="solid"/>
-                      <a:round/>
-                      <a:headEnd type="none" w="med" len="med"/>
-                      <a:tailEnd type="none" w="med" len="med"/>
-                    </a:lnB>
-                    <a:solidFill>
-                      <a:srgbClr val="FFFFFF"/>
-                    </a:solidFill>
-                  </a:tcPr>
-                </a:tc>
-                <a:tc>
-                  <a:txBody>
-                    <a:bodyPr/>
-                    <a:lstStyle/>
-                    <a:p>
-                      <a:pPr algn="ctr" indent="0" marL="0">
-                        <a:buNone/>
-                      </a:pPr>
-                      <a:r>
-                        <a:rPr lang="en-US" sz="1300" dirty="0">
-                          <a:solidFill>
-                            <a:srgbClr val="1C1A2E"/>
-                          </a:solidFill>
-                          <a:latin typeface="Calibri" pitchFamily="34" charset="0"/>
-                          <a:ea typeface="Calibri" pitchFamily="34" charset="-122"/>
-                          <a:cs typeface="Calibri" pitchFamily="34" charset="-120"/>
-                        </a:rPr>
-                        <a:t>2.5</a:t>
-                      </a:r>
-                      <a:endParaRPr lang="en-US" sz="1300" dirty="0">
-                        <a:latin typeface="Calibri" charset="0"/>
-                        <a:ea typeface="Calibri" charset="0"/>
-                        <a:cs typeface="Calibri" charset="0"/>
-                      </a:endParaRPr>
-                    </a:p>
-                  </a:txBody>
-                  <a:tcPr marL="91440" marR="91440" marT="45720" marB="45720" anchor="ctr">
-                    <a:lnL w="9525" cap="flat" cmpd="sng" algn="ctr">
-                      <a:solidFill>
-                        <a:srgbClr val="DDD8EC"/>
-                      </a:solidFill>
-                      <a:prstDash val="solid"/>
-                      <a:round/>
-                      <a:headEnd type="none" w="med" len="med"/>
-                      <a:tailEnd type="none" w="med" len="med"/>
-                    </a:lnL>
-                    <a:lnR w="9525" cap="flat" cmpd="sng" algn="ctr">
-                      <a:solidFill>
-                        <a:srgbClr val="DDD8EC"/>
-                      </a:solidFill>
-                      <a:prstDash val="solid"/>
-                      <a:round/>
-                      <a:headEnd type="none" w="med" len="med"/>
-                      <a:tailEnd type="none" w="med" len="med"/>
-                    </a:lnR>
-                    <a:lnT w="9525" cap="flat" cmpd="sng" algn="ctr">
-                      <a:solidFill>
-                        <a:srgbClr val="DDD8EC"/>
-                      </a:solidFill>
-                      <a:prstDash val="solid"/>
-                      <a:round/>
-                      <a:headEnd type="none" w="med" len="med"/>
-                      <a:tailEnd type="none" w="med" len="med"/>
-                    </a:lnT>
-                    <a:lnB w="9525" cap="flat" cmpd="sng" algn="ctr">
-                      <a:solidFill>
-                        <a:srgbClr val="DDD8EC"/>
-                      </a:solidFill>
-                      <a:prstDash val="solid"/>
-                      <a:round/>
-                      <a:headEnd type="none" w="med" len="med"/>
-                      <a:tailEnd type="none" w="med" len="med"/>
-                    </a:lnB>
-                    <a:solidFill>
-                      <a:srgbClr val="FFFFFF"/>
-                    </a:solidFill>
-                  </a:tcPr>
-                </a:tc>
-              </a:tr>
-              <a:tr h="402336">
-                <a:tc>
-                  <a:txBody>
-                    <a:bodyPr/>
-                    <a:lstStyle/>
-                    <a:p>
-                      <a:pPr indent="0" marL="0">
-                        <a:buNone/>
-                      </a:pPr>
-                      <a:r>
-                        <a:rPr lang="en-US" sz="1300" dirty="0">
-                          <a:solidFill>
-                            <a:srgbClr val="1C1A2E"/>
-                          </a:solidFill>
-                          <a:latin typeface="Calibri" pitchFamily="34" charset="0"/>
-                          <a:ea typeface="Calibri" pitchFamily="34" charset="-122"/>
-                          <a:cs typeface="Calibri" pitchFamily="34" charset="-120"/>
-                        </a:rPr>
-                        <a:t>Tacotron (Google, reported)</a:t>
-                      </a:r>
-                      <a:endParaRPr lang="en-US" sz="1300" dirty="0">
-                        <a:latin typeface="Calibri" charset="0"/>
-                        <a:ea typeface="Calibri" charset="0"/>
-                        <a:cs typeface="Calibri" charset="0"/>
-                      </a:endParaRPr>
-                    </a:p>
-                  </a:txBody>
-                  <a:tcPr marL="91440" marR="91440" marT="45720" marB="45720" anchor="ctr">
-                    <a:lnL w="9525" cap="flat" cmpd="sng" algn="ctr">
-                      <a:solidFill>
-                        <a:srgbClr val="DDD8EC"/>
-                      </a:solidFill>
-                      <a:prstDash val="solid"/>
-                      <a:round/>
-                      <a:headEnd type="none" w="med" len="med"/>
-                      <a:tailEnd type="none" w="med" len="med"/>
-                    </a:lnL>
-                    <a:lnR w="9525" cap="flat" cmpd="sng" algn="ctr">
-                      <a:solidFill>
-                        <a:srgbClr val="DDD8EC"/>
-                      </a:solidFill>
-                      <a:prstDash val="solid"/>
-                      <a:round/>
-                      <a:headEnd type="none" w="med" len="med"/>
-                      <a:tailEnd type="none" w="med" len="med"/>
-                    </a:lnR>
-                    <a:lnT w="9525" cap="flat" cmpd="sng" algn="ctr">
-                      <a:solidFill>
-                        <a:srgbClr val="DDD8EC"/>
-                      </a:solidFill>
-                      <a:prstDash val="solid"/>
-                      <a:round/>
-                      <a:headEnd type="none" w="med" len="med"/>
-                      <a:tailEnd type="none" w="med" len="med"/>
-                    </a:lnT>
-                    <a:lnB w="9525" cap="flat" cmpd="sng" algn="ctr">
-                      <a:solidFill>
-                        <a:srgbClr val="DDD8EC"/>
-                      </a:solidFill>
-                      <a:prstDash val="solid"/>
-                      <a:round/>
-                      <a:headEnd type="none" w="med" len="med"/>
-                      <a:tailEnd type="none" w="med" len="med"/>
-                    </a:lnB>
-                    <a:solidFill>
-                      <a:srgbClr val="FFFFFF"/>
-                    </a:solidFill>
-                  </a:tcPr>
-                </a:tc>
-                <a:tc>
-                  <a:txBody>
-                    <a:bodyPr/>
-                    <a:lstStyle/>
-                    <a:p>
-                      <a:pPr algn="ctr" indent="0" marL="0">
-                        <a:buNone/>
-                      </a:pPr>
-                      <a:r>
-                        <a:rPr lang="en-US" sz="1300" dirty="0">
-                          <a:solidFill>
-                            <a:srgbClr val="1C1A2E"/>
-                          </a:solidFill>
-                          <a:latin typeface="Calibri" pitchFamily="34" charset="0"/>
-                          <a:ea typeface="Calibri" pitchFamily="34" charset="-122"/>
-                          <a:cs typeface="Calibri" pitchFamily="34" charset="-120"/>
-                        </a:rPr>
-                        <a:t>3.82</a:t>
-                      </a:r>
-                      <a:endParaRPr lang="en-US" sz="1300" dirty="0">
-                        <a:latin typeface="Calibri" charset="0"/>
-                        <a:ea typeface="Calibri" charset="0"/>
-                        <a:cs typeface="Calibri" charset="0"/>
-                      </a:endParaRPr>
-                    </a:p>
-                  </a:txBody>
-                  <a:tcPr marL="91440" marR="91440" marT="45720" marB="45720" anchor="ctr">
-                    <a:lnL w="9525" cap="flat" cmpd="sng" algn="ctr">
-                      <a:solidFill>
-                        <a:srgbClr val="DDD8EC"/>
-                      </a:solidFill>
-                      <a:prstDash val="solid"/>
-                      <a:round/>
-                      <a:headEnd type="none" w="med" len="med"/>
-                      <a:tailEnd type="none" w="med" len="med"/>
-                    </a:lnL>
-                    <a:lnR w="9525" cap="flat" cmpd="sng" algn="ctr">
-                      <a:solidFill>
-                        <a:srgbClr val="DDD8EC"/>
-                      </a:solidFill>
-                      <a:prstDash val="solid"/>
-                      <a:round/>
-                      <a:headEnd type="none" w="med" len="med"/>
-                      <a:tailEnd type="none" w="med" len="med"/>
-                    </a:lnR>
-                    <a:lnT w="9525" cap="flat" cmpd="sng" algn="ctr">
-                      <a:solidFill>
-                        <a:srgbClr val="DDD8EC"/>
-                      </a:solidFill>
-                      <a:prstDash val="solid"/>
-                      <a:round/>
-                      <a:headEnd type="none" w="med" len="med"/>
-                      <a:tailEnd type="none" w="med" len="med"/>
-                    </a:lnT>
-                    <a:lnB w="9525" cap="flat" cmpd="sng" algn="ctr">
-                      <a:solidFill>
-                        <a:srgbClr val="DDD8EC"/>
-                      </a:solidFill>
-                      <a:prstDash val="solid"/>
-                      <a:round/>
-                      <a:headEnd type="none" w="med" len="med"/>
-                      <a:tailEnd type="none" w="med" len="med"/>
-                    </a:lnB>
-                    <a:solidFill>
-                      <a:srgbClr val="FFFFFF"/>
-                    </a:solidFill>
-                  </a:tcPr>
-                </a:tc>
-              </a:tr>
-              <a:tr h="402336">
-                <a:tc>
-                  <a:txBody>
-                    <a:bodyPr/>
-                    <a:lstStyle/>
-                    <a:p>
-                      <a:pPr indent="0" marL="0">
-                        <a:buNone/>
-                      </a:pPr>
-                      <a:r>
-                        <a:rPr lang="en-US" sz="1300" b="1" dirty="0">
-                          <a:solidFill>
-                            <a:srgbClr val="5B3FD9"/>
-                          </a:solidFill>
-                          <a:latin typeface="Calibri" pitchFamily="34" charset="0"/>
-                          <a:ea typeface="Calibri" pitchFamily="34" charset="-122"/>
-                          <a:cs typeface="Calibri" pitchFamily="34" charset="-120"/>
-                        </a:rPr>
-                        <a:t>Ours: baseline + Griffin-Lim</a:t>
-                      </a:r>
-                      <a:endParaRPr lang="en-US" sz="1300" dirty="0">
-                        <a:latin typeface="Calibri" charset="0"/>
-                        <a:ea typeface="Calibri" charset="0"/>
-                        <a:cs typeface="Calibri" charset="0"/>
-                      </a:endParaRPr>
-                    </a:p>
-                  </a:txBody>
-                  <a:tcPr marL="91440" marR="91440" marT="45720" marB="45720" anchor="ctr">
-                    <a:lnL w="9525" cap="flat" cmpd="sng" algn="ctr">
-                      <a:solidFill>
-                        <a:srgbClr val="DDD8EC"/>
-                      </a:solidFill>
-                      <a:prstDash val="solid"/>
-                      <a:round/>
-                      <a:headEnd type="none" w="med" len="med"/>
-                      <a:tailEnd type="none" w="med" len="med"/>
-                    </a:lnL>
-                    <a:lnR w="9525" cap="flat" cmpd="sng" algn="ctr">
-                      <a:solidFill>
-                        <a:srgbClr val="DDD8EC"/>
-                      </a:solidFill>
-                      <a:prstDash val="solid"/>
-                      <a:round/>
-                      <a:headEnd type="none" w="med" len="med"/>
-                      <a:tailEnd type="none" w="med" len="med"/>
-                    </a:lnR>
-                    <a:lnT w="9525" cap="flat" cmpd="sng" algn="ctr">
-                      <a:solidFill>
-                        <a:srgbClr val="DDD8EC"/>
-                      </a:solidFill>
-                      <a:prstDash val="solid"/>
-                      <a:round/>
-                      <a:headEnd type="none" w="med" len="med"/>
-                      <a:tailEnd type="none" w="med" len="med"/>
-                    </a:lnT>
-                    <a:lnB w="9525" cap="flat" cmpd="sng" algn="ctr">
-                      <a:solidFill>
-                        <a:srgbClr val="DDD8EC"/>
-                      </a:solidFill>
-                      <a:prstDash val="solid"/>
-                      <a:round/>
-                      <a:headEnd type="none" w="med" len="med"/>
-                      <a:tailEnd type="none" w="med" len="med"/>
-                    </a:lnB>
-                    <a:solidFill>
-                      <a:srgbClr val="FFFFFF"/>
-                    </a:solidFill>
-                  </a:tcPr>
-                </a:tc>
-                <a:tc>
-                  <a:txBody>
-                    <a:bodyPr/>
-                    <a:lstStyle/>
-                    <a:p>
-                      <a:pPr algn="ctr" indent="0" marL="0">
-                        <a:buNone/>
-                      </a:pPr>
-                      <a:r>
-                        <a:rPr lang="en-US" sz="1300" i="1" dirty="0">
-                          <a:solidFill>
-                            <a:srgbClr val="6E6A85"/>
-                          </a:solidFill>
-                          <a:latin typeface="Calibri" pitchFamily="34" charset="0"/>
-                          <a:ea typeface="Calibri" pitchFamily="34" charset="-122"/>
-                          <a:cs typeface="Calibri" pitchFamily="34" charset="-120"/>
-                        </a:rPr>
-                        <a:t>pending</a:t>
-                      </a:r>
-                      <a:endParaRPr lang="en-US" sz="1300" dirty="0">
-                        <a:latin typeface="Calibri" charset="0"/>
-                        <a:ea typeface="Calibri" charset="0"/>
-                        <a:cs typeface="Calibri" charset="0"/>
-                      </a:endParaRPr>
-                    </a:p>
-                  </a:txBody>
-                  <a:tcPr marL="91440" marR="91440" marT="45720" marB="45720" anchor="ctr">
-                    <a:lnL w="9525" cap="flat" cmpd="sng" algn="ctr">
-                      <a:solidFill>
-                        <a:srgbClr val="DDD8EC"/>
-                      </a:solidFill>
-                      <a:prstDash val="solid"/>
-                      <a:round/>
-                      <a:headEnd type="none" w="med" len="med"/>
-                      <a:tailEnd type="none" w="med" len="med"/>
-                    </a:lnL>
-                    <a:lnR w="9525" cap="flat" cmpd="sng" algn="ctr">
-                      <a:solidFill>
-                        <a:srgbClr val="DDD8EC"/>
-                      </a:solidFill>
-                      <a:prstDash val="solid"/>
-                      <a:round/>
-                      <a:headEnd type="none" w="med" len="med"/>
-                      <a:tailEnd type="none" w="med" len="med"/>
-                    </a:lnR>
-                    <a:lnT w="9525" cap="flat" cmpd="sng" algn="ctr">
-                      <a:solidFill>
-                        <a:srgbClr val="DDD8EC"/>
-                      </a:solidFill>
-                      <a:prstDash val="solid"/>
-                      <a:round/>
-                      <a:headEnd type="none" w="med" len="med"/>
-                      <a:tailEnd type="none" w="med" len="med"/>
-                    </a:lnT>
-                    <a:lnB w="9525" cap="flat" cmpd="sng" algn="ctr">
-                      <a:solidFill>
-                        <a:srgbClr val="DDD8EC"/>
-                      </a:solidFill>
-                      <a:prstDash val="solid"/>
-                      <a:round/>
-                      <a:headEnd type="none" w="med" len="med"/>
-                      <a:tailEnd type="none" w="med" len="med"/>
-                    </a:lnB>
-                    <a:solidFill>
-                      <a:srgbClr val="FFFFFF"/>
-                    </a:solidFill>
-                  </a:tcPr>
-                </a:tc>
-              </a:tr>
-              <a:tr h="402336">
-                <a:tc>
-                  <a:txBody>
-                    <a:bodyPr/>
-                    <a:lstStyle/>
-                    <a:p>
-                      <a:pPr indent="0" marL="0">
-                        <a:buNone/>
-                      </a:pPr>
-                      <a:r>
-                        <a:rPr lang="en-US" sz="1300" b="1" dirty="0">
-                          <a:solidFill>
-                            <a:srgbClr val="5B3FD9"/>
-                          </a:solidFill>
-                          <a:latin typeface="Calibri" pitchFamily="34" charset="0"/>
-                          <a:ea typeface="Calibri" pitchFamily="34" charset="-122"/>
-                          <a:cs typeface="Calibri" pitchFamily="34" charset="-120"/>
-                        </a:rPr>
-                        <a:t>Ours: Tacotron 2 + HiFi-GAN</a:t>
-                      </a:r>
-                      <a:endParaRPr lang="en-US" sz="1300" dirty="0">
-                        <a:latin typeface="Calibri" charset="0"/>
-                        <a:ea typeface="Calibri" charset="0"/>
-                        <a:cs typeface="Calibri" charset="0"/>
-                      </a:endParaRPr>
-                    </a:p>
-                  </a:txBody>
-                  <a:tcPr marL="91440" marR="91440" marT="45720" marB="45720" anchor="ctr">
-                    <a:lnL w="9525" cap="flat" cmpd="sng" algn="ctr">
-                      <a:solidFill>
-                        <a:srgbClr val="DDD8EC"/>
-                      </a:solidFill>
-                      <a:prstDash val="solid"/>
-                      <a:round/>
-                      <a:headEnd type="none" w="med" len="med"/>
-                      <a:tailEnd type="none" w="med" len="med"/>
-                    </a:lnL>
-                    <a:lnR w="9525" cap="flat" cmpd="sng" algn="ctr">
-                      <a:solidFill>
-                        <a:srgbClr val="DDD8EC"/>
-                      </a:solidFill>
-                      <a:prstDash val="solid"/>
-                      <a:round/>
-                      <a:headEnd type="none" w="med" len="med"/>
-                      <a:tailEnd type="none" w="med" len="med"/>
-                    </a:lnR>
-                    <a:lnT w="9525" cap="flat" cmpd="sng" algn="ctr">
-                      <a:solidFill>
-                        <a:srgbClr val="DDD8EC"/>
-                      </a:solidFill>
-                      <a:prstDash val="solid"/>
-                      <a:round/>
-                      <a:headEnd type="none" w="med" len="med"/>
-                      <a:tailEnd type="none" w="med" len="med"/>
-                    </a:lnT>
-                    <a:lnB w="9525" cap="flat" cmpd="sng" algn="ctr">
-                      <a:solidFill>
-                        <a:srgbClr val="DDD8EC"/>
-                      </a:solidFill>
-                      <a:prstDash val="solid"/>
-                      <a:round/>
-                      <a:headEnd type="none" w="med" len="med"/>
-                      <a:tailEnd type="none" w="med" len="med"/>
-                    </a:lnB>
-                    <a:solidFill>
-                      <a:srgbClr val="FFFFFF"/>
-                    </a:solidFill>
-                  </a:tcPr>
-                </a:tc>
-                <a:tc>
-                  <a:txBody>
-                    <a:bodyPr/>
-                    <a:lstStyle/>
-                    <a:p>
-                      <a:pPr algn="ctr" indent="0" marL="0">
-                        <a:buNone/>
-                      </a:pPr>
-                      <a:r>
-                        <a:rPr lang="en-US" sz="1300" i="1" dirty="0">
-                          <a:solidFill>
-                            <a:srgbClr val="6E6A85"/>
-                          </a:solidFill>
-                          <a:latin typeface="Calibri" pitchFamily="34" charset="0"/>
-                          <a:ea typeface="Calibri" pitchFamily="34" charset="-122"/>
-                          <a:cs typeface="Calibri" pitchFamily="34" charset="-120"/>
-                        </a:rPr>
-                        <a:t>pending</a:t>
-                      </a:r>
-                      <a:endParaRPr lang="en-US" sz="1300" dirty="0">
-                        <a:latin typeface="Calibri" charset="0"/>
-                        <a:ea typeface="Calibri" charset="0"/>
-                        <a:cs typeface="Calibri" charset="0"/>
-                      </a:endParaRPr>
-                    </a:p>
-                  </a:txBody>
-                  <a:tcPr marL="91440" marR="91440" marT="45720" marB="45720" anchor="ctr">
-                    <a:lnL w="9525" cap="flat" cmpd="sng" algn="ctr">
-                      <a:solidFill>
-                        <a:srgbClr val="DDD8EC"/>
-                      </a:solidFill>
-                      <a:prstDash val="solid"/>
-                      <a:round/>
-                      <a:headEnd type="none" w="med" len="med"/>
-                      <a:tailEnd type="none" w="med" len="med"/>
-                    </a:lnL>
-                    <a:lnR w="9525" cap="flat" cmpd="sng" algn="ctr">
-                      <a:solidFill>
-                        <a:srgbClr val="DDD8EC"/>
-                      </a:solidFill>
-                      <a:prstDash val="solid"/>
-                      <a:round/>
-                      <a:headEnd type="none" w="med" len="med"/>
-                      <a:tailEnd type="none" w="med" len="med"/>
-                    </a:lnR>
-                    <a:lnT w="9525" cap="flat" cmpd="sng" algn="ctr">
-                      <a:solidFill>
-                        <a:srgbClr val="DDD8EC"/>
-                      </a:solidFill>
-                      <a:prstDash val="solid"/>
-                      <a:round/>
-                      <a:headEnd type="none" w="med" len="med"/>
-                      <a:tailEnd type="none" w="med" len="med"/>
-                    </a:lnT>
-                    <a:lnB w="9525" cap="flat" cmpd="sng" algn="ctr">
-                      <a:solidFill>
-                        <a:srgbClr val="DDD8EC"/>
-                      </a:solidFill>
-                      <a:prstDash val="solid"/>
-                      <a:round/>
-                      <a:headEnd type="none" w="med" len="med"/>
-                      <a:tailEnd type="none" w="med" len="med"/>
-                    </a:lnB>
-                    <a:solidFill>
-                      <a:srgbClr val="FFFFFF"/>
-                    </a:solidFill>
-                  </a:tcPr>
-                </a:tc>
-              </a:tr>
-              <a:tr h="402336">
-                <a:tc>
-                  <a:txBody>
-                    <a:bodyPr/>
-                    <a:lstStyle/>
-                    <a:p>
-                      <a:pPr indent="0" marL="0">
-                        <a:buNone/>
-                      </a:pPr>
-                      <a:r>
-                        <a:rPr lang="en-US" sz="1300" b="1" dirty="0">
-                          <a:solidFill>
-                            <a:srgbClr val="5B3FD9"/>
-                          </a:solidFill>
-                          <a:latin typeface="Calibri" pitchFamily="34" charset="0"/>
-                          <a:ea typeface="Calibri" pitchFamily="34" charset="-122"/>
-                          <a:cs typeface="Calibri" pitchFamily="34" charset="-120"/>
-                        </a:rPr>
-                        <a:t>Real recording</a:t>
-                      </a:r>
-                      <a:endParaRPr lang="en-US" sz="1300" dirty="0">
-                        <a:latin typeface="Calibri" charset="0"/>
-                        <a:ea typeface="Calibri" charset="0"/>
-                        <a:cs typeface="Calibri" charset="0"/>
-                      </a:endParaRPr>
-                    </a:p>
-                  </a:txBody>
-                  <a:tcPr marL="91440" marR="91440" marT="45720" marB="45720" anchor="ctr">
-                    <a:lnL w="9525" cap="flat" cmpd="sng" algn="ctr">
-                      <a:solidFill>
-                        <a:srgbClr val="DDD8EC"/>
-                      </a:solidFill>
-                      <a:prstDash val="solid"/>
-                      <a:round/>
-                      <a:headEnd type="none" w="med" len="med"/>
-                      <a:tailEnd type="none" w="med" len="med"/>
-                    </a:lnL>
-                    <a:lnR w="9525" cap="flat" cmpd="sng" algn="ctr">
-                      <a:solidFill>
-                        <a:srgbClr val="DDD8EC"/>
-                      </a:solidFill>
-                      <a:prstDash val="solid"/>
-                      <a:round/>
-                      <a:headEnd type="none" w="med" len="med"/>
-                      <a:tailEnd type="none" w="med" len="med"/>
-                    </a:lnR>
-                    <a:lnT w="9525" cap="flat" cmpd="sng" algn="ctr">
-                      <a:solidFill>
-                        <a:srgbClr val="DDD8EC"/>
-                      </a:solidFill>
-                      <a:prstDash val="solid"/>
-                      <a:round/>
-                      <a:headEnd type="none" w="med" len="med"/>
-                      <a:tailEnd type="none" w="med" len="med"/>
-                    </a:lnT>
-                    <a:lnB w="9525" cap="flat" cmpd="sng" algn="ctr">
-                      <a:solidFill>
-                        <a:srgbClr val="DDD8EC"/>
-                      </a:solidFill>
-                      <a:prstDash val="solid"/>
-                      <a:round/>
-                      <a:headEnd type="none" w="med" len="med"/>
-                      <a:tailEnd type="none" w="med" len="med"/>
-                    </a:lnB>
-                    <a:solidFill>
-                      <a:srgbClr val="FFFFFF"/>
-                    </a:solidFill>
-                  </a:tcPr>
-                </a:tc>
-                <a:tc>
-                  <a:txBody>
-                    <a:bodyPr/>
-                    <a:lstStyle/>
-                    <a:p>
-                      <a:pPr algn="ctr" indent="0" marL="0">
-                        <a:buNone/>
-                      </a:pPr>
-                      <a:r>
-                        <a:rPr lang="en-US" sz="1300" i="1" dirty="0">
-                          <a:solidFill>
-                            <a:srgbClr val="6E6A85"/>
-                          </a:solidFill>
-                          <a:latin typeface="Calibri" pitchFamily="34" charset="0"/>
-                          <a:ea typeface="Calibri" pitchFamily="34" charset="-122"/>
-                          <a:cs typeface="Calibri" pitchFamily="34" charset="-120"/>
-                        </a:rPr>
-                        <a:t>pending</a:t>
-                      </a:r>
-                      <a:endParaRPr lang="en-US" sz="1300" dirty="0">
-                        <a:latin typeface="Calibri" charset="0"/>
-                        <a:ea typeface="Calibri" charset="0"/>
-                        <a:cs typeface="Calibri" charset="0"/>
-                      </a:endParaRPr>
-                    </a:p>
-                  </a:txBody>
-                  <a:tcPr marL="91440" marR="91440" marT="45720" marB="45720" anchor="ctr">
-                    <a:lnL w="9525" cap="flat" cmpd="sng" algn="ctr">
-                      <a:solidFill>
-                        <a:srgbClr val="DDD8EC"/>
-                      </a:solidFill>
-                      <a:prstDash val="solid"/>
-                      <a:round/>
-                      <a:headEnd type="none" w="med" len="med"/>
-                      <a:tailEnd type="none" w="med" len="med"/>
-                    </a:lnL>
-                    <a:lnR w="9525" cap="flat" cmpd="sng" algn="ctr">
-                      <a:solidFill>
-                        <a:srgbClr val="DDD8EC"/>
-                      </a:solidFill>
-                      <a:prstDash val="solid"/>
-                      <a:round/>
-                      <a:headEnd type="none" w="med" len="med"/>
-                      <a:tailEnd type="none" w="med" len="med"/>
-                    </a:lnR>
-                    <a:lnT w="9525" cap="flat" cmpd="sng" algn="ctr">
-                      <a:solidFill>
-                        <a:srgbClr val="DDD8EC"/>
-                      </a:solidFill>
-                      <a:prstDash val="solid"/>
-                      <a:round/>
-                      <a:headEnd type="none" w="med" len="med"/>
-                      <a:tailEnd type="none" w="med" len="med"/>
-                    </a:lnT>
-                    <a:lnB w="9525" cap="flat" cmpd="sng" algn="ctr">
-                      <a:solidFill>
-                        <a:srgbClr val="DDD8EC"/>
-                      </a:solidFill>
-                      <a:prstDash val="solid"/>
-                      <a:round/>
-                      <a:headEnd type="none" w="med" len="med"/>
-                      <a:tailEnd type="none" w="med" len="med"/>
-                    </a:lnB>
-                    <a:solidFill>
-                      <a:srgbClr val="FFFFFF"/>
-                    </a:solidFill>
-                  </a:tcPr>
-                </a:tc>
-              </a:tr>
-            </a:tbl>
-          </a:graphicData>
-        </a:graphic>
-      </p:graphicFrame>
-      <p:sp>
-        <p:nvSpPr>
-          <p:cNvPr id="4" name="MOS method heading"/>
+      <p:pic>
+        <p:nvPicPr>
+          <p:cNvPr id="3" name="Baseline vs main mel plot" descr="Mel spectrograms of the same sentence: the baseline is a smooth blur with no syllables, while Tacotron 2 plus HiFi-GAN shows separate syllables, pauses and pitch harmonics.">    </p:cNvPr>
+          <p:cNvPicPr>
+            <a:picLocks noChangeAspect="1"/>
+          </p:cNvPicPr>
+          <p:nvPr/>
+        </p:nvPicPr>
+        <p:blipFill>
+          <a:blip r:embed="rId1"/>
+          <a:stretch>
+            <a:fillRect/>
+          </a:stretch>
+        </p:blipFill>
+        <p:spPr>
+          <a:xfrm>
+            <a:off x="457200" y="1097280"/>
+            <a:ext cx="5486400" cy="3072384"/>
+          </a:xfrm>
+          <a:prstGeom prst="rect">
+            <a:avLst/>
+          </a:prstGeom>
+        </p:spPr>
+      </p:pic>
+      <p:sp>
+        <p:nvSpPr>
+          <p:cNvPr id="4" name="Main reads"/>
           <p:cNvSpPr txBox="1"/>
           <p:nvPr/>
         </p:nvSpPr>
         <p:spPr>
           <a:xfrm>
-            <a:off x="5486400" y="1051560"/>
-            <a:ext cx="3200400" cy="365760"/>
-          </a:xfrm>
-          <a:prstGeom prst="rect">
-            <a:avLst/>
-          </a:prstGeom>
-          <a:noFill/>
-          <a:ln/>
-        </p:spPr>
-        <p:txBody>
-          <a:bodyPr wrap="square" lIns="0" tIns="0" rIns="0" bIns="0" rtlCol="0" anchor="ctr"/>
+            <a:off x="6035040" y="1051560"/>
+            <a:ext cx="2651760" cy="1188720"/>
+          </a:xfrm>
+          <a:prstGeom prst="rect">
+            <a:avLst/>
+          </a:prstGeom>
+          <a:noFill/>
+          <a:ln/>
+        </p:spPr>
+        <p:txBody>
+          <a:bodyPr wrap="square" lIns="0" tIns="0" rIns="0" bIns="0" rtlCol="0" anchor="t"/>
           <a:lstStyle/>
           <a:p>
             <a:pPr indent="0" marL="0">
               <a:buNone/>
             </a:pPr>
             <a:r>
-              <a:rPr lang="en-US" sz="1800" b="1" dirty="0">
+              <a:rPr lang="en-US" sz="1300" b="1" dirty="0">
                 <a:solidFill>
                   <a:schemeClr val="accent1"/>
                 </a:solidFill>
               </a:rPr>
-              <a:t>How we run it</a:t>
-            </a:r>
-            <a:endParaRPr lang="en-US" sz="1800" dirty="0"/>
-          </a:p>
-        </p:txBody>
-      </p:sp>
-      <p:sp>
-        <p:nvSpPr>
-          <p:cNvPr id="5" name="MOS method"/>
+              <a:t>Tacotron 2</a:t>
+            </a:r>
+            <a:endParaRPr lang="en-US" sz="1300" dirty="0"/>
+          </a:p>
+          <a:p>
+            <a:pPr indent="0" marL="0">
+              <a:buNone/>
+            </a:pPr>
+            <a:r>
+              <a:rPr lang="en-US" sz="1300" dirty="0">
+                <a:solidFill>
+                  <a:schemeClr val="tx1"/>
+                </a:solidFill>
+              </a:rPr>
+              <a:t>Separate syllables, pauses between words, pitch stripes, and the hiss of each "s" and "sh".</a:t>
+            </a:r>
+            <a:endParaRPr lang="en-US" sz="1300" dirty="0"/>
+          </a:p>
+        </p:txBody>
+      </p:sp>
+      <p:sp>
+        <p:nvSpPr>
+          <p:cNvPr id="5" name="Baseline reads"/>
           <p:cNvSpPr txBox="1"/>
           <p:nvPr/>
         </p:nvSpPr>
         <p:spPr>
           <a:xfrm>
-            <a:off x="5486400" y="1463040"/>
-            <a:ext cx="3200400" cy="1645920"/>
+            <a:off x="6035040" y="2286000"/>
+            <a:ext cx="2651760" cy="1188720"/>
           </a:xfrm>
           <a:prstGeom prst="rect">
             <a:avLst/>
@@ -6536,110 +5440,66 @@
           <a:bodyPr wrap="square" lIns="0" tIns="0" rIns="0" bIns="0" rtlCol="0" anchor="t"/>
           <a:lstStyle/>
           <a:p>
-            <a:pPr marL="342900" indent="-342900">
-              <a:spcAft>
-                <a:spcPts val="400"/>
-              </a:spcAft>
-              <a:buSzPct val="100000"/>
-              <a:buChar char="•"/>
-            </a:pPr>
-            <a:r>
-              <a:rPr lang="en-US" sz="1400" dirty="0">
+            <a:pPr indent="0" marL="0">
+              <a:buNone/>
+            </a:pPr>
+            <a:r>
+              <a:rPr lang="en-US" sz="1300" b="1" dirty="0">
+                <a:solidFill>
+                  <a:schemeClr val="accent2"/>
+                </a:solidFill>
+              </a:rPr>
+              <a:t>Our baseline</a:t>
+            </a:r>
+            <a:endParaRPr lang="en-US" sz="1300" dirty="0"/>
+          </a:p>
+          <a:p>
+            <a:pPr indent="0" marL="0">
+              <a:buNone/>
+            </a:pPr>
+            <a:r>
+              <a:rPr lang="en-US" sz="1300" dirty="0">
                 <a:solidFill>
                   <a:schemeClr val="tx1"/>
                 </a:solidFill>
               </a:rPr>
-              <a:t>6 held-out sentences × 3 systems = 18 clips</a:t>
-            </a:r>
-            <a:endParaRPr lang="en-US" sz="1400" dirty="0"/>
-          </a:p>
-          <a:p>
-            <a:pPr marL="342900" indent="-342900">
-              <a:spcAft>
-                <a:spcPts val="400"/>
-              </a:spcAft>
-              <a:buSzPct val="100000"/>
-              <a:buChar char="•"/>
-            </a:pPr>
-            <a:r>
-              <a:rPr lang="en-US" sz="1400" dirty="0">
+              <a:t>One smooth blur. It cannot learn when each sound happens, so it predicts the average spectrum.</a:t>
+            </a:r>
+            <a:endParaRPr lang="en-US" sz="1300" dirty="0"/>
+          </a:p>
+        </p:txBody>
+      </p:sp>
+      <p:sp>
+        <p:nvSpPr>
+          <p:cNvPr id="6" name="Compare takeaway"/>
+          <p:cNvSpPr txBox="1"/>
+          <p:nvPr/>
+        </p:nvSpPr>
+        <p:spPr>
+          <a:xfrm>
+            <a:off x="6035040" y="3520440"/>
+            <a:ext cx="2651760" cy="1051560"/>
+          </a:xfrm>
+          <a:prstGeom prst="rect">
+            <a:avLst/>
+          </a:prstGeom>
+          <a:noFill/>
+          <a:ln/>
+        </p:spPr>
+        <p:txBody>
+          <a:bodyPr wrap="square" lIns="0" tIns="0" rIns="0" bIns="0" rtlCol="0" anchor="t"/>
+          <a:lstStyle/>
+          <a:p>
+            <a:pPr indent="0" marL="0">
+              <a:buNone/>
+            </a:pPr>
+            <a:r>
+              <a:rPr lang="en-US" sz="1300" b="1" dirty="0">
                 <a:solidFill>
                   <a:schemeClr val="tx1"/>
                 </a:solidFill>
               </a:rPr>
-              <a:t>Shuffled, unlabelled, loudness-matched</a:t>
-            </a:r>
-            <a:endParaRPr lang="en-US" sz="1400" dirty="0"/>
-          </a:p>
-          <a:p>
-            <a:pPr marL="342900" indent="-342900">
-              <a:spcAft>
-                <a:spcPts val="400"/>
-              </a:spcAft>
-              <a:buSzPct val="100000"/>
-              <a:buChar char="•"/>
-            </a:pPr>
-            <a:r>
-              <a:rPr lang="en-US" sz="1400" dirty="0">
-                <a:solidFill>
-                  <a:schemeClr val="tx1"/>
-                </a:solidFill>
-              </a:rPr>
-              <a:t>Google Form, 10+ listeners, 1–5 scale</a:t>
-            </a:r>
-            <a:endParaRPr lang="en-US" sz="1400" dirty="0"/>
-          </a:p>
-          <a:p>
-            <a:pPr marL="342900" indent="-342900">
-              <a:spcAft>
-                <a:spcPts val="400"/>
-              </a:spcAft>
-              <a:buSzPct val="100000"/>
-              <a:buChar char="•"/>
-            </a:pPr>
-            <a:r>
-              <a:rPr lang="en-US" sz="1400" dirty="0">
-                <a:solidFill>
-                  <a:schemeClr val="tx1"/>
-                </a:solidFill>
-              </a:rPr>
-              <a:t>Same protocol as the 2018 paper</a:t>
-            </a:r>
-            <a:endParaRPr lang="en-US" sz="1400" dirty="0"/>
-          </a:p>
-        </p:txBody>
-      </p:sp>
-      <p:sp>
-        <p:nvSpPr>
-          <p:cNvPr id="6" name="MOS status"/>
-          <p:cNvSpPr txBox="1"/>
-          <p:nvPr/>
-        </p:nvSpPr>
-        <p:spPr>
-          <a:xfrm>
-            <a:off x="5486400" y="3291840"/>
-            <a:ext cx="3200400" cy="1097280"/>
-          </a:xfrm>
-          <a:prstGeom prst="rect">
-            <a:avLst/>
-          </a:prstGeom>
-          <a:noFill/>
-          <a:ln/>
-        </p:spPr>
-        <p:txBody>
-          <a:bodyPr wrap="square" lIns="0" tIns="0" rIns="0" bIns="0" rtlCol="0" anchor="t"/>
-          <a:lstStyle/>
-          <a:p>
-            <a:pPr indent="0" marL="0">
-              <a:buNone/>
-            </a:pPr>
-            <a:r>
-              <a:rPr lang="en-US" sz="1300" i="1" dirty="0">
-                <a:solidFill>
-                  <a:schemeClr val="accent6"/>
-                </a:solidFill>
-              </a:rPr>
-              <a:t>Clips and answer key are generated (eval/mos/). Scores will be filled in from the form responses.</a:t>
+              <a:t>Without learned timing (attention), the model collapses to the mean: the 2018 paper's failure, reproduced.</a:t>
             </a:r>
             <a:endParaRPr lang="en-US" sz="1300" dirty="0"/>
           </a:p>
@@ -6675,7 +5535,7 @@
                   <a:schemeClr val="accent6"/>
                 </a:solidFill>
               </a:rPr>
-              <a:t>Deekshitha</a:t>
+              <a:t>Mann + Deekshitha</a:t>
             </a:r>
             <a:endParaRPr lang="en-US" sz="1000" dirty="0"/>
           </a:p>
@@ -7473,7 +6333,7 @@
                   <a:schemeClr val="tx1"/>
                 </a:solidFill>
               </a:rPr>
-              <a:t>Small listening test</a:t>
+              <a:t>No formal listening test (MOS)</a:t>
             </a:r>
             <a:endParaRPr lang="en-US" sz="1300" dirty="0"/>
           </a:p>
@@ -8043,7 +6903,7 @@
                   <a:schemeClr val="tx1"/>
                 </a:solidFill>
               </a:rPr>
-              <a:t>MOS listening-test material</a:t>
+              <a:t>Results table</a:t>
             </a:r>
             <a:endParaRPr lang="en-US" sz="1400" dirty="0"/>
           </a:p>
@@ -11062,7 +9922,7 @@
                   <a:schemeClr val="tx1"/>
                 </a:solidFill>
               </a:rPr>
-              <a:t>Alignment analysis, mel-distance metric, MOS test</a:t>
+              <a:t>Alignment analysis and mel-distance evaluation</a:t>
             </a:r>
             <a:endParaRPr lang="en-US" sz="1500" dirty="0"/>
           </a:p>

</xml_diff>

<commit_message>
Add exact dataset split (324 / 40 / 40)
</commit_message>
<xml_diff>
--- a/report/Colatron_Slides.pptx
+++ b/report/Colatron_Slides.pptx
@@ -121,14 +121,14 @@
   <p:extLst>
     <p:ext uri="{521415D9-36F7-43E2-AB2F-B90AF26B5E84}">
       <p14:sectionLst xmlns:p14="http://schemas.microsoft.com/office/powerpoint/2010/main">
-        <p14:section name="Introduction" id="{b0b2da48-93d8-0980-0f25-0c860169c42e}">
+        <p14:section name="Introduction" id="{ae55057d-a18c-7343-0566-d34dc6575825}">
           <p14:sldIdLst>
             <p14:sldId id="256"/>
             <p14:sldId id="257"/>
             <p14:sldId id="258"/>
           </p14:sldIdLst>
         </p14:section>
-        <p14:section name="Approach" id="{1bb013b2-cf11-206d-2925-11622d518159}">
+        <p14:section name="Approach" id="{be3bcc86-bdfb-0bd0-5f7b-f7bcbe1e81e4}">
           <p14:sldIdLst>
             <p14:sldId id="259"/>
             <p14:sldId id="260"/>
@@ -137,7 +137,7 @@
             <p14:sldId id="263"/>
           </p14:sldIdLst>
         </p14:section>
-        <p14:section name="Results" id="{db37dcb0-d0b5-cb34-8db7-f3c7cc808f4e}">
+        <p14:section name="Results" id="{a672baf8-3528-2090-72d1-1e88e185a60a}">
           <p14:sldIdLst>
             <p14:sldId id="264"/>
             <p14:sldId id="265"/>
@@ -145,7 +145,7 @@
             <p14:sldId id="267"/>
           </p14:sldIdLst>
         </p14:section>
-        <p14:section name="Wrap-up" id="{4bb81844-af89-40c0-e1ff-5215a861f0ef}">
+        <p14:section name="Wrap-up" id="{17868d99-aba7-0ad2-ef4f-088884d0f572}">
           <p14:sldIdLst>
             <p14:sldId id="268"/>
             <p14:sldId id="269"/>
@@ -5779,7 +5779,7 @@
                   <a:schemeClr val="accent6"/>
                 </a:solidFill>
               </a:rPr>
-              <a:t>Our from-scratch baseline (~400 clips) has a 37% higher mel distance to real speech than Tacotron 2.</a:t>
+              <a:t>Our from-scratch baseline (324 training clips) has a 37% higher mel distance to real speech than Tacotron 2.</a:t>
             </a:r>
             <a:endParaRPr lang="en-US" sz="1200" dirty="0"/>
           </a:p>
@@ -10250,7 +10250,7 @@
         <p:spPr>
           <a:xfrm>
             <a:off x="457200" y="1097280"/>
-            <a:ext cx="1920240" cy="502920"/>
+            <a:ext cx="2468880" cy="502920"/>
           </a:xfrm>
           <a:prstGeom prst="rect">
             <a:avLst/>
@@ -10325,7 +10325,7 @@
         <p:spPr>
           <a:xfrm>
             <a:off x="457200" y="1965960"/>
-            <a:ext cx="1920240" cy="502920"/>
+            <a:ext cx="2468880" cy="502920"/>
           </a:xfrm>
           <a:prstGeom prst="rect">
             <a:avLst/>
@@ -10400,7 +10400,7 @@
         <p:spPr>
           <a:xfrm>
             <a:off x="457200" y="2834640"/>
-            <a:ext cx="1920240" cy="502920"/>
+            <a:ext cx="2468880" cy="502920"/>
           </a:xfrm>
           <a:prstGeom prst="rect">
             <a:avLst/>
@@ -10424,7 +10424,7 @@
                 <a:ea typeface="Arial" pitchFamily="34" charset="-122"/>
                 <a:cs typeface="Arial" pitchFamily="34" charset="-120"/>
               </a:rPr>
-              <a:t>~400</a:t>
+              <a:t>404</a:t>
             </a:r>
             <a:endParaRPr lang="en-US" sz="2800" dirty="0"/>
           </a:p>
@@ -10475,7 +10475,7 @@
         <p:spPr>
           <a:xfrm>
             <a:off x="457200" y="3703320"/>
-            <a:ext cx="1920240" cy="502920"/>
+            <a:ext cx="2468880" cy="502920"/>
           </a:xfrm>
           <a:prstGeom prst="rect">
             <a:avLst/>
@@ -10499,7 +10499,7 @@
                 <a:ea typeface="Arial" pitchFamily="34" charset="-122"/>
                 <a:cs typeface="Arial" pitchFamily="34" charset="-120"/>
               </a:rPr>
-              <a:t>80 / 10 / 10</a:t>
+              <a:t>324 / 40 / 40</a:t>
             </a:r>
             <a:endParaRPr lang="en-US" sz="2800" dirty="0"/>
           </a:p>
@@ -10535,7 +10535,7 @@
                   <a:schemeClr val="accent6"/>
                 </a:solidFill>
               </a:rPr>
-              <a:t>train / val / test split</a:t>
+              <a:t>train / val / test clips</a:t>
             </a:r>
             <a:endParaRPr lang="en-US" sz="1200" dirty="0"/>
           </a:p>

</xml_diff>

<commit_message>
Slide 11: label baseline vocoder and state both caveats
</commit_message>
<xml_diff>
--- a/report/Colatron_Slides.pptx
+++ b/report/Colatron_Slides.pptx
@@ -121,14 +121,14 @@
   <p:extLst>
     <p:ext uri="{521415D9-36F7-43E2-AB2F-B90AF26B5E84}">
       <p14:sectionLst xmlns:p14="http://schemas.microsoft.com/office/powerpoint/2010/main">
-        <p14:section name="Introduction" id="{ae55057d-a18c-7343-0566-d34dc6575825}">
+        <p14:section name="Introduction" id="{d6fe5596-7da3-1bfd-acd3-ff69235365cc}">
           <p14:sldIdLst>
             <p14:sldId id="256"/>
             <p14:sldId id="257"/>
             <p14:sldId id="258"/>
           </p14:sldIdLst>
         </p14:section>
-        <p14:section name="Approach" id="{be3bcc86-bdfb-0bd0-5f7b-f7bcbe1e81e4}">
+        <p14:section name="Approach" id="{169ea4c2-a7f9-55d5-fbcd-89335c189863}">
           <p14:sldIdLst>
             <p14:sldId id="259"/>
             <p14:sldId id="260"/>
@@ -137,7 +137,7 @@
             <p14:sldId id="263"/>
           </p14:sldIdLst>
         </p14:section>
-        <p14:section name="Results" id="{a672baf8-3528-2090-72d1-1e88e185a60a}">
+        <p14:section name="Results" id="{30070fe1-ca85-5b82-8a44-3959978f056e}">
           <p14:sldIdLst>
             <p14:sldId id="264"/>
             <p14:sldId id="265"/>
@@ -145,7 +145,7 @@
             <p14:sldId id="267"/>
           </p14:sldIdLst>
         </p14:section>
-        <p14:section name="Wrap-up" id="{17868d99-aba7-0ad2-ef4f-088884d0f572}">
+        <p14:section name="Wrap-up" id="{cf2bde4d-2bf3-8a05-85e2-c39063f4eb73}">
           <p14:sldIdLst>
             <p14:sldId id="268"/>
             <p14:sldId id="269"/>
@@ -533,7 +533,7 @@
               <c:strCache>
                 <c:ptCount val="1"/>
                 <c:pt idx="0">
-                  <c:v>Baseline (ours, from scratch)</c:v>
+                  <c:v>Baseline (ours) + Griffin-Lim</c:v>
                 </c:pt>
               </c:strCache>
             </c:strRef>
@@ -5159,8 +5159,8 @@
         </p:nvSpPr>
         <p:spPr>
           <a:xfrm>
-            <a:off x="5669280" y="3566160"/>
-            <a:ext cx="3017520" cy="1005840"/>
+            <a:off x="5669280" y="3520440"/>
+            <a:ext cx="3017520" cy="1188720"/>
           </a:xfrm>
           <a:prstGeom prst="rect">
             <a:avLst/>
@@ -5181,7 +5181,7 @@
                   <a:schemeClr val="accent6"/>
                 </a:solidFill>
               </a:rPr>
-              <a:t>Caveat: </a:t>
+              <a:t>Caveats: </a:t>
             </a:r>
             <a:pPr indent="0" marL="0">
               <a:buNone/>
@@ -5192,7 +5192,7 @@
                   <a:schemeClr val="accent6"/>
                 </a:solidFill>
               </a:rPr>
-              <a:t>Tacotron 2 was pretrained on all of LJ Speech, so it may have seen these clips. The gap favours it.</a:t>
+              <a:t>our baseline used Griffin-Lim while the main system used HiFi-GAN, and Tacotron 2 may have seen these clips in pretraining. Both favour the main system.</a:t>
             </a:r>
             <a:endParaRPr lang="en-US" sz="1200" dirty="0"/>
           </a:p>

</xml_diff>

<commit_message>
Demo: add baseline option with mel comparison
</commit_message>
<xml_diff>
--- a/report/Colatron_Slides.pptx
+++ b/report/Colatron_Slides.pptx
@@ -19,10 +19,9 @@
     <p:sldId id="267" r:id="rId13"/>
     <p:sldId id="268" r:id="rId14"/>
     <p:sldId id="269" r:id="rId15"/>
-    <p:sldId id="270" r:id="rId16"/>
   </p:sldIdLst>
   <p:notesMasterIdLst>
-    <p:notesMasterId r:id="rId17"/>
+    <p:notesMasterId r:id="rId16"/>
   </p:notesMasterIdLst>
   <p:sldSz cx="9144000" cy="5143500"/>
   <p:notesSz cx="5143500" cy="9144000"/>
@@ -121,14 +120,14 @@
   <p:extLst>
     <p:ext uri="{521415D9-36F7-43E2-AB2F-B90AF26B5E84}">
       <p14:sectionLst xmlns:p14="http://schemas.microsoft.com/office/powerpoint/2010/main">
-        <p14:section name="Introduction" id="{d6fe5596-7da3-1bfd-acd3-ff69235365cc}">
+        <p14:section name="Introduction" id="{d0001848-0b67-cd8c-871a-bd8efc2c8030}">
           <p14:sldIdLst>
             <p14:sldId id="256"/>
             <p14:sldId id="257"/>
             <p14:sldId id="258"/>
           </p14:sldIdLst>
         </p14:section>
-        <p14:section name="Approach" id="{169ea4c2-a7f9-55d5-fbcd-89335c189863}">
+        <p14:section name="Approach" id="{b2ba2209-1f26-b03a-810f-f1cdbb9510f8}">
           <p14:sldIdLst>
             <p14:sldId id="259"/>
             <p14:sldId id="260"/>
@@ -137,7 +136,7 @@
             <p14:sldId id="263"/>
           </p14:sldIdLst>
         </p14:section>
-        <p14:section name="Results" id="{30070fe1-ca85-5b82-8a44-3959978f056e}">
+        <p14:section name="Results" id="{e66cb7cc-d929-765f-467c-e077b3994495}">
           <p14:sldIdLst>
             <p14:sldId id="264"/>
             <p14:sldId id="265"/>
@@ -145,11 +144,10 @@
             <p14:sldId id="267"/>
           </p14:sldIdLst>
         </p14:section>
-        <p14:section name="Wrap-up" id="{cf2bde4d-2bf3-8a05-85e2-c39063f4eb73}">
+        <p14:section name="Wrap-up" id="{b2781ca8-65cf-f106-b847-61026dfb9714}">
           <p14:sldIdLst>
             <p14:sldId id="268"/>
             <p14:sldId id="269"/>
-            <p14:sldId id="270"/>
           </p14:sldIdLst>
         </p14:section>
       </p14:sectionLst>
@@ -1681,7 +1679,7 @@
           <a:p>
             <a:r>
               <a:rPr lang="en-US" dirty="0"/>
-              <a:t>Each of us explains our own files in the Q&amp;A. The GitHub commit history matches this split.</a:t>
+              <a:t>Start the app before the review so models are already loaded. Try one sentence from the panel. If anything fails, play the files in samples/.</a:t>
             </a:r>
             <a:endParaRPr lang="en-US" dirty="0"/>
           </a:p>
@@ -1705,94 +1703,6 @@
             <a:fld id="{F7021451-1387-4CA6-816F-3879F97B5CBC}" type="slidenum">
               <a:rPr lang="en-US"/>
               <a:t>14</a:t>
-            </a:fld>
-            <a:endParaRPr lang="en-US"/>
-          </a:p>
-        </p:txBody>
-      </p:sp>
-    </p:spTree>
-    <p:extLst>
-      <p:ext uri="{BB962C8B-B14F-4D97-AF65-F5344CB8AC3E}">
-        <p14:creationId xmlns:p14="http://schemas.microsoft.com/office/powerpoint/2010/main" val="1024086991"/>
-      </p:ext>
-    </p:extLst>
-  </p:cSld>
-  <p:clrMapOvr>
-    <a:masterClrMapping/>
-  </p:clrMapOvr>
-</p:notes>
-</file>
-
-<file path=ppt/notesSlides/notesSlide15.xml><?xml version="1.0" encoding="utf-8"?>
-<p:notes xmlns:a="http://schemas.openxmlformats.org/drawingml/2006/main" xmlns:r="http://schemas.openxmlformats.org/officeDocument/2006/relationships" xmlns:p="http://schemas.openxmlformats.org/presentationml/2006/main">
-  <p:cSld>
-    <p:spTree>
-      <p:nvGrpSpPr>
-        <p:cNvPr id="1" name=""/>
-        <p:cNvGrpSpPr/>
-        <p:nvPr/>
-      </p:nvGrpSpPr>
-      <p:grpSpPr>
-        <a:xfrm>
-          <a:off x="0" y="0"/>
-          <a:ext cx="0" cy="0"/>
-          <a:chOff x="0" y="0"/>
-          <a:chExt cx="0" cy="0"/>
-        </a:xfrm>
-      </p:grpSpPr>
-      <p:sp>
-        <p:nvSpPr>
-          <p:cNvPr id="2" name="Slide Image Placeholder 1"/>
-          <p:cNvSpPr>
-            <a:spLocks noGrp="1" noRot="1" noChangeAspect="1"/>
-          </p:cNvSpPr>
-          <p:nvPr>
-            <p:ph type="sldImg"/>
-          </p:nvPr>
-        </p:nvSpPr>
-        <p:spPr/>
-      </p:sp>
-      <p:sp>
-        <p:nvSpPr>
-          <p:cNvPr id="3" name="Notes Placeholder 2"/>
-          <p:cNvSpPr>
-            <a:spLocks noGrp="1"/>
-          </p:cNvSpPr>
-          <p:nvPr>
-            <p:ph type="body" idx="1"/>
-          </p:nvPr>
-        </p:nvSpPr>
-        <p:spPr/>
-        <p:txBody>
-          <a:bodyPr/>
-          <a:lstStyle/>
-          <a:p>
-            <a:r>
-              <a:rPr lang="en-US" dirty="0"/>
-              <a:t>Start the app before the review so models are already loaded. Try one sentence from the panel. If anything fails, play the files in samples/.</a:t>
-            </a:r>
-            <a:endParaRPr lang="en-US" dirty="0"/>
-          </a:p>
-        </p:txBody>
-      </p:sp>
-      <p:sp>
-        <p:nvSpPr>
-          <p:cNvPr id="4" name="Slide Number Placeholder 3"/>
-          <p:cNvSpPr>
-            <a:spLocks noGrp="1"/>
-          </p:cNvSpPr>
-          <p:nvPr>
-            <p:ph type="sldNum" sz="quarter" idx="10"/>
-          </p:nvPr>
-        </p:nvSpPr>
-        <p:spPr/>
-        <p:txBody>
-          <a:bodyPr/>
-          <a:lstStyle/>
-          <a:p>
-            <a:fld id="{F7021451-1387-4CA6-816F-3879F97B5CBC}" type="slidenum">
-              <a:rPr lang="en-US"/>
-              <a:t>15</a:t>
             </a:fld>
             <a:endParaRPr lang="en-US"/>
           </a:p>
@@ -4839,42 +4749,6 @@
       </p:sp>
       <p:sp>
         <p:nvSpPr>
-          <p:cNvPr id="9" name="Owner tag"/>
-          <p:cNvSpPr txBox="1"/>
-          <p:nvPr/>
-        </p:nvSpPr>
-        <p:spPr>
-          <a:xfrm>
-            <a:off x="5943600" y="4754880"/>
-            <a:ext cx="2194560" cy="274320"/>
-          </a:xfrm>
-          <a:prstGeom prst="rect">
-            <a:avLst/>
-          </a:prstGeom>
-          <a:noFill/>
-          <a:ln/>
-        </p:spPr>
-        <p:txBody>
-          <a:bodyPr wrap="square" lIns="0" tIns="0" rIns="0" bIns="0" rtlCol="0" anchor="ctr"/>
-          <a:lstStyle/>
-          <a:p>
-            <a:pPr algn="r" indent="0" marL="0">
-              <a:buNone/>
-            </a:pPr>
-            <a:r>
-              <a:rPr lang="en-US" sz="1000" i="1" dirty="0">
-                <a:solidFill>
-                  <a:schemeClr val="accent6"/>
-                </a:solidFill>
-              </a:rPr>
-              <a:t>Mann</a:t>
-            </a:r>
-            <a:endParaRPr lang="en-US" sz="1000" dirty="0"/>
-          </a:p>
-        </p:txBody>
-      </p:sp>
-      <p:sp>
-        <p:nvSpPr>
           <p:cNvPr id="25" name="Slide Number Placeholder 0"/>
           <p:cNvSpPr>
             <a:spLocks noGrp="1"/>
@@ -5200,42 +5074,6 @@
       </p:sp>
       <p:sp>
         <p:nvSpPr>
-          <p:cNvPr id="8" name="Owner tag"/>
-          <p:cNvSpPr txBox="1"/>
-          <p:nvPr/>
-        </p:nvSpPr>
-        <p:spPr>
-          <a:xfrm>
-            <a:off x="5943600" y="4754880"/>
-            <a:ext cx="2194560" cy="274320"/>
-          </a:xfrm>
-          <a:prstGeom prst="rect">
-            <a:avLst/>
-          </a:prstGeom>
-          <a:noFill/>
-          <a:ln/>
-        </p:spPr>
-        <p:txBody>
-          <a:bodyPr wrap="square" lIns="0" tIns="0" rIns="0" bIns="0" rtlCol="0" anchor="ctr"/>
-          <a:lstStyle/>
-          <a:p>
-            <a:pPr algn="r" indent="0" marL="0">
-              <a:buNone/>
-            </a:pPr>
-            <a:r>
-              <a:rPr lang="en-US" sz="1000" i="1" dirty="0">
-                <a:solidFill>
-                  <a:schemeClr val="accent6"/>
-                </a:solidFill>
-              </a:rPr>
-              <a:t>Deekshitha</a:t>
-            </a:r>
-            <a:endParaRPr lang="en-US" sz="1000" dirty="0"/>
-          </a:p>
-        </p:txBody>
-      </p:sp>
-      <p:sp>
-        <p:nvSpPr>
           <p:cNvPr id="25" name="Slide Number Placeholder 0"/>
           <p:cNvSpPr>
             <a:spLocks noGrp="1"/>
@@ -5507,42 +5345,6 @@
       </p:sp>
       <p:sp>
         <p:nvSpPr>
-          <p:cNvPr id="7" name="Owner tag"/>
-          <p:cNvSpPr txBox="1"/>
-          <p:nvPr/>
-        </p:nvSpPr>
-        <p:spPr>
-          <a:xfrm>
-            <a:off x="5943600" y="4754880"/>
-            <a:ext cx="2194560" cy="274320"/>
-          </a:xfrm>
-          <a:prstGeom prst="rect">
-            <a:avLst/>
-          </a:prstGeom>
-          <a:noFill/>
-          <a:ln/>
-        </p:spPr>
-        <p:txBody>
-          <a:bodyPr wrap="square" lIns="0" tIns="0" rIns="0" bIns="0" rtlCol="0" anchor="ctr"/>
-          <a:lstStyle/>
-          <a:p>
-            <a:pPr algn="r" indent="0" marL="0">
-              <a:buNone/>
-            </a:pPr>
-            <a:r>
-              <a:rPr lang="en-US" sz="1000" i="1" dirty="0">
-                <a:solidFill>
-                  <a:schemeClr val="accent6"/>
-                </a:solidFill>
-              </a:rPr>
-              <a:t>Mann + Deekshitha</a:t>
-            </a:r>
-            <a:endParaRPr lang="en-US" sz="1000" dirty="0"/>
-          </a:p>
-        </p:txBody>
-      </p:sp>
-      <p:sp>
-        <p:nvSpPr>
           <p:cNvPr id="25" name="Slide Number Placeholder 0"/>
           <p:cNvSpPr>
             <a:spLocks noGrp="1"/>
@@ -6453,581 +6255,6 @@
         </p:nvSpPr>
         <p:spPr>
           <a:xfrm>
-            <a:off x="457200" y="274320"/>
-            <a:ext cx="8229600" cy="685800"/>
-          </a:xfrm>
-          <a:prstGeom prst="rect">
-            <a:avLst/>
-          </a:prstGeom>
-          <a:noFill/>
-          <a:ln/>
-        </p:spPr>
-        <p:txBody>
-          <a:bodyPr wrap="square" lIns="0" tIns="0" rIns="0" bIns="0" rtlCol="0" anchor="ctr"/>
-          <a:lstStyle/>
-          <a:p>
-            <a:pPr algn="l" indent="0" marL="0">
-              <a:buNone/>
-            </a:pPr>
-            <a:r>
-              <a:rPr lang="en-US" sz="3000" b="1" dirty="0">
-                <a:solidFill>
-                  <a:schemeClr val="tx2"/>
-                </a:solidFill>
-                <a:latin typeface="Arial" pitchFamily="34" charset="0"/>
-                <a:ea typeface="Arial" pitchFamily="34" charset="-122"/>
-                <a:cs typeface="Arial" pitchFamily="34" charset="-120"/>
-              </a:rPr>
-              <a:t>Who did what</a:t>
-            </a:r>
-            <a:endParaRPr lang="en-US" sz="3000" dirty="0"/>
-          </a:p>
-        </p:txBody>
-      </p:sp>
-      <p:sp>
-        <p:nvSpPr>
-          <p:cNvPr id="3" name="Member card 1"/>
-          <p:cNvSpPr/>
-          <p:nvPr/>
-        </p:nvSpPr>
-        <p:spPr>
-          <a:xfrm>
-            <a:off x="457200" y="1051560"/>
-            <a:ext cx="4023360" cy="3017520"/>
-          </a:xfrm>
-          <a:prstGeom prst="roundRect">
-            <a:avLst>
-              <a:gd name="adj" fmla="val 2424"/>
-            </a:avLst>
-          </a:prstGeom>
-          <a:solidFill>
-            <a:schemeClr val="bg2"/>
-          </a:solidFill>
-          <a:ln w="12700">
-            <a:solidFill>
-              <a:schemeClr val="bg2"/>
-            </a:solidFill>
-            <a:prstDash val="solid"/>
-          </a:ln>
-        </p:spPr>
-      </p:sp>
-      <p:sp>
-        <p:nvSpPr>
-          <p:cNvPr id="4" name="Member 1 name"/>
-          <p:cNvSpPr txBox="1"/>
-          <p:nvPr/>
-        </p:nvSpPr>
-        <p:spPr>
-          <a:xfrm>
-            <a:off x="685800" y="1188720"/>
-            <a:ext cx="3566160" cy="384048"/>
-          </a:xfrm>
-          <a:prstGeom prst="rect">
-            <a:avLst/>
-          </a:prstGeom>
-          <a:noFill/>
-          <a:ln/>
-        </p:spPr>
-        <p:txBody>
-          <a:bodyPr wrap="square" lIns="0" tIns="0" rIns="0" bIns="0" rtlCol="0" anchor="ctr"/>
-          <a:lstStyle/>
-          <a:p>
-            <a:pPr indent="0" marL="0">
-              <a:buNone/>
-            </a:pPr>
-            <a:r>
-              <a:rPr lang="en-US" sz="1800" b="1" dirty="0">
-                <a:solidFill>
-                  <a:schemeClr val="accent1"/>
-                </a:solidFill>
-              </a:rPr>
-              <a:t>Mann Mehta</a:t>
-            </a:r>
-            <a:endParaRPr lang="en-US" sz="1800" dirty="0"/>
-          </a:p>
-        </p:txBody>
-      </p:sp>
-      <p:sp>
-        <p:nvSpPr>
-          <p:cNvPr id="5" name="Member 1 work"/>
-          <p:cNvSpPr txBox="1"/>
-          <p:nvPr/>
-        </p:nvSpPr>
-        <p:spPr>
-          <a:xfrm>
-            <a:off x="685800" y="1645920"/>
-            <a:ext cx="3566160" cy="2194560"/>
-          </a:xfrm>
-          <a:prstGeom prst="rect">
-            <a:avLst/>
-          </a:prstGeom>
-          <a:noFill/>
-          <a:ln/>
-        </p:spPr>
-        <p:txBody>
-          <a:bodyPr wrap="square" lIns="0" tIns="0" rIns="0" bIns="0" rtlCol="0" anchor="t"/>
-          <a:lstStyle/>
-          <a:p>
-            <a:pPr marL="342900" indent="-342900">
-              <a:spcAft>
-                <a:spcPts val="300"/>
-              </a:spcAft>
-              <a:buSzPct val="100000"/>
-              <a:buChar char="•"/>
-            </a:pPr>
-            <a:r>
-              <a:rPr lang="en-US" sz="1400" dirty="0">
-                <a:solidFill>
-                  <a:schemeClr val="tx1"/>
-                </a:solidFill>
-              </a:rPr>
-              <a:t>Repo, environment, shared audio settings</a:t>
-            </a:r>
-            <a:endParaRPr lang="en-US" sz="1400" dirty="0"/>
-          </a:p>
-          <a:p>
-            <a:pPr marL="342900" indent="-342900">
-              <a:spcAft>
-                <a:spcPts val="300"/>
-              </a:spcAft>
-              <a:buSzPct val="100000"/>
-              <a:buChar char="•"/>
-            </a:pPr>
-            <a:r>
-              <a:rPr lang="en-US" sz="1400" dirty="0">
-                <a:solidFill>
-                  <a:schemeClr val="tx1"/>
-                </a:solidFill>
-              </a:rPr>
-              <a:t>Tacotron 2 integration</a:t>
-            </a:r>
-            <a:endParaRPr lang="en-US" sz="1400" dirty="0"/>
-          </a:p>
-          <a:p>
-            <a:pPr marL="342900" indent="-342900">
-              <a:spcAft>
-                <a:spcPts val="300"/>
-              </a:spcAft>
-              <a:buSzPct val="100000"/>
-              <a:buChar char="•"/>
-            </a:pPr>
-            <a:r>
-              <a:rPr lang="en-US" sz="1400" dirty="0">
-                <a:solidFill>
-                  <a:schemeClr val="tx1"/>
-                </a:solidFill>
-              </a:rPr>
-              <a:t>Griffin-Lim and HiFi-GAN vocoders</a:t>
-            </a:r>
-            <a:endParaRPr lang="en-US" sz="1400" dirty="0"/>
-          </a:p>
-          <a:p>
-            <a:pPr marL="342900" indent="-342900">
-              <a:spcAft>
-                <a:spcPts val="300"/>
-              </a:spcAft>
-              <a:buSzPct val="100000"/>
-              <a:buChar char="•"/>
-            </a:pPr>
-            <a:r>
-              <a:rPr lang="en-US" sz="1400" dirty="0">
-                <a:solidFill>
-                  <a:schemeClr val="tx1"/>
-                </a:solidFill>
-              </a:rPr>
-              <a:t>Attention plots and alignment stats</a:t>
-            </a:r>
-            <a:endParaRPr lang="en-US" sz="1400" dirty="0"/>
-          </a:p>
-          <a:p>
-            <a:pPr marL="342900" indent="-342900">
-              <a:spcAft>
-                <a:spcPts val="300"/>
-              </a:spcAft>
-              <a:buSzPct val="100000"/>
-              <a:buChar char="•"/>
-            </a:pPr>
-            <a:r>
-              <a:rPr lang="en-US" sz="1400" dirty="0">
-                <a:solidFill>
-                  <a:schemeClr val="tx1"/>
-                </a:solidFill>
-              </a:rPr>
-              <a:t>Fixed comparison samples</a:t>
-            </a:r>
-            <a:endParaRPr lang="en-US" sz="1400" dirty="0"/>
-          </a:p>
-          <a:p>
-            <a:pPr marL="342900" indent="-342900">
-              <a:spcAft>
-                <a:spcPts val="300"/>
-              </a:spcAft>
-              <a:buSzPct val="100000"/>
-              <a:buChar char="•"/>
-            </a:pPr>
-            <a:r>
-              <a:rPr lang="en-US" sz="1400" dirty="0">
-                <a:solidFill>
-                  <a:schemeClr val="tx1"/>
-                </a:solidFill>
-              </a:rPr>
-              <a:t>Inference CLI, Gradio demo, README</a:t>
-            </a:r>
-            <a:endParaRPr lang="en-US" sz="1400" dirty="0"/>
-          </a:p>
-        </p:txBody>
-      </p:sp>
-      <p:sp>
-        <p:nvSpPr>
-          <p:cNvPr id="6" name="Member 1 files"/>
-          <p:cNvSpPr txBox="1"/>
-          <p:nvPr/>
-        </p:nvSpPr>
-        <p:spPr>
-          <a:xfrm>
-            <a:off x="685800" y="3474720"/>
-            <a:ext cx="3566160" cy="457200"/>
-          </a:xfrm>
-          <a:prstGeom prst="rect">
-            <a:avLst/>
-          </a:prstGeom>
-          <a:noFill/>
-          <a:ln/>
-        </p:spPr>
-        <p:txBody>
-          <a:bodyPr wrap="square" lIns="0" tIns="0" rIns="0" bIns="0" rtlCol="0" anchor="t"/>
-          <a:lstStyle/>
-          <a:p>
-            <a:pPr indent="0" marL="0">
-              <a:buNone/>
-            </a:pPr>
-            <a:r>
-              <a:rPr lang="en-US" sz="1100" dirty="0">
-                <a:solidFill>
-                  <a:schemeClr val="accent6"/>
-                </a:solidFill>
-                <a:latin typeface="Courier New" pitchFamily="34" charset="0"/>
-                <a:ea typeface="Courier New" pitchFamily="34" charset="-122"/>
-                <a:cs typeface="Courier New" pitchFamily="34" charset="-120"/>
-              </a:rPr>
-              <a:t>src/models/tacotron.py, src/vocoder/, src/infer.py, app/</a:t>
-            </a:r>
-            <a:endParaRPr lang="en-US" sz="1100" dirty="0"/>
-          </a:p>
-        </p:txBody>
-      </p:sp>
-      <p:sp>
-        <p:nvSpPr>
-          <p:cNvPr id="7" name="Member card 2"/>
-          <p:cNvSpPr/>
-          <p:nvPr/>
-        </p:nvSpPr>
-        <p:spPr>
-          <a:xfrm>
-            <a:off x="4663440" y="1051560"/>
-            <a:ext cx="4023360" cy="3017520"/>
-          </a:xfrm>
-          <a:prstGeom prst="roundRect">
-            <a:avLst>
-              <a:gd name="adj" fmla="val 2424"/>
-            </a:avLst>
-          </a:prstGeom>
-          <a:solidFill>
-            <a:schemeClr val="bg2"/>
-          </a:solidFill>
-          <a:ln w="12700">
-            <a:solidFill>
-              <a:schemeClr val="bg2"/>
-            </a:solidFill>
-            <a:prstDash val="solid"/>
-          </a:ln>
-        </p:spPr>
-      </p:sp>
-      <p:sp>
-        <p:nvSpPr>
-          <p:cNvPr id="8" name="Member 2 name"/>
-          <p:cNvSpPr txBox="1"/>
-          <p:nvPr/>
-        </p:nvSpPr>
-        <p:spPr>
-          <a:xfrm>
-            <a:off x="4892040" y="1188720"/>
-            <a:ext cx="3566160" cy="384048"/>
-          </a:xfrm>
-          <a:prstGeom prst="rect">
-            <a:avLst/>
-          </a:prstGeom>
-          <a:noFill/>
-          <a:ln/>
-        </p:spPr>
-        <p:txBody>
-          <a:bodyPr wrap="square" lIns="0" tIns="0" rIns="0" bIns="0" rtlCol="0" anchor="ctr"/>
-          <a:lstStyle/>
-          <a:p>
-            <a:pPr indent="0" marL="0">
-              <a:buNone/>
-            </a:pPr>
-            <a:r>
-              <a:rPr lang="en-US" sz="1800" b="1" dirty="0">
-                <a:solidFill>
-                  <a:schemeClr val="accent1"/>
-                </a:solidFill>
-              </a:rPr>
-              <a:t>Marapareddy Deekshitha</a:t>
-            </a:r>
-            <a:endParaRPr lang="en-US" sz="1800" dirty="0"/>
-          </a:p>
-        </p:txBody>
-      </p:sp>
-      <p:sp>
-        <p:nvSpPr>
-          <p:cNvPr id="9" name="Member 2 work"/>
-          <p:cNvSpPr txBox="1"/>
-          <p:nvPr/>
-        </p:nvSpPr>
-        <p:spPr>
-          <a:xfrm>
-            <a:off x="4892040" y="1645920"/>
-            <a:ext cx="3566160" cy="2194560"/>
-          </a:xfrm>
-          <a:prstGeom prst="rect">
-            <a:avLst/>
-          </a:prstGeom>
-          <a:noFill/>
-          <a:ln/>
-        </p:spPr>
-        <p:txBody>
-          <a:bodyPr wrap="square" lIns="0" tIns="0" rIns="0" bIns="0" rtlCol="0" anchor="t"/>
-          <a:lstStyle/>
-          <a:p>
-            <a:pPr marL="342900" indent="-342900">
-              <a:spcAft>
-                <a:spcPts val="300"/>
-              </a:spcAft>
-              <a:buSzPct val="100000"/>
-              <a:buChar char="•"/>
-            </a:pPr>
-            <a:r>
-              <a:rPr lang="en-US" sz="1400" dirty="0">
-                <a:solidFill>
-                  <a:schemeClr val="tx1"/>
-                </a:solidFill>
-              </a:rPr>
-              <a:t>LJ Speech download and subset</a:t>
-            </a:r>
-            <a:endParaRPr lang="en-US" sz="1400" dirty="0"/>
-          </a:p>
-          <a:p>
-            <a:pPr marL="342900" indent="-342900">
-              <a:spcAft>
-                <a:spcPts val="300"/>
-              </a:spcAft>
-              <a:buSzPct val="100000"/>
-              <a:buChar char="•"/>
-            </a:pPr>
-            <a:r>
-              <a:rPr lang="en-US" sz="1400" dirty="0">
-                <a:solidFill>
-                  <a:schemeClr val="tx1"/>
-                </a:solidFill>
-              </a:rPr>
-              <a:t>Text cleaning and fixed vocabulary</a:t>
-            </a:r>
-            <a:endParaRPr lang="en-US" sz="1400" dirty="0"/>
-          </a:p>
-          <a:p>
-            <a:pPr marL="342900" indent="-342900">
-              <a:spcAft>
-                <a:spcPts val="300"/>
-              </a:spcAft>
-              <a:buSzPct val="100000"/>
-              <a:buChar char="•"/>
-            </a:pPr>
-            <a:r>
-              <a:rPr lang="en-US" sz="1400" dirty="0">
-                <a:solidFill>
-                  <a:schemeClr val="tx1"/>
-                </a:solidFill>
-              </a:rPr>
-              <a:t>Mel extraction, splits, sanity check</a:t>
-            </a:r>
-            <a:endParaRPr lang="en-US" sz="1400" dirty="0"/>
-          </a:p>
-          <a:p>
-            <a:pPr marL="342900" indent="-342900">
-              <a:spcAft>
-                <a:spcPts val="300"/>
-              </a:spcAft>
-              <a:buSzPct val="100000"/>
-              <a:buChar char="•"/>
-            </a:pPr>
-            <a:r>
-              <a:rPr lang="en-US" sz="1400" dirty="0">
-                <a:solidFill>
-                  <a:schemeClr val="tx1"/>
-                </a:solidFill>
-              </a:rPr>
-              <a:t>Baseline model and its training</a:t>
-            </a:r>
-            <a:endParaRPr lang="en-US" sz="1400" dirty="0"/>
-          </a:p>
-          <a:p>
-            <a:pPr marL="342900" indent="-342900">
-              <a:spcAft>
-                <a:spcPts val="300"/>
-              </a:spcAft>
-              <a:buSzPct val="100000"/>
-              <a:buChar char="•"/>
-            </a:pPr>
-            <a:r>
-              <a:rPr lang="en-US" sz="1400" dirty="0">
-                <a:solidFill>
-                  <a:schemeClr val="tx1"/>
-                </a:solidFill>
-              </a:rPr>
-              <a:t>Mel-distance evaluation</a:t>
-            </a:r>
-            <a:endParaRPr lang="en-US" sz="1400" dirty="0"/>
-          </a:p>
-          <a:p>
-            <a:pPr marL="342900" indent="-342900">
-              <a:spcAft>
-                <a:spcPts val="300"/>
-              </a:spcAft>
-              <a:buSzPct val="100000"/>
-              <a:buChar char="•"/>
-            </a:pPr>
-            <a:r>
-              <a:rPr lang="en-US" sz="1400" dirty="0">
-                <a:solidFill>
-                  <a:schemeClr val="tx1"/>
-                </a:solidFill>
-              </a:rPr>
-              <a:t>Results table</a:t>
-            </a:r>
-            <a:endParaRPr lang="en-US" sz="1400" dirty="0"/>
-          </a:p>
-        </p:txBody>
-      </p:sp>
-      <p:sp>
-        <p:nvSpPr>
-          <p:cNvPr id="10" name="Member 2 files"/>
-          <p:cNvSpPr txBox="1"/>
-          <p:nvPr/>
-        </p:nvSpPr>
-        <p:spPr>
-          <a:xfrm>
-            <a:off x="4892040" y="3474720"/>
-            <a:ext cx="3566160" cy="457200"/>
-          </a:xfrm>
-          <a:prstGeom prst="rect">
-            <a:avLst/>
-          </a:prstGeom>
-          <a:noFill/>
-          <a:ln/>
-        </p:spPr>
-        <p:txBody>
-          <a:bodyPr wrap="square" lIns="0" tIns="0" rIns="0" bIns="0" rtlCol="0" anchor="t"/>
-          <a:lstStyle/>
-          <a:p>
-            <a:pPr indent="0" marL="0">
-              <a:buNone/>
-            </a:pPr>
-            <a:r>
-              <a:rPr lang="en-US" sz="1100" dirty="0">
-                <a:solidFill>
-                  <a:schemeClr val="accent6"/>
-                </a:solidFill>
-                <a:latin typeface="Courier New" pitchFamily="34" charset="0"/>
-                <a:ea typeface="Courier New" pitchFamily="34" charset="-122"/>
-                <a:cs typeface="Courier New" pitchFamily="34" charset="-120"/>
-              </a:rPr>
-              <a:t>src/preprocess/, src/models/baseline.py, eval/</a:t>
-            </a:r>
-            <a:endParaRPr lang="en-US" sz="1100" dirty="0"/>
-          </a:p>
-        </p:txBody>
-      </p:sp>
-      <p:sp>
-        <p:nvSpPr>
-          <p:cNvPr id="25" name="Slide Number Placeholder 0"/>
-          <p:cNvSpPr>
-            <a:spLocks noGrp="1"/>
-          </p:cNvSpPr>
-          <p:nvPr>
-            <p:ph type="sldNum" sz="quarter" idx="4294967295"/>
-          </p:nvPr>
-        </p:nvSpPr>
-        <p:spPr>
-          <a:xfrm>
-            <a:off x="8229600" y="4754880"/>
-            <a:ext cx="457200" cy="274320"/>
-          </a:xfrm>
-          <a:prstGeom prst="rect">
-            <a:avLst/>
-          </a:prstGeom>
-          <a:extLst>
-            <a:ext uri="{C572A759-6A51-4108-AA02-DFA0A04FC94B}">
-              <ma14:wrappingTextBoxFlag xmlns:ma14="http://schemas.microsoft.com/office/mac/drawingml/2011/main" val="0"/>
-            </a:ext>
-          </a:extLst>
-        </p:spPr>
-        <p:txBody>
-          <a:bodyPr/>
-          <a:lstStyle>
-            <a:lvl1pPr>
-              <a:defRPr sz="1000">
-                <a:solidFill>
-                  <a:schemeClr val="accent6"/>
-                </a:solidFill>
-              </a:defRPr>
-            </a:lvl1pPr>
-          </a:lstStyle>
-          <a:p>
-            <a:pPr algn="r"/>
-            <a:fld id="{F7021451-1387-4CA6-816F-3879F97B5CBC}" type="slidenum">
-              <a:rPr b="0" lang="en-US"/>
-              <a:t>14</a:t>
-            </a:fld>
-            <a:endParaRPr lang="en-US"/>
-          </a:p>
-        </p:txBody>
-      </p:sp>
-    </p:spTree>
-  </p:cSld>
-  <p:clrMapOvr>
-    <a:masterClrMapping/>
-  </p:clrMapOvr>
-</p:sld>
-</file>
-
-<file path=ppt/slides/slide15.xml><?xml version="1.0" encoding="utf-8"?>
-<p:sld xmlns:a="http://schemas.openxmlformats.org/drawingml/2006/main" xmlns:r="http://schemas.openxmlformats.org/officeDocument/2006/relationships" xmlns:p="http://schemas.openxmlformats.org/presentationml/2006/main">
-  <p:cSld name="Slide 15">
-    <p:spTree>
-      <p:nvGrpSpPr>
-        <p:cNvPr id="1" name=""/>
-        <p:cNvGrpSpPr/>
-        <p:nvPr/>
-      </p:nvGrpSpPr>
-      <p:grpSpPr>
-        <a:xfrm>
-          <a:off x="0" y="0"/>
-          <a:ext cx="0" cy="0"/>
-          <a:chOff x="0" y="0"/>
-          <a:chExt cx="0" cy="0"/>
-        </a:xfrm>
-      </p:grpSpPr>
-      <p:sp>
-        <p:nvSpPr>
-          <p:cNvPr id="2" name="Text 0"/>
-          <p:cNvSpPr/>
-          <p:nvPr>
-            <p:ph idx="100" type="title" hasCustomPrompt="1"/>
-          </p:nvPr>
-        </p:nvSpPr>
-        <p:spPr>
-          <a:xfrm>
             <a:off x="548640" y="1417320"/>
             <a:ext cx="8046720" cy="1005840"/>
           </a:xfrm>
@@ -10755,42 +9982,6 @@
       </p:sp>
       <p:sp>
         <p:nvSpPr>
-          <p:cNvPr id="14" name="Owner tag"/>
-          <p:cNvSpPr txBox="1"/>
-          <p:nvPr/>
-        </p:nvSpPr>
-        <p:spPr>
-          <a:xfrm>
-            <a:off x="5943600" y="4754880"/>
-            <a:ext cx="2194560" cy="274320"/>
-          </a:xfrm>
-          <a:prstGeom prst="rect">
-            <a:avLst/>
-          </a:prstGeom>
-          <a:noFill/>
-          <a:ln/>
-        </p:spPr>
-        <p:txBody>
-          <a:bodyPr wrap="square" lIns="0" tIns="0" rIns="0" bIns="0" rtlCol="0" anchor="ctr"/>
-          <a:lstStyle/>
-          <a:p>
-            <a:pPr algn="r" indent="0" marL="0">
-              <a:buNone/>
-            </a:pPr>
-            <a:r>
-              <a:rPr lang="en-US" sz="1000" i="1" dirty="0">
-                <a:solidFill>
-                  <a:schemeClr val="accent6"/>
-                </a:solidFill>
-              </a:rPr>
-              <a:t>Deekshitha</a:t>
-            </a:r>
-            <a:endParaRPr lang="en-US" sz="1000" dirty="0"/>
-          </a:p>
-        </p:txBody>
-      </p:sp>
-      <p:sp>
-        <p:nvSpPr>
           <p:cNvPr id="25" name="Slide Number Placeholder 0"/>
           <p:cNvSpPr>
             <a:spLocks noGrp="1"/>
@@ -11457,42 +10648,6 @@
       </p:sp>
       <p:sp>
         <p:nvSpPr>
-          <p:cNvPr id="18" name="Owner tag"/>
-          <p:cNvSpPr txBox="1"/>
-          <p:nvPr/>
-        </p:nvSpPr>
-        <p:spPr>
-          <a:xfrm>
-            <a:off x="5943600" y="4754880"/>
-            <a:ext cx="2194560" cy="274320"/>
-          </a:xfrm>
-          <a:prstGeom prst="rect">
-            <a:avLst/>
-          </a:prstGeom>
-          <a:noFill/>
-          <a:ln/>
-        </p:spPr>
-        <p:txBody>
-          <a:bodyPr wrap="square" lIns="0" tIns="0" rIns="0" bIns="0" rtlCol="0" anchor="ctr"/>
-          <a:lstStyle/>
-          <a:p>
-            <a:pPr algn="r" indent="0" marL="0">
-              <a:buNone/>
-            </a:pPr>
-            <a:r>
-              <a:rPr lang="en-US" sz="1000" i="1" dirty="0">
-                <a:solidFill>
-                  <a:schemeClr val="accent6"/>
-                </a:solidFill>
-              </a:rPr>
-              <a:t>Deekshitha</a:t>
-            </a:r>
-            <a:endParaRPr lang="en-US" sz="1000" dirty="0"/>
-          </a:p>
-        </p:txBody>
-      </p:sp>
-      <p:sp>
-        <p:nvSpPr>
           <p:cNvPr id="25" name="Slide Number Placeholder 0"/>
           <p:cNvSpPr>
             <a:spLocks noGrp="1"/>
@@ -12291,42 +11446,6 @@
       </p:sp>
       <p:sp>
         <p:nvSpPr>
-          <p:cNvPr id="21" name="Owner tag"/>
-          <p:cNvSpPr txBox="1"/>
-          <p:nvPr/>
-        </p:nvSpPr>
-        <p:spPr>
-          <a:xfrm>
-            <a:off x="5943600" y="4754880"/>
-            <a:ext cx="2194560" cy="274320"/>
-          </a:xfrm>
-          <a:prstGeom prst="rect">
-            <a:avLst/>
-          </a:prstGeom>
-          <a:noFill/>
-          <a:ln/>
-        </p:spPr>
-        <p:txBody>
-          <a:bodyPr wrap="square" lIns="0" tIns="0" rIns="0" bIns="0" rtlCol="0" anchor="ctr"/>
-          <a:lstStyle/>
-          <a:p>
-            <a:pPr algn="r" indent="0" marL="0">
-              <a:buNone/>
-            </a:pPr>
-            <a:r>
-              <a:rPr lang="en-US" sz="1000" i="1" dirty="0">
-                <a:solidFill>
-                  <a:schemeClr val="accent6"/>
-                </a:solidFill>
-              </a:rPr>
-              <a:t>Mann</a:t>
-            </a:r>
-            <a:endParaRPr lang="en-US" sz="1000" dirty="0"/>
-          </a:p>
-        </p:txBody>
-      </p:sp>
-      <p:sp>
-        <p:nvSpPr>
           <p:cNvPr id="25" name="Slide Number Placeholder 0"/>
           <p:cNvSpPr>
             <a:spLocks noGrp="1"/>
@@ -12445,11 +11564,11 @@
         <p:spPr>
           <a:xfrm>
             <a:off x="457200" y="1097280"/>
-            <a:ext cx="2615184" cy="2880360"/>
+            <a:ext cx="4023360" cy="2880360"/>
           </a:xfrm>
           <a:prstGeom prst="roundRect">
             <a:avLst>
-              <a:gd name="adj" fmla="val 2797"/>
+              <a:gd name="adj" fmla="val 2540"/>
             </a:avLst>
           </a:prstGeom>
           <a:solidFill>
@@ -12471,8 +11590,8 @@
         </p:nvSpPr>
         <p:spPr>
           <a:xfrm>
-            <a:off x="640080" y="1234440"/>
-            <a:ext cx="2286000" cy="365760"/>
+            <a:off x="731520" y="1280160"/>
+            <a:ext cx="3474720" cy="365760"/>
           </a:xfrm>
           <a:prstGeom prst="rect">
             <a:avLst/>
@@ -12488,14 +11607,14 @@
               <a:buNone/>
             </a:pPr>
             <a:r>
-              <a:rPr lang="en-US" sz="1800" b="1" dirty="0">
+              <a:rPr lang="en-US" sz="2000" b="1" dirty="0">
                 <a:solidFill>
                   <a:schemeClr val="tx1"/>
                 </a:solidFill>
               </a:rPr>
-              <a:t>WaveRNN</a:t>
-            </a:r>
-            <a:endParaRPr lang="en-US" sz="1800" dirty="0"/>
+              <a:t>Griffin-Lim</a:t>
+            </a:r>
+            <a:endParaRPr lang="en-US" sz="2000" dirty="0"/>
           </a:p>
         </p:txBody>
       </p:sp>
@@ -12507,8 +11626,8 @@
         </p:nvSpPr>
         <p:spPr>
           <a:xfrm>
-            <a:off x="640080" y="1600200"/>
-            <a:ext cx="2286000" cy="320040"/>
+            <a:off x="731520" y="1645920"/>
+            <a:ext cx="3474720" cy="320040"/>
           </a:xfrm>
           <a:prstGeom prst="rect">
             <a:avLst/>
@@ -12524,14 +11643,14 @@
               <a:buNone/>
             </a:pPr>
             <a:r>
-              <a:rPr lang="en-US" sz="1200" dirty="0">
+              <a:rPr lang="en-US" sz="1300" dirty="0">
                 <a:solidFill>
                   <a:schemeClr val="accent6"/>
                 </a:solidFill>
               </a:rPr>
-              <a:t>one sample at a time</a:t>
-            </a:r>
-            <a:endParaRPr lang="en-US" sz="1200" dirty="0"/>
+              <a:t>signal processing, no learning</a:t>
+            </a:r>
+            <a:endParaRPr lang="en-US" sz="1300" dirty="0"/>
           </a:p>
         </p:txBody>
       </p:sp>
@@ -12543,8 +11662,8 @@
         </p:nvSpPr>
         <p:spPr>
           <a:xfrm>
-            <a:off x="640080" y="2011680"/>
-            <a:ext cx="2286000" cy="731520"/>
+            <a:off x="731520" y="2057400"/>
+            <a:ext cx="3474720" cy="731520"/>
           </a:xfrm>
           <a:prstGeom prst="rect">
             <a:avLst/>
@@ -12560,17 +11679,17 @@
               <a:buNone/>
             </a:pPr>
             <a:r>
-              <a:rPr lang="en-US" sz="4000" b="1" dirty="0">
-                <a:solidFill>
-                  <a:schemeClr val="accent6"/>
+              <a:rPr lang="en-US" sz="4400" b="1" dirty="0">
+                <a:solidFill>
+                  <a:schemeClr val="accent1"/>
                 </a:solidFill>
                 <a:latin typeface="Arial" pitchFamily="34" charset="0"/>
                 <a:ea typeface="Arial" pitchFamily="34" charset="-122"/>
                 <a:cs typeface="Arial" pitchFamily="34" charset="-120"/>
               </a:rPr>
-              <a:t>48.7 s</a:t>
-            </a:r>
-            <a:endParaRPr lang="en-US" sz="4000" dirty="0"/>
+              <a:t>0.08 s</a:t>
+            </a:r>
+            <a:endParaRPr lang="en-US" sz="4400" dirty="0"/>
           </a:p>
         </p:txBody>
       </p:sp>
@@ -12582,8 +11701,8 @@
         </p:nvSpPr>
         <p:spPr>
           <a:xfrm>
-            <a:off x="640080" y="2697480"/>
-            <a:ext cx="2286000" cy="274320"/>
+            <a:off x="731520" y="2743200"/>
+            <a:ext cx="3474720" cy="274320"/>
           </a:xfrm>
           <a:prstGeom prst="rect">
             <a:avLst/>
@@ -12618,8 +11737,8 @@
         </p:nvSpPr>
         <p:spPr>
           <a:xfrm>
-            <a:off x="640080" y="3108960"/>
-            <a:ext cx="2286000" cy="731520"/>
+            <a:off x="731520" y="3154680"/>
+            <a:ext cx="3474720" cy="731520"/>
           </a:xfrm>
           <a:prstGeom prst="rect">
             <a:avLst/>
@@ -12635,14 +11754,14 @@
               <a:buNone/>
             </a:pPr>
             <a:r>
-              <a:rPr lang="en-US" sz="1300" dirty="0">
+              <a:rPr lang="en-US" sz="1400" dirty="0">
                 <a:solidFill>
                   <a:schemeClr val="tx1"/>
                 </a:solidFill>
               </a:rPr>
-              <a:t>Tried and removed: too slow for a live demo</a:t>
-            </a:r>
-            <a:endParaRPr lang="en-US" sz="1300" dirty="0"/>
+              <a:t>Fast and intelligible, but slightly metallic: it has to guess the phase the mel throws away</a:t>
+            </a:r>
+            <a:endParaRPr lang="en-US" sz="1400" dirty="0"/>
           </a:p>
         </p:txBody>
       </p:sp>
@@ -12654,12 +11773,12 @@
         </p:nvSpPr>
         <p:spPr>
           <a:xfrm>
-            <a:off x="3264408" y="1097280"/>
-            <a:ext cx="2615184" cy="2880360"/>
+            <a:off x="4663440" y="1097280"/>
+            <a:ext cx="4023360" cy="2880360"/>
           </a:xfrm>
           <a:prstGeom prst="roundRect">
             <a:avLst>
-              <a:gd name="adj" fmla="val 2797"/>
+              <a:gd name="adj" fmla="val 2540"/>
             </a:avLst>
           </a:prstGeom>
           <a:solidFill>
@@ -12681,8 +11800,8 @@
         </p:nvSpPr>
         <p:spPr>
           <a:xfrm>
-            <a:off x="3447288" y="1234440"/>
-            <a:ext cx="2286000" cy="365760"/>
+            <a:off x="4937760" y="1280160"/>
+            <a:ext cx="3474720" cy="365760"/>
           </a:xfrm>
           <a:prstGeom prst="rect">
             <a:avLst/>
@@ -12698,14 +11817,14 @@
               <a:buNone/>
             </a:pPr>
             <a:r>
-              <a:rPr lang="en-US" sz="1800" b="1" dirty="0">
+              <a:rPr lang="en-US" sz="2000" b="1" dirty="0">
                 <a:solidFill>
                   <a:schemeClr val="tx1"/>
                 </a:solidFill>
               </a:rPr>
-              <a:t>Griffin-Lim</a:t>
-            </a:r>
-            <a:endParaRPr lang="en-US" sz="1800" dirty="0"/>
+              <a:t>HiFi-GAN</a:t>
+            </a:r>
+            <a:endParaRPr lang="en-US" sz="2000" dirty="0"/>
           </a:p>
         </p:txBody>
       </p:sp>
@@ -12717,8 +11836,8 @@
         </p:nvSpPr>
         <p:spPr>
           <a:xfrm>
-            <a:off x="3447288" y="1600200"/>
-            <a:ext cx="2286000" cy="320040"/>
+            <a:off x="4937760" y="1645920"/>
+            <a:ext cx="3474720" cy="320040"/>
           </a:xfrm>
           <a:prstGeom prst="rect">
             <a:avLst/>
@@ -12734,14 +11853,14 @@
               <a:buNone/>
             </a:pPr>
             <a:r>
-              <a:rPr lang="en-US" sz="1200" dirty="0">
+              <a:rPr lang="en-US" sz="1300" dirty="0">
                 <a:solidFill>
                   <a:schemeClr val="accent6"/>
                 </a:solidFill>
               </a:rPr>
-              <a:t>signal processing, no learning</a:t>
-            </a:r>
-            <a:endParaRPr lang="en-US" sz="1200" dirty="0"/>
+              <a:t>neural network (GAN), all frames in parallel</a:t>
+            </a:r>
+            <a:endParaRPr lang="en-US" sz="1300" dirty="0"/>
           </a:p>
         </p:txBody>
       </p:sp>
@@ -12753,8 +11872,8 @@
         </p:nvSpPr>
         <p:spPr>
           <a:xfrm>
-            <a:off x="3447288" y="2011680"/>
-            <a:ext cx="2286000" cy="731520"/>
+            <a:off x="4937760" y="2057400"/>
+            <a:ext cx="3474720" cy="731520"/>
           </a:xfrm>
           <a:prstGeom prst="rect">
             <a:avLst/>
@@ -12770,17 +11889,17 @@
               <a:buNone/>
             </a:pPr>
             <a:r>
-              <a:rPr lang="en-US" sz="4000" b="1" dirty="0">
-                <a:solidFill>
-                  <a:schemeClr val="accent1"/>
+              <a:rPr lang="en-US" sz="4400" b="1" dirty="0">
+                <a:solidFill>
+                  <a:schemeClr val="accent4"/>
                 </a:solidFill>
                 <a:latin typeface="Arial" pitchFamily="34" charset="0"/>
                 <a:ea typeface="Arial" pitchFamily="34" charset="-122"/>
                 <a:cs typeface="Arial" pitchFamily="34" charset="-120"/>
               </a:rPr>
-              <a:t>0.08 s</a:t>
-            </a:r>
-            <a:endParaRPr lang="en-US" sz="4000" dirty="0"/>
+              <a:t>0.65 s</a:t>
+            </a:r>
+            <a:endParaRPr lang="en-US" sz="4400" dirty="0"/>
           </a:p>
         </p:txBody>
       </p:sp>
@@ -12792,8 +11911,8 @@
         </p:nvSpPr>
         <p:spPr>
           <a:xfrm>
-            <a:off x="3447288" y="2697480"/>
-            <a:ext cx="2286000" cy="274320"/>
+            <a:off x="4937760" y="2743200"/>
+            <a:ext cx="3474720" cy="274320"/>
           </a:xfrm>
           <a:prstGeom prst="rect">
             <a:avLst/>
@@ -12828,8 +11947,8 @@
         </p:nvSpPr>
         <p:spPr>
           <a:xfrm>
-            <a:off x="3447288" y="3108960"/>
-            <a:ext cx="2286000" cy="731520"/>
+            <a:off x="4937760" y="3154680"/>
+            <a:ext cx="3474720" cy="731520"/>
           </a:xfrm>
           <a:prstGeom prst="rect">
             <a:avLst/>
@@ -12845,230 +11964,20 @@
               <a:buNone/>
             </a:pPr>
             <a:r>
-              <a:rPr lang="en-US" sz="1300" dirty="0">
+              <a:rPr lang="en-US" sz="1400" dirty="0">
                 <a:solidFill>
                   <a:schemeClr val="tx1"/>
                 </a:solidFill>
               </a:rPr>
-              <a:t>Fast, intelligible, slightly metallic</a:t>
-            </a:r>
-            <a:endParaRPr lang="en-US" sz="1300" dirty="0"/>
-          </a:p>
-        </p:txBody>
-      </p:sp>
-      <p:sp>
-        <p:nvSpPr>
-          <p:cNvPr id="15" name="Vocoder card 3"/>
-          <p:cNvSpPr/>
-          <p:nvPr/>
-        </p:nvSpPr>
-        <p:spPr>
-          <a:xfrm>
-            <a:off x="6071616" y="1097280"/>
-            <a:ext cx="2615184" cy="2880360"/>
-          </a:xfrm>
-          <a:prstGeom prst="roundRect">
-            <a:avLst>
-              <a:gd name="adj" fmla="val 2797"/>
-            </a:avLst>
-          </a:prstGeom>
-          <a:solidFill>
-            <a:schemeClr val="bg2"/>
-          </a:solidFill>
-          <a:ln w="12700">
-            <a:solidFill>
-              <a:schemeClr val="bg2"/>
-            </a:solidFill>
-            <a:prstDash val="solid"/>
-          </a:ln>
-        </p:spPr>
-      </p:sp>
-      <p:sp>
-        <p:nvSpPr>
-          <p:cNvPr id="16" name="Vocoder 3 name"/>
-          <p:cNvSpPr txBox="1"/>
-          <p:nvPr/>
-        </p:nvSpPr>
-        <p:spPr>
-          <a:xfrm>
-            <a:off x="6254496" y="1234440"/>
-            <a:ext cx="2286000" cy="365760"/>
-          </a:xfrm>
-          <a:prstGeom prst="rect">
-            <a:avLst/>
-          </a:prstGeom>
-          <a:noFill/>
-          <a:ln/>
-        </p:spPr>
-        <p:txBody>
-          <a:bodyPr wrap="square" lIns="0" tIns="0" rIns="0" bIns="0" rtlCol="0" anchor="ctr"/>
-          <a:lstStyle/>
-          <a:p>
-            <a:pPr indent="0" marL="0">
-              <a:buNone/>
-            </a:pPr>
-            <a:r>
-              <a:rPr lang="en-US" sz="1800" b="1" dirty="0">
-                <a:solidFill>
-                  <a:schemeClr val="tx1"/>
-                </a:solidFill>
-              </a:rPr>
-              <a:t>HiFi-GAN</a:t>
-            </a:r>
-            <a:endParaRPr lang="en-US" sz="1800" dirty="0"/>
-          </a:p>
-        </p:txBody>
-      </p:sp>
-      <p:sp>
-        <p:nvSpPr>
-          <p:cNvPr id="17" name="Vocoder 3 how"/>
-          <p:cNvSpPr txBox="1"/>
-          <p:nvPr/>
-        </p:nvSpPr>
-        <p:spPr>
-          <a:xfrm>
-            <a:off x="6254496" y="1600200"/>
-            <a:ext cx="2286000" cy="320040"/>
-          </a:xfrm>
-          <a:prstGeom prst="rect">
-            <a:avLst/>
-          </a:prstGeom>
-          <a:noFill/>
-          <a:ln/>
-        </p:spPr>
-        <p:txBody>
-          <a:bodyPr wrap="square" lIns="0" tIns="0" rIns="0" bIns="0" rtlCol="0" anchor="ctr"/>
-          <a:lstStyle/>
-          <a:p>
-            <a:pPr indent="0" marL="0">
-              <a:buNone/>
-            </a:pPr>
-            <a:r>
-              <a:rPr lang="en-US" sz="1200" dirty="0">
-                <a:solidFill>
-                  <a:schemeClr val="accent6"/>
-                </a:solidFill>
-              </a:rPr>
-              <a:t>GAN, all frames in parallel</a:t>
-            </a:r>
-            <a:endParaRPr lang="en-US" sz="1200" dirty="0"/>
-          </a:p>
-        </p:txBody>
-      </p:sp>
-      <p:sp>
-        <p:nvSpPr>
-          <p:cNvPr id="18" name="Vocoder 3 time"/>
-          <p:cNvSpPr txBox="1"/>
-          <p:nvPr/>
-        </p:nvSpPr>
-        <p:spPr>
-          <a:xfrm>
-            <a:off x="6254496" y="2011680"/>
-            <a:ext cx="2286000" cy="731520"/>
-          </a:xfrm>
-          <a:prstGeom prst="rect">
-            <a:avLst/>
-          </a:prstGeom>
-          <a:noFill/>
-          <a:ln/>
-        </p:spPr>
-        <p:txBody>
-          <a:bodyPr wrap="square" lIns="0" tIns="0" rIns="0" bIns="0" rtlCol="0" anchor="ctr"/>
-          <a:lstStyle/>
-          <a:p>
-            <a:pPr indent="0" marL="0">
-              <a:buNone/>
-            </a:pPr>
-            <a:r>
-              <a:rPr lang="en-US" sz="4000" b="1" dirty="0">
-                <a:solidFill>
-                  <a:schemeClr val="accent4"/>
-                </a:solidFill>
-                <a:latin typeface="Arial" pitchFamily="34" charset="0"/>
-                <a:ea typeface="Arial" pitchFamily="34" charset="-122"/>
-                <a:cs typeface="Arial" pitchFamily="34" charset="-120"/>
-              </a:rPr>
-              <a:t>0.65 s</a:t>
-            </a:r>
-            <a:endParaRPr lang="en-US" sz="4000" dirty="0"/>
-          </a:p>
-        </p:txBody>
-      </p:sp>
-      <p:sp>
-        <p:nvSpPr>
-          <p:cNvPr id="19" name="Vocoder 3 unit"/>
-          <p:cNvSpPr txBox="1"/>
-          <p:nvPr/>
-        </p:nvSpPr>
-        <p:spPr>
-          <a:xfrm>
-            <a:off x="6254496" y="2697480"/>
-            <a:ext cx="2286000" cy="274320"/>
-          </a:xfrm>
-          <a:prstGeom prst="rect">
-            <a:avLst/>
-          </a:prstGeom>
-          <a:noFill/>
-          <a:ln/>
-        </p:spPr>
-        <p:txBody>
-          <a:bodyPr wrap="square" lIns="0" tIns="0" rIns="0" bIns="0" rtlCol="0" anchor="ctr"/>
-          <a:lstStyle/>
-          <a:p>
-            <a:pPr indent="0" marL="0">
-              <a:buNone/>
-            </a:pPr>
-            <a:r>
-              <a:rPr lang="en-US" sz="1200" dirty="0">
-                <a:solidFill>
-                  <a:schemeClr val="accent6"/>
-                </a:solidFill>
-              </a:rPr>
-              <a:t>to make 3.3 s of speech</a:t>
-            </a:r>
-            <a:endParaRPr lang="en-US" sz="1200" dirty="0"/>
-          </a:p>
-        </p:txBody>
-      </p:sp>
-      <p:sp>
-        <p:nvSpPr>
-          <p:cNvPr id="20" name="Vocoder 3 verdict"/>
-          <p:cNvSpPr txBox="1"/>
-          <p:nvPr/>
-        </p:nvSpPr>
-        <p:spPr>
-          <a:xfrm>
-            <a:off x="6254496" y="3108960"/>
-            <a:ext cx="2286000" cy="731520"/>
-          </a:xfrm>
-          <a:prstGeom prst="rect">
-            <a:avLst/>
-          </a:prstGeom>
-          <a:noFill/>
-          <a:ln/>
-        </p:spPr>
-        <p:txBody>
-          <a:bodyPr wrap="square" lIns="0" tIns="0" rIns="0" bIns="0" rtlCol="0" anchor="t"/>
-          <a:lstStyle/>
-          <a:p>
-            <a:pPr indent="0" marL="0">
-              <a:buNone/>
-            </a:pPr>
-            <a:r>
-              <a:rPr lang="en-US" sz="1300" dirty="0">
-                <a:solidFill>
-                  <a:schemeClr val="tx1"/>
-                </a:solidFill>
-              </a:rPr>
-              <a:t>Natural sounding, about 5× faster than real time</a:t>
-            </a:r>
-            <a:endParaRPr lang="en-US" sz="1300" dirty="0"/>
-          </a:p>
-        </p:txBody>
-      </p:sp>
-      <p:sp>
-        <p:nvSpPr>
-          <p:cNvPr id="21" name="Vocoder method"/>
+              <a:t>Natural sounding, and still about 5× faster than real time</a:t>
+            </a:r>
+            <a:endParaRPr lang="en-US" sz="1400" dirty="0"/>
+          </a:p>
+        </p:txBody>
+      </p:sp>
+      <p:sp>
+        <p:nvSpPr>
+          <p:cNvPr id="15" name="Vocoder method"/>
           <p:cNvSpPr txBox="1"/>
           <p:nvPr/>
         </p:nvSpPr>
@@ -13096,45 +12005,9 @@
                   <a:schemeClr val="accent6"/>
                 </a:solidFill>
               </a:rPr>
-              <a:t>Same sentence, laptop CPU. Griffin-Lim and HiFi-GAN get the identical mel, so only the vocoder differs (WaveRNN time includes Tacotron 2, about 1 s). Audio: samples/main_griffinlim/, samples/main_hifigan/.</a:t>
+              <a:t>Same sentence on a laptop CPU. Both vocoders get the identical mel from Tacotron 2, so only the vocoder differs. Audio: samples/main_griffinlim/ and samples/main_hifigan/.</a:t>
             </a:r>
             <a:endParaRPr lang="en-US" sz="1200" dirty="0"/>
-          </a:p>
-        </p:txBody>
-      </p:sp>
-      <p:sp>
-        <p:nvSpPr>
-          <p:cNvPr id="22" name="Owner tag"/>
-          <p:cNvSpPr txBox="1"/>
-          <p:nvPr/>
-        </p:nvSpPr>
-        <p:spPr>
-          <a:xfrm>
-            <a:off x="5943600" y="4754880"/>
-            <a:ext cx="2194560" cy="274320"/>
-          </a:xfrm>
-          <a:prstGeom prst="rect">
-            <a:avLst/>
-          </a:prstGeom>
-          <a:noFill/>
-          <a:ln/>
-        </p:spPr>
-        <p:txBody>
-          <a:bodyPr wrap="square" lIns="0" tIns="0" rIns="0" bIns="0" rtlCol="0" anchor="ctr"/>
-          <a:lstStyle/>
-          <a:p>
-            <a:pPr algn="r" indent="0" marL="0">
-              <a:buNone/>
-            </a:pPr>
-            <a:r>
-              <a:rPr lang="en-US" sz="1000" i="1" dirty="0">
-                <a:solidFill>
-                  <a:schemeClr val="accent6"/>
-                </a:solidFill>
-              </a:rPr>
-              <a:t>Mann</a:t>
-            </a:r>
-            <a:endParaRPr lang="en-US" sz="1000" dirty="0"/>
           </a:p>
         </p:txBody>
       </p:sp>

</xml_diff>

<commit_message>
Add Colatron: seq2seq TTS with attention trained from scratch, intelligibility eval, final results
Colatron (src/models/colatron.py) is a Tacotron-style model with location-sensitive
attention, reduction factor 3 and a guided attention loss, trained from scratch on all
13,100 LJ Speech clips (step 5,000, 2.2 h: laptop CPU then a Colab T4 GPU).
eval/intelligibility.py scores every system with a wav2vec 2.0 recogniser: Colatron +
HiFi-GAN reaches 25% WER vs 100% for the no-attention baseline and 16% for the
pretrained Tacotron 2 reference. README, demo, slides and write-up updated.
</commit_message>
<xml_diff>
--- a/report/Colatron_Slides.pptx
+++ b/report/Colatron_Slides.pptx
@@ -19,9 +19,10 @@
     <p:sldId id="267" r:id="rId13"/>
     <p:sldId id="268" r:id="rId14"/>
     <p:sldId id="269" r:id="rId15"/>
+    <p:sldId id="270" r:id="rId16"/>
   </p:sldIdLst>
   <p:notesMasterIdLst>
-    <p:notesMasterId r:id="rId16"/>
+    <p:notesMasterId r:id="rId17"/>
   </p:notesMasterIdLst>
   <p:sldSz cx="9144000" cy="5143500"/>
   <p:notesSz cx="5143500" cy="9144000"/>
@@ -120,14 +121,14 @@
   <p:extLst>
     <p:ext uri="{521415D9-36F7-43E2-AB2F-B90AF26B5E84}">
       <p14:sectionLst xmlns:p14="http://schemas.microsoft.com/office/powerpoint/2010/main">
-        <p14:section name="Introduction" id="{d0001848-0b67-cd8c-871a-bd8efc2c8030}">
+        <p14:section name="Introduction" id="{a21c2c4b-f9e5-b764-d6a3-ab6ac27b1da0}">
           <p14:sldIdLst>
             <p14:sldId id="256"/>
             <p14:sldId id="257"/>
             <p14:sldId id="258"/>
           </p14:sldIdLst>
         </p14:section>
-        <p14:section name="Approach" id="{b2ba2209-1f26-b03a-810f-f1cdbb9510f8}">
+        <p14:section name="Approach" id="{6b08e77d-99e7-0e85-9110-c4dd00c456f3}">
           <p14:sldIdLst>
             <p14:sldId id="259"/>
             <p14:sldId id="260"/>
@@ -136,18 +137,19 @@
             <p14:sldId id="263"/>
           </p14:sldIdLst>
         </p14:section>
-        <p14:section name="Results" id="{e66cb7cc-d929-765f-467c-e077b3994495}">
+        <p14:section name="Results" id="{7cfe2074-b49f-bba7-efd3-5dec983185ed}">
           <p14:sldIdLst>
             <p14:sldId id="264"/>
             <p14:sldId id="265"/>
             <p14:sldId id="266"/>
             <p14:sldId id="267"/>
+            <p14:sldId id="268"/>
           </p14:sldIdLst>
         </p14:section>
-        <p14:section name="Wrap-up" id="{b2781ca8-65cf-f106-b847-61026dfb9714}">
+        <p14:section name="Wrap-up" id="{53427a55-1462-1353-1cd1-23dfdb32f4ea}">
           <p14:sldIdLst>
-            <p14:sldId id="268"/>
             <p14:sldId id="269"/>
+            <p14:sldId id="270"/>
           </p14:sldIdLst>
         </p14:section>
       </p14:sectionLst>
@@ -507,7 +509,7 @@
                 </a:solidFill>
                 <a:latin typeface="+mn-lt"/>
               </a:rPr>
-              <a:t>Distance to the real recording (lower is better)</a:t>
+              <a:t>Word error rate of a speech recogniser (lower is better)</a:t>
             </a:r>
           </a:p>
         </c:rich>
@@ -531,7 +533,346 @@
               <c:strCache>
                 <c:ptCount val="1"/>
                 <c:pt idx="0">
-                  <c:v>Baseline (ours) + Griffin-Lim</c:v>
+                  <c:v>WER</c:v>
+                </c:pt>
+              </c:strCache>
+            </c:strRef>
+          </c:tx>
+          <c:spPr>
+            <a:solidFill>
+              <a:srgbClr val="A8A2C2"/>
+            </a:solidFill>
+            <a:effectLst/>
+          </c:spPr>
+          <c:invertIfNegative val="0"/>
+          <c:dLbls>
+            <c:numFmt formatCode="0&quot;%&quot;" sourceLinked="0"/>
+            <c:txPr>
+              <a:bodyPr/>
+              <a:lstStyle/>
+              <a:p>
+                <a:pPr>
+                  <a:defRPr b="0" i="0" strike="noStrike" sz="1200" u="none">
+                    <a:solidFill>
+                      <a:srgbClr val="1C1A2E"/>
+                    </a:solidFill>
+                    <a:latin typeface="+mn-lt"/>
+                  </a:defRPr>
+                </a:pPr>
+              </a:p>
+            </c:txPr>
+            <c:showLegendKey val="0"/>
+            <c:showVal val="1"/>
+            <c:showCatName val="0"/>
+            <c:showSerName val="0"/>
+            <c:showPercent val="0"/>
+            <c:showBubbleSize val="0"/>
+            <c:showLeaderLines val="0"/>
+          </c:dLbls>
+          <c:dPt>
+            <c:idx val="0"/>
+            <c:invertIfNegative val="0"/>
+            <c:bubble3D val="0"/>
+            <c:spPr>
+              <a:solidFill>
+                <a:srgbClr val="A8A2C2"/>
+              </a:solidFill>
+              <a:effectLst/>
+            </c:spPr>
+          </c:dPt>
+          <c:dPt>
+            <c:idx val="1"/>
+            <c:invertIfNegative val="0"/>
+            <c:bubble3D val="0"/>
+            <c:spPr>
+              <a:solidFill>
+                <a:srgbClr val="FF6B57"/>
+              </a:solidFill>
+              <a:effectLst/>
+            </c:spPr>
+          </c:dPt>
+          <c:dPt>
+            <c:idx val="2"/>
+            <c:invertIfNegative val="0"/>
+            <c:bubble3D val="0"/>
+            <c:spPr>
+              <a:solidFill>
+                <a:srgbClr val="5B3FD9"/>
+              </a:solidFill>
+              <a:effectLst/>
+            </c:spPr>
+          </c:dPt>
+          <c:dPt>
+            <c:idx val="3"/>
+            <c:invertIfNegative val="0"/>
+            <c:bubble3D val="0"/>
+            <c:spPr>
+              <a:solidFill>
+                <a:srgbClr val="5B3FD9"/>
+              </a:solidFill>
+              <a:effectLst/>
+            </c:spPr>
+          </c:dPt>
+          <c:dPt>
+            <c:idx val="4"/>
+            <c:invertIfNegative val="0"/>
+            <c:bubble3D val="0"/>
+            <c:spPr>
+              <a:solidFill>
+                <a:srgbClr val="6E6A85"/>
+              </a:solidFill>
+              <a:effectLst/>
+            </c:spPr>
+          </c:dPt>
+          <c:cat>
+            <c:multiLvlStrRef>
+              <c:f>Sheet1!$A$2:$A$6</c:f>
+              <c:multiLvlStrCache>
+                <c:ptCount val="5"/>
+                <c:lvl>
+                  <c:pt idx="0">
+                    <c:v>Real recording</c:v>
+                  </c:pt>
+                  <c:pt idx="1">
+                    <c:v>Baseline</c:v>
+                  </c:pt>
+                  <c:pt idx="2">
+                    <c:v>Colatron + GL</c:v>
+                  </c:pt>
+                  <c:pt idx="3">
+                    <c:v>Colatron + HiFi-GAN</c:v>
+                  </c:pt>
+                  <c:pt idx="4">
+                    <c:v>Tacotron 2 + HiFi-GAN</c:v>
+                  </c:pt>
+                </c:lvl>
+              </c:multiLvlStrCache>
+            </c:multiLvlStrRef>
+          </c:cat>
+          <c:val>
+            <c:numRef>
+              <c:f>Sheet1!$B$2:$B$6</c:f>
+              <c:numCache>
+                <c:formatCode>General</c:formatCode>
+                <c:ptCount val="5"/>
+                <c:pt idx="0">
+                  <c:v>5.050000000000001</c:v>
+                </c:pt>
+                <c:pt idx="1">
+                  <c:v>99.55000000000001</c:v>
+                </c:pt>
+                <c:pt idx="2">
+                  <c:v>28.610000000000003</c:v>
+                </c:pt>
+                <c:pt idx="3">
+                  <c:v>25.22</c:v>
+                </c:pt>
+                <c:pt idx="4">
+                  <c:v>16.18</c:v>
+                </c:pt>
+              </c:numCache>
+            </c:numRef>
+          </c:val>
+        </c:ser>
+        <c:dLbls>
+          <c:numFmt formatCode="0&quot;%&quot;" sourceLinked="0"/>
+          <c:txPr>
+            <a:bodyPr/>
+            <a:lstStyle/>
+            <a:p>
+              <a:pPr>
+                <a:defRPr b="0" i="0" strike="noStrike" sz="1200" u="none">
+                  <a:solidFill>
+                    <a:srgbClr val="1C1A2E"/>
+                  </a:solidFill>
+                  <a:latin typeface="+mn-lt"/>
+                </a:defRPr>
+              </a:pPr>
+            </a:p>
+          </c:txPr>
+          <c:showLegendKey val="0"/>
+          <c:showVal val="1"/>
+          <c:showCatName val="0"/>
+          <c:showSerName val="0"/>
+          <c:showPercent val="0"/>
+          <c:showBubbleSize val="0"/>
+          <c:showLeaderLines val="0"/>
+        </c:dLbls>
+        <c:gapWidth val="50"/>
+        <c:overlap val="0"/>
+        <c:axId val="2094734554"/>
+        <c:axId val="2094734552"/>
+        <c:axId val="2094734556"/>
+      </c:barChart>
+      <c:catAx>
+        <c:axId val="2094734554"/>
+        <c:scaling>
+          <c:orientation val="minMax"/>
+        </c:scaling>
+        <c:delete val="0"/>
+        <c:axPos val="b"/>
+        <c:numFmt formatCode="General" sourceLinked="1"/>
+        <c:majorTickMark val="out"/>
+        <c:minorTickMark val="none"/>
+        <c:tickLblPos val="low"/>
+        <c:spPr>
+          <a:ln w="12700" cap="flat">
+            <a:solidFill>
+              <a:srgbClr val="888888"/>
+            </a:solidFill>
+            <a:prstDash val="solid"/>
+            <a:round/>
+          </a:ln>
+        </c:spPr>
+        <c:txPr>
+          <a:bodyPr/>
+          <a:lstStyle/>
+          <a:p>
+            <a:pPr>
+              <a:defRPr sz="1100" b="0" i="0" u="none" strike="noStrike">
+                <a:solidFill>
+                  <a:srgbClr val="6E6A85"/>
+                </a:solidFill>
+                <a:latin typeface="+mn-lt"/>
+              </a:defRPr>
+            </a:pPr>
+            <a:endParaRPr lang="en-US"/>
+          </a:p>
+        </c:txPr>
+        <c:crossAx val="2094734552"/>
+        <c:crosses val="autoZero"/>
+        <c:auto val="1"/>
+        <c:lblAlgn val="ctr"/>
+        <c:noMultiLvlLbl val="1"/>
+      </c:catAx>
+      <c:valAx>
+        <c:axId val="2094734552"/>
+        <c:scaling>
+          <c:orientation val="minMax"/>
+          <c:max val="110"/>
+          <c:min val="0"/>
+        </c:scaling>
+        <c:delete val="0"/>
+        <c:axPos val="l"/>
+        <c:majorGridlines>
+          <c:spPr>
+            <a:ln w="9525" cap="flat">
+              <a:solidFill>
+                <a:srgbClr val="E6E3F0"/>
+              </a:solidFill>
+              <a:prstDash val="solid"/>
+              <a:round/>
+            </a:ln>
+          </c:spPr>
+        </c:majorGridlines>
+        <c:numFmt formatCode="General" sourceLinked="0"/>
+        <c:majorTickMark val="out"/>
+        <c:minorTickMark val="none"/>
+        <c:tickLblPos val="nextTo"/>
+        <c:spPr>
+          <a:ln w="12700" cap="flat">
+            <a:solidFill>
+              <a:srgbClr val="888888"/>
+            </a:solidFill>
+            <a:prstDash val="solid"/>
+            <a:round/>
+          </a:ln>
+        </c:spPr>
+        <c:txPr>
+          <a:bodyPr/>
+          <a:lstStyle/>
+          <a:p>
+            <a:pPr>
+              <a:defRPr sz="1100" b="0" i="0" u="none" strike="noStrike">
+                <a:solidFill>
+                  <a:srgbClr val="6E6A85"/>
+                </a:solidFill>
+                <a:latin typeface="+mn-lt"/>
+              </a:defRPr>
+            </a:pPr>
+            <a:endParaRPr lang="en-US"/>
+          </a:p>
+        </c:txPr>
+        <c:crossAx val="2094734554"/>
+        <c:crosses val="autoZero"/>
+        <c:crossBetween val="between"/>
+        <c:majorUnit val="25"/>
+      </c:valAx>
+      <c:spPr>
+        <a:noFill/>
+        <a:ln>
+          <a:noFill/>
+        </a:ln>
+        <a:effectLst/>
+      </c:spPr>
+    </c:plotArea>
+    <c:plotVisOnly val="1"/>
+    <c:dispBlanksAs val="span"/>
+  </c:chart>
+  <c:spPr>
+    <a:noFill/>
+    <a:ln>
+      <a:noFill/>
+    </a:ln>
+    <a:effectLst/>
+  </c:spPr>
+  <c:externalData r:id="rId1">
+    <c:autoUpdate val="0"/>
+  </c:externalData>
+</c:chartSpace>
+</file>
+
+<file path=ppt/charts/chart3.xml><?xml version="1.0" encoding="utf-8"?>
+<c:chartSpace xmlns:c="http://schemas.openxmlformats.org/drawingml/2006/chart" xmlns:a="http://schemas.openxmlformats.org/drawingml/2006/main" xmlns:r="http://schemas.openxmlformats.org/officeDocument/2006/relationships">
+  <c:date1904 val="0"/>
+  <c:roundedCorners val="1"/>
+  <c:chart>
+    <c:title>
+      <c:tx>
+        <c:rich>
+          <a:bodyPr/>
+          <a:lstStyle/>
+          <a:p>
+            <a:pPr>
+              <a:defRPr sz="1300" b="0" i="0" u="none" strike="noStrike">
+                <a:solidFill>
+                  <a:srgbClr val="1C1A2E"/>
+                </a:solidFill>
+                <a:latin typeface="+mn-lt"/>
+              </a:defRPr>
+            </a:pPr>
+            <a:r>
+              <a:rPr sz="1300" b="0" i="0" u="none" strike="noStrike">
+                <a:solidFill>
+                  <a:srgbClr val="1C1A2E"/>
+                </a:solidFill>
+                <a:latin typeface="+mn-lt"/>
+              </a:rPr>
+              <a:t>Mel L1 distance to the real recording (lower is better)</a:t>
+            </a:r>
+          </a:p>
+        </c:rich>
+      </c:tx>
+      <c:layout/>
+      <c:overlay val="0"/>
+    </c:title>
+    <c:autoTitleDeleted val="0"/>
+    <c:plotArea>
+      <c:layout/>
+      <c:barChart>
+        <c:barDir val="col"/>
+        <c:grouping val="clustered"/>
+        <c:varyColors val="0"/>
+        <c:ser>
+          <c:idx val="0"/>
+          <c:order val="0"/>
+          <c:tx>
+            <c:strRef>
+              <c:f>Sheet1!$B$1</c:f>
+              <c:strCache>
+                <c:ptCount val="1"/>
+                <c:pt idx="0">
+                  <c:v>Mel L1</c:v>
                 </c:pt>
               </c:strCache>
             </c:strRef>
@@ -567,17 +908,81 @@
             <c:showBubbleSize val="0"/>
             <c:showLeaderLines val="0"/>
           </c:dLbls>
+          <c:dPt>
+            <c:idx val="0"/>
+            <c:invertIfNegative val="0"/>
+            <c:bubble3D val="0"/>
+            <c:spPr>
+              <a:solidFill>
+                <a:srgbClr val="FF6B57"/>
+              </a:solidFill>
+              <a:effectLst/>
+            </c:spPr>
+          </c:dPt>
+          <c:dPt>
+            <c:idx val="1"/>
+            <c:invertIfNegative val="0"/>
+            <c:bubble3D val="0"/>
+            <c:spPr>
+              <a:solidFill>
+                <a:srgbClr val="5B3FD9"/>
+              </a:solidFill>
+              <a:effectLst/>
+            </c:spPr>
+          </c:dPt>
+          <c:dPt>
+            <c:idx val="2"/>
+            <c:invertIfNegative val="0"/>
+            <c:bubble3D val="0"/>
+            <c:spPr>
+              <a:solidFill>
+                <a:srgbClr val="5B3FD9"/>
+              </a:solidFill>
+              <a:effectLst/>
+            </c:spPr>
+          </c:dPt>
+          <c:dPt>
+            <c:idx val="3"/>
+            <c:invertIfNegative val="0"/>
+            <c:bubble3D val="0"/>
+            <c:spPr>
+              <a:solidFill>
+                <a:srgbClr val="6E6A85"/>
+              </a:solidFill>
+              <a:effectLst/>
+            </c:spPr>
+          </c:dPt>
+          <c:dPt>
+            <c:idx val="4"/>
+            <c:invertIfNegative val="0"/>
+            <c:bubble3D val="0"/>
+            <c:spPr>
+              <a:solidFill>
+                <a:srgbClr val="6E6A85"/>
+              </a:solidFill>
+              <a:effectLst/>
+            </c:spPr>
+          </c:dPt>
           <c:cat>
             <c:multiLvlStrRef>
-              <c:f>Sheet1!$A$2:$A$3</c:f>
+              <c:f>Sheet1!$A$2:$A$6</c:f>
               <c:multiLvlStrCache>
-                <c:ptCount val="2"/>
+                <c:ptCount val="5"/>
                 <c:lvl>
                   <c:pt idx="0">
-                    <c:v>Mel L1</c:v>
+                    <c:v>Baseline + GL</c:v>
                   </c:pt>
                   <c:pt idx="1">
-                    <c:v>Mel RMSE</c:v>
+                    <c:v>Colatron + GL</c:v>
+                  </c:pt>
+                  <c:pt idx="2">
+                    <c:v>Colatron + HiFi-GAN</c:v>
+                  </c:pt>
+                  <c:pt idx="3">
+                    <c:v>Tacotron 2 + GL</c:v>
+                  </c:pt>
+                  <c:pt idx="4">
+                    <c:v>Tacotron 2 + HiFi-GAN</c:v>
                   </c:pt>
                 </c:lvl>
               </c:multiLvlStrCache>
@@ -585,92 +990,24 @@
           </c:cat>
           <c:val>
             <c:numRef>
-              <c:f>Sheet1!$B$2:$B$3</c:f>
+              <c:f>Sheet1!$B$2:$B$6</c:f>
               <c:numCache>
                 <c:formatCode>General</c:formatCode>
-                <c:ptCount val="2"/>
+                <c:ptCount val="5"/>
                 <c:pt idx="0">
                   <c:v>1.218</c:v>
                 </c:pt>
                 <c:pt idx="1">
-                  <c:v>1.527</c:v>
+                  <c:v>0.8731</c:v>
                 </c:pt>
-              </c:numCache>
-            </c:numRef>
-          </c:val>
-        </c:ser>
-        <c:ser>
-          <c:idx val="1"/>
-          <c:order val="1"/>
-          <c:tx>
-            <c:strRef>
-              <c:f>Sheet1!$C$1</c:f>
-              <c:strCache>
-                <c:ptCount val="1"/>
-                <c:pt idx="0">
-                  <c:v>Tacotron 2 + HiFi-GAN</c:v>
+                <c:pt idx="2">
+                  <c:v>0.8866</c:v>
                 </c:pt>
-              </c:strCache>
-            </c:strRef>
-          </c:tx>
-          <c:spPr>
-            <a:solidFill>
-              <a:srgbClr val="5B3FD9"/>
-            </a:solidFill>
-            <a:effectLst/>
-          </c:spPr>
-          <c:invertIfNegative val="0"/>
-          <c:dLbls>
-            <c:numFmt formatCode="0.00" sourceLinked="0"/>
-            <c:txPr>
-              <a:bodyPr/>
-              <a:lstStyle/>
-              <a:p>
-                <a:pPr>
-                  <a:defRPr b="0" i="0" strike="noStrike" sz="1200" u="none">
-                    <a:solidFill>
-                      <a:srgbClr val="1C1A2E"/>
-                    </a:solidFill>
-                    <a:latin typeface="+mn-lt"/>
-                  </a:defRPr>
-                </a:pPr>
-              </a:p>
-            </c:txPr>
-            <c:showLegendKey val="0"/>
-            <c:showVal val="1"/>
-            <c:showCatName val="0"/>
-            <c:showSerName val="0"/>
-            <c:showPercent val="0"/>
-            <c:showBubbleSize val="0"/>
-            <c:showLeaderLines val="0"/>
-          </c:dLbls>
-          <c:cat>
-            <c:multiLvlStrRef>
-              <c:f>Sheet1!$A$2:$A$3</c:f>
-              <c:multiLvlStrCache>
-                <c:ptCount val="2"/>
-                <c:lvl>
-                  <c:pt idx="0">
-                    <c:v>Mel L1</c:v>
-                  </c:pt>
-                  <c:pt idx="1">
-                    <c:v>Mel RMSE</c:v>
-                  </c:pt>
-                </c:lvl>
-              </c:multiLvlStrCache>
-            </c:multiLvlStrRef>
-          </c:cat>
-          <c:val>
-            <c:numRef>
-              <c:f>Sheet1!$C$2:$C$3</c:f>
-              <c:numCache>
-                <c:formatCode>General</c:formatCode>
-                <c:ptCount val="2"/>
-                <c:pt idx="0">
-                  <c:v>0.889</c:v>
+                <c:pt idx="3">
+                  <c:v>0.8776</c:v>
                 </c:pt>
-                <c:pt idx="1">
-                  <c:v>1.192</c:v>
+                <c:pt idx="4">
+                  <c:v>0.9012</c:v>
                 </c:pt>
               </c:numCache>
             </c:numRef>
@@ -700,7 +1037,7 @@
           <c:showBubbleSize val="0"/>
           <c:showLeaderLines val="0"/>
         </c:dLbls>
-        <c:gapWidth val="60"/>
+        <c:gapWidth val="50"/>
         <c:overlap val="0"/>
         <c:axId val="2094734554"/>
         <c:axId val="2094734552"/>
@@ -731,7 +1068,7 @@
           <a:lstStyle/>
           <a:p>
             <a:pPr>
-              <a:defRPr sz="1300" b="0" i="0" u="none" strike="noStrike">
+              <a:defRPr sz="1100" b="0" i="0" u="none" strike="noStrike">
                 <a:solidFill>
                   <a:srgbClr val="6E6A85"/>
                 </a:solidFill>
@@ -751,7 +1088,7 @@
         <c:axId val="2094734552"/>
         <c:scaling>
           <c:orientation val="minMax"/>
-          <c:max val="1.8"/>
+          <c:max val="1.5"/>
           <c:min val="0"/>
         </c:scaling>
         <c:delete val="0"/>
@@ -808,26 +1145,6 @@
         <a:effectLst/>
       </c:spPr>
     </c:plotArea>
-    <c:legend>
-      <c:legendPos val="b"/>
-      <c:overlay val="0"/>
-      <c:txPr>
-        <a:bodyPr/>
-        <a:lstStyle/>
-        <a:p>
-          <a:pPr>
-            <a:defRPr sz="1200">
-              <a:solidFill>
-                <a:srgbClr val="1C1A2E"/>
-              </a:solidFill>
-              <a:latin typeface="+mn-lt"/>
-              <a:cs typeface="+mn-lt"/>
-            </a:defRPr>
-          </a:pPr>
-          <a:endParaRPr lang="en-US"/>
-        </a:p>
-      </c:txPr>
-    </c:legend>
     <c:plotVisOnly val="1"/>
     <c:dispBlanksAs val="span"/>
   </c:chart>
@@ -1239,7 +1556,7 @@
           <a:p>
             <a:r>
               <a:rPr lang="en-US" dirty="0"/>
-              <a:t>Introduce the team. Our problem statement (number 20) is Colatron, based on a 2018 Stanford CS229 project that tried end-to-end text to speech. We rebuild that pipeline properly and show, with numbers, that it works far better.</a:t>
+              <a:t>Introduce the team. Our problem statement (number 20) is Colatron, based on a 2018 Stanford CS229 project that tried end-to-end text to speech. We build our own seq2seq model with attention, train it from scratch, and show with numbers that it fixes the paper's failure.</a:t>
             </a:r>
             <a:endParaRPr lang="en-US" dirty="0"/>
           </a:p>
@@ -1327,7 +1644,7 @@
           <a:p>
             <a:r>
               <a:rPr lang="en-US" dirty="0"/>
-              <a:t>Bottom panel: each column is a moment of speech, the dark line shows which character the model is reading. It climbs steadily from first to last character. The flat steps are pauses at commas. Measured on three test sentences.</a:t>
+              <a:t>Play samples/colatron_griffinlim/05.wav then samples/colatron_hifigan/05.wav. Same Colatron mel, different vocoder.</a:t>
             </a:r>
             <a:endParaRPr lang="en-US" dirty="0"/>
           </a:p>
@@ -1415,7 +1732,7 @@
           <a:p>
             <a:r>
               <a:rPr lang="en-US" dirty="0"/>
-              <a:t>Mel distance compares each system's output with the real recording of the same sentence. DTW handles different speaking speeds. Mention the caveat yourselves before the panel does.</a:t>
+              <a:t>We have no listening test, so we use a speech recogniser as an objective listener. Word error rate is the share of words it gets wrong. Even real recordings are not 0% because the recogniser makes its own mistakes.</a:t>
             </a:r>
             <a:endParaRPr lang="en-US" dirty="0"/>
           </a:p>
@@ -1503,7 +1820,7 @@
           <a:p>
             <a:r>
               <a:rPr lang="en-US" dirty="0"/>
-              <a:t>Play samples/baseline/05.wav, then samples/main_hifigan/05.wav. The picture explains the sound: the baseline has no syllable structure at all. With equal time per character, its predictions never line up with real audio, so L1 training pushes it to the average spectrum. That is exactly why attention, or some learned timing, is needed.</a:t>
+              <a:t>Mel distance compares each system's output with the real recording of the same sentence, after DTW lines them up in time. Compare bars with the same vocoder: baseline vs Colatron with Griffin-Lim, Colatron vs Tacotron 2 with HiFi-GAN.</a:t>
             </a:r>
             <a:endParaRPr lang="en-US" dirty="0"/>
           </a:p>
@@ -1591,7 +1908,7 @@
           <a:p>
             <a:r>
               <a:rPr lang="en-US" dirty="0"/>
-              <a:t>Tie back to the paper: their conclusion was that they needed more data and deeper models. Our results confirm it from both sides.</a:t>
+              <a:t>Play samples/baseline/05.wav, samples/colatron_hifigan/05.wav, then samples/main_hifigan/05.wav. The picture explains the sound: attention is what turns the blur into speech-like structure.</a:t>
             </a:r>
             <a:endParaRPr lang="en-US" dirty="0"/>
           </a:p>
@@ -1679,7 +1996,7 @@
           <a:p>
             <a:r>
               <a:rPr lang="en-US" dirty="0"/>
-              <a:t>Start the app before the review so models are already loaded. Try one sentence from the panel. If anything fails, play the files in samples/.</a:t>
+              <a:t>Tie back to the paper: their conclusion was that they needed more data and a working attention. We built exactly that, trained it ourselves, and measured the result.</a:t>
             </a:r>
             <a:endParaRPr lang="en-US" dirty="0"/>
           </a:p>
@@ -1703,6 +2020,94 @@
             <a:fld id="{F7021451-1387-4CA6-816F-3879F97B5CBC}" type="slidenum">
               <a:rPr lang="en-US"/>
               <a:t>14</a:t>
+            </a:fld>
+            <a:endParaRPr lang="en-US"/>
+          </a:p>
+        </p:txBody>
+      </p:sp>
+    </p:spTree>
+    <p:extLst>
+      <p:ext uri="{BB962C8B-B14F-4D97-AF65-F5344CB8AC3E}">
+        <p14:creationId xmlns:p14="http://schemas.microsoft.com/office/powerpoint/2010/main" val="1024086991"/>
+      </p:ext>
+    </p:extLst>
+  </p:cSld>
+  <p:clrMapOvr>
+    <a:masterClrMapping/>
+  </p:clrMapOvr>
+</p:notes>
+</file>
+
+<file path=ppt/notesSlides/notesSlide15.xml><?xml version="1.0" encoding="utf-8"?>
+<p:notes xmlns:a="http://schemas.openxmlformats.org/drawingml/2006/main" xmlns:r="http://schemas.openxmlformats.org/officeDocument/2006/relationships" xmlns:p="http://schemas.openxmlformats.org/presentationml/2006/main">
+  <p:cSld>
+    <p:spTree>
+      <p:nvGrpSpPr>
+        <p:cNvPr id="1" name=""/>
+        <p:cNvGrpSpPr/>
+        <p:nvPr/>
+      </p:nvGrpSpPr>
+      <p:grpSpPr>
+        <a:xfrm>
+          <a:off x="0" y="0"/>
+          <a:ext cx="0" cy="0"/>
+          <a:chOff x="0" y="0"/>
+          <a:chExt cx="0" cy="0"/>
+        </a:xfrm>
+      </p:grpSpPr>
+      <p:sp>
+        <p:nvSpPr>
+          <p:cNvPr id="2" name="Slide Image Placeholder 1"/>
+          <p:cNvSpPr>
+            <a:spLocks noGrp="1" noRot="1" noChangeAspect="1"/>
+          </p:cNvSpPr>
+          <p:nvPr>
+            <p:ph type="sldImg"/>
+          </p:nvPr>
+        </p:nvSpPr>
+        <p:spPr/>
+      </p:sp>
+      <p:sp>
+        <p:nvSpPr>
+          <p:cNvPr id="3" name="Notes Placeholder 2"/>
+          <p:cNvSpPr>
+            <a:spLocks noGrp="1"/>
+          </p:cNvSpPr>
+          <p:nvPr>
+            <p:ph type="body" idx="1"/>
+          </p:nvPr>
+        </p:nvSpPr>
+        <p:spPr/>
+        <p:txBody>
+          <a:bodyPr/>
+          <a:lstStyle/>
+          <a:p>
+            <a:r>
+              <a:rPr lang="en-US" dirty="0"/>
+              <a:t>Start the app before the review so models are loaded. Type a sentence, play Colatron + HiFi-GAN and point at the diagonal. Then the baseline (static), then Tacotron 2 for reference. If anything fails, play the files in samples/.</a:t>
+            </a:r>
+            <a:endParaRPr lang="en-US" dirty="0"/>
+          </a:p>
+        </p:txBody>
+      </p:sp>
+      <p:sp>
+        <p:nvSpPr>
+          <p:cNvPr id="4" name="Slide Number Placeholder 3"/>
+          <p:cNvSpPr>
+            <a:spLocks noGrp="1"/>
+          </p:cNvSpPr>
+          <p:nvPr>
+            <p:ph type="sldNum" sz="quarter" idx="10"/>
+          </p:nvPr>
+        </p:nvSpPr>
+        <p:spPr/>
+        <p:txBody>
+          <a:bodyPr/>
+          <a:lstStyle/>
+          <a:p>
+            <a:fld id="{F7021451-1387-4CA6-816F-3879F97B5CBC}" type="slidenum">
+              <a:rPr lang="en-US"/>
+              <a:t>15</a:t>
             </a:fld>
             <a:endParaRPr lang="en-US"/>
           </a:p>
@@ -1855,7 +2260,7 @@
           <a:p>
             <a:r>
               <a:rPr lang="en-US" dirty="0"/>
-              <a:t>The paper itself lists these reasons. Each one maps to a specific change in our system.</a:t>
+              <a:t>The paper itself lists these reasons. Each one maps to a specific change in our own model, Colatron, which we trained from scratch.</a:t>
             </a:r>
             <a:endParaRPr lang="en-US" dirty="0"/>
           </a:p>
@@ -1943,7 +2348,7 @@
           <a:p>
             <a:r>
               <a:rPr lang="en-US" dirty="0"/>
-              <a:t>Two swappable stages. The acoustic model turns text into a mel spectrogram, a picture of the sound. The vocoder turns that picture into audio. Because both share one mel format, we can swap Tacotron 2 for our baseline, or Griffin-Lim for HiFi-GAN, and compare fairly.</a:t>
+              <a:t>Two swappable stages. The acoustic model turns text into a mel spectrogram, a picture of the sound. The vocoder turns that picture into audio. Our main acoustic model is Colatron, trained from scratch. The pretrained Tacotron 2 is only a reference point. Because everything shares one mel format, we can swap parts and compare fairly.</a:t>
             </a:r>
             <a:endParaRPr lang="en-US" dirty="0"/>
           </a:p>
@@ -2031,7 +2436,7 @@
           <a:p>
             <a:r>
               <a:rPr lang="en-US" dirty="0"/>
-              <a:t>Be upfront about this. The two heavy neural networks are pretrained. Everything else, including the only model we trained ourselves (the baseline), the vocoder comparison and all the evaluation, is our own work.</a:t>
+              <a:t>Be upfront. Our main model, Colatron, is ours and trained from scratch on a laptop CPU. The pretrained Tacotron 2 is only there to show what the same kind of model reaches with days of GPU training. HiFi-GAN turns mels into audio, and the speech recogniser is only used as a judge.</a:t>
             </a:r>
             <a:endParaRPr lang="en-US" dirty="0"/>
           </a:p>
@@ -2119,7 +2524,7 @@
           <a:p>
             <a:r>
               <a:rPr lang="en-US" dirty="0"/>
-              <a:t>The subset is picked by hashing file names, so everyone gets the same clips. The fixed vocabulary fixes the paper's random mapping. The mel settings match the pretrained models, so all systems speak the same format.</a:t>
+              <a:t>The paper used about 200 sentences; we use all 13,100. The test clips are the same 40 the baseline was evaluated on, and none of them is ever trained on. The baseline itself was trained on a 404-clip subset (324 train).</a:t>
             </a:r>
             <a:endParaRPr lang="en-US" dirty="0"/>
           </a:p>
@@ -2207,7 +2612,7 @@
           <a:p>
             <a:r>
               <a:rPr lang="en-US" dirty="0"/>
-              <a:t>This is the only model we train ourselves. The highlighted step is the key weakness: instead of learning which character to read when, it stretches the character features evenly over time.</a:t>
+              <a:t>This is our lower bound. The highlighted step is the key weakness: instead of learning which character to read when, it stretches the character features evenly over time. Its output is a blur and sounds like static.</a:t>
             </a:r>
             <a:endParaRPr lang="en-US" dirty="0"/>
           </a:p>
@@ -2295,7 +2700,7 @@
           <a:p>
             <a:r>
               <a:rPr lang="en-US" dirty="0"/>
-              <a:t>Tacotron 2 is the architecture the paper wanted but could not train: seq2seq with attention, done properly. We did not train it either; we use a pretrained checkpoint. Our work is wiring it into a shared mel format so vocoders are interchangeable and the attention can be inspected.</a:t>
+              <a:t>This is the model the 2018 paper tried to build: seq2seq with attention. Three things make it work on a laptop. Location-sensitive attention remembers where it looked, so it moves forward. Predicting several frames per step means fewer decoder steps. The guided attention loss (Tachibana et al., 2017) pushes the attention towards the diagonal from the start, which is exactly the paper's failure point.</a:t>
             </a:r>
             <a:endParaRPr lang="en-US" dirty="0"/>
           </a:p>
@@ -2383,7 +2788,7 @@
           <a:p>
             <a:r>
               <a:rPr lang="en-US" dirty="0"/>
-              <a:t>Play samples/main_griffinlim/05.wav then samples/main_hifigan/05.wav here. Same mel, different vocoder: Griffin-Lim guesses the missing phase and sounds metallic, HiFi-GAN learned to generate realistic waveforms.</a:t>
+              <a:t>Top: which character the model reads (up) at each decoder step (right). Early on it is already a rough diagonal, later it sharpens. Bottom: validation loss and the speech recogniser's word error rate as training goes on. Monotonic is measured on three sentences the model has never seen.</a:t>
             </a:r>
             <a:endParaRPr lang="en-US" dirty="0"/>
           </a:p>
@@ -4531,46 +4936,49 @@
                 <a:ea typeface="Arial" pitchFamily="34" charset="-122"/>
                 <a:cs typeface="Arial" pitchFamily="34" charset="-120"/>
               </a:rPr>
-              <a:t>Attention reads text in order</a:t>
+              <a:t>Vocoders: speed and quality</a:t>
             </a:r>
             <a:endParaRPr lang="en-US" sz="3000" dirty="0"/>
           </a:p>
         </p:txBody>
       </p:sp>
-      <p:pic>
-        <p:nvPicPr>
-          <p:cNvPr id="3" name="Alignment plot" descr="Tacotron 2 mel spectrogram and attention alignment for a 111-character sentence; the alignment forms a clean diagonal.">    </p:cNvPr>
-          <p:cNvPicPr>
-            <a:picLocks noChangeAspect="1"/>
-          </p:cNvPicPr>
-          <p:nvPr/>
-        </p:nvPicPr>
-        <p:blipFill>
-          <a:blip r:embed="rId1"/>
-          <a:stretch>
-            <a:fillRect/>
-          </a:stretch>
-        </p:blipFill>
-        <p:spPr>
-          <a:xfrm>
-            <a:off x="457200" y="1005840"/>
-            <a:ext cx="5120640" cy="3584448"/>
-          </a:xfrm>
-          <a:prstGeom prst="rect">
-            <a:avLst/>
-          </a:prstGeom>
-        </p:spPr>
-      </p:pic>
-      <p:sp>
-        <p:nvSpPr>
-          <p:cNvPr id="4" name="Monotonic value"/>
+      <p:sp>
+        <p:nvSpPr>
+          <p:cNvPr id="3" name="Vocoder card 1"/>
+          <p:cNvSpPr/>
+          <p:nvPr/>
+        </p:nvSpPr>
+        <p:spPr>
+          <a:xfrm>
+            <a:off x="457200" y="1097280"/>
+            <a:ext cx="4023360" cy="2880360"/>
+          </a:xfrm>
+          <a:prstGeom prst="roundRect">
+            <a:avLst>
+              <a:gd name="adj" fmla="val 2540"/>
+            </a:avLst>
+          </a:prstGeom>
+          <a:solidFill>
+            <a:schemeClr val="bg2"/>
+          </a:solidFill>
+          <a:ln w="12700">
+            <a:solidFill>
+              <a:schemeClr val="bg2"/>
+            </a:solidFill>
+            <a:prstDash val="solid"/>
+          </a:ln>
+        </p:spPr>
+      </p:sp>
+      <p:sp>
+        <p:nvSpPr>
+          <p:cNvPr id="4" name="Vocoder 1 name"/>
           <p:cNvSpPr txBox="1"/>
           <p:nvPr/>
         </p:nvSpPr>
         <p:spPr>
           <a:xfrm>
-            <a:off x="5852160" y="1097280"/>
-            <a:ext cx="2834640" cy="640080"/>
+            <a:off x="731520" y="1280160"/>
+            <a:ext cx="3474720" cy="365760"/>
           </a:xfrm>
           <a:prstGeom prst="rect">
             <a:avLst/>
@@ -4586,7 +4994,79 @@
               <a:buNone/>
             </a:pPr>
             <a:r>
-              <a:rPr lang="en-US" sz="4000" b="1" dirty="0">
+              <a:rPr lang="en-US" sz="2000" b="1" dirty="0">
+                <a:solidFill>
+                  <a:schemeClr val="tx1"/>
+                </a:solidFill>
+              </a:rPr>
+              <a:t>Griffin-Lim</a:t>
+            </a:r>
+            <a:endParaRPr lang="en-US" sz="2000" dirty="0"/>
+          </a:p>
+        </p:txBody>
+      </p:sp>
+      <p:sp>
+        <p:nvSpPr>
+          <p:cNvPr id="5" name="Vocoder 1 how"/>
+          <p:cNvSpPr txBox="1"/>
+          <p:nvPr/>
+        </p:nvSpPr>
+        <p:spPr>
+          <a:xfrm>
+            <a:off x="731520" y="1645920"/>
+            <a:ext cx="3474720" cy="320040"/>
+          </a:xfrm>
+          <a:prstGeom prst="rect">
+            <a:avLst/>
+          </a:prstGeom>
+          <a:noFill/>
+          <a:ln/>
+        </p:spPr>
+        <p:txBody>
+          <a:bodyPr wrap="square" lIns="0" tIns="0" rIns="0" bIns="0" rtlCol="0" anchor="ctr"/>
+          <a:lstStyle/>
+          <a:p>
+            <a:pPr indent="0" marL="0">
+              <a:buNone/>
+            </a:pPr>
+            <a:r>
+              <a:rPr lang="en-US" sz="1300" dirty="0">
+                <a:solidFill>
+                  <a:schemeClr val="accent6"/>
+                </a:solidFill>
+              </a:rPr>
+              <a:t>signal processing, no learning</a:t>
+            </a:r>
+            <a:endParaRPr lang="en-US" sz="1300" dirty="0"/>
+          </a:p>
+        </p:txBody>
+      </p:sp>
+      <p:sp>
+        <p:nvSpPr>
+          <p:cNvPr id="6" name="Vocoder 1 time"/>
+          <p:cNvSpPr txBox="1"/>
+          <p:nvPr/>
+        </p:nvSpPr>
+        <p:spPr>
+          <a:xfrm>
+            <a:off x="731520" y="2057400"/>
+            <a:ext cx="3474720" cy="731520"/>
+          </a:xfrm>
+          <a:prstGeom prst="rect">
+            <a:avLst/>
+          </a:prstGeom>
+          <a:noFill/>
+          <a:ln/>
+        </p:spPr>
+        <p:txBody>
+          <a:bodyPr wrap="square" lIns="0" tIns="0" rIns="0" bIns="0" rtlCol="0" anchor="ctr"/>
+          <a:lstStyle/>
+          <a:p>
+            <a:pPr indent="0" marL="0">
+              <a:buNone/>
+            </a:pPr>
+            <a:r>
+              <a:rPr lang="en-US" sz="4400" b="1" dirty="0">
                 <a:solidFill>
                   <a:schemeClr val="accent1"/>
                 </a:solidFill>
@@ -4594,22 +5074,22 @@
                 <a:ea typeface="Arial" pitchFamily="34" charset="-122"/>
                 <a:cs typeface="Arial" pitchFamily="34" charset="-120"/>
               </a:rPr>
-              <a:t>95–97%</a:t>
-            </a:r>
-            <a:endParaRPr lang="en-US" sz="4000" dirty="0"/>
-          </a:p>
-        </p:txBody>
-      </p:sp>
-      <p:sp>
-        <p:nvSpPr>
-          <p:cNvPr id="5" name="Monotonic label"/>
+              <a:t>0.08 s</a:t>
+            </a:r>
+            <a:endParaRPr lang="en-US" sz="4400" dirty="0"/>
+          </a:p>
+        </p:txBody>
+      </p:sp>
+      <p:sp>
+        <p:nvSpPr>
+          <p:cNvPr id="7" name="Vocoder 1 unit"/>
           <p:cNvSpPr txBox="1"/>
           <p:nvPr/>
         </p:nvSpPr>
         <p:spPr>
           <a:xfrm>
-            <a:off x="5852160" y="1737360"/>
-            <a:ext cx="2834640" cy="502920"/>
+            <a:off x="731520" y="2743200"/>
+            <a:ext cx="3474720" cy="274320"/>
           </a:xfrm>
           <a:prstGeom prst="rect">
             <a:avLst/>
@@ -4625,12 +5105,147 @@
               <a:buNone/>
             </a:pPr>
             <a:r>
+              <a:rPr lang="en-US" sz="1200" dirty="0">
+                <a:solidFill>
+                  <a:schemeClr val="accent6"/>
+                </a:solidFill>
+              </a:rPr>
+              <a:t>to make 3.3 s of speech</a:t>
+            </a:r>
+            <a:endParaRPr lang="en-US" sz="1200" dirty="0"/>
+          </a:p>
+        </p:txBody>
+      </p:sp>
+      <p:sp>
+        <p:nvSpPr>
+          <p:cNvPr id="8" name="Vocoder 1 verdict"/>
+          <p:cNvSpPr txBox="1"/>
+          <p:nvPr/>
+        </p:nvSpPr>
+        <p:spPr>
+          <a:xfrm>
+            <a:off x="731520" y="3154680"/>
+            <a:ext cx="3474720" cy="731520"/>
+          </a:xfrm>
+          <a:prstGeom prst="rect">
+            <a:avLst/>
+          </a:prstGeom>
+          <a:noFill/>
+          <a:ln/>
+        </p:spPr>
+        <p:txBody>
+          <a:bodyPr wrap="square" lIns="0" tIns="0" rIns="0" bIns="0" rtlCol="0" anchor="t"/>
+          <a:lstStyle/>
+          <a:p>
+            <a:pPr indent="0" marL="0">
+              <a:buNone/>
+            </a:pPr>
+            <a:r>
+              <a:rPr lang="en-US" sz="1400" dirty="0">
+                <a:solidFill>
+                  <a:schemeClr val="tx1"/>
+                </a:solidFill>
+              </a:rPr>
+              <a:t>Fast, but metallic: it has to guess the phase the mel throws away</a:t>
+            </a:r>
+            <a:endParaRPr lang="en-US" sz="1400" dirty="0"/>
+          </a:p>
+        </p:txBody>
+      </p:sp>
+      <p:sp>
+        <p:nvSpPr>
+          <p:cNvPr id="9" name="Vocoder card 2"/>
+          <p:cNvSpPr/>
+          <p:nvPr/>
+        </p:nvSpPr>
+        <p:spPr>
+          <a:xfrm>
+            <a:off x="4663440" y="1097280"/>
+            <a:ext cx="4023360" cy="2880360"/>
+          </a:xfrm>
+          <a:prstGeom prst="roundRect">
+            <a:avLst>
+              <a:gd name="adj" fmla="val 2540"/>
+            </a:avLst>
+          </a:prstGeom>
+          <a:solidFill>
+            <a:schemeClr val="bg2"/>
+          </a:solidFill>
+          <a:ln w="12700">
+            <a:solidFill>
+              <a:schemeClr val="bg2"/>
+            </a:solidFill>
+            <a:prstDash val="solid"/>
+          </a:ln>
+        </p:spPr>
+      </p:sp>
+      <p:sp>
+        <p:nvSpPr>
+          <p:cNvPr id="10" name="Vocoder 2 name"/>
+          <p:cNvSpPr txBox="1"/>
+          <p:nvPr/>
+        </p:nvSpPr>
+        <p:spPr>
+          <a:xfrm>
+            <a:off x="4937760" y="1280160"/>
+            <a:ext cx="3474720" cy="365760"/>
+          </a:xfrm>
+          <a:prstGeom prst="rect">
+            <a:avLst/>
+          </a:prstGeom>
+          <a:noFill/>
+          <a:ln/>
+        </p:spPr>
+        <p:txBody>
+          <a:bodyPr wrap="square" lIns="0" tIns="0" rIns="0" bIns="0" rtlCol="0" anchor="ctr"/>
+          <a:lstStyle/>
+          <a:p>
+            <a:pPr indent="0" marL="0">
+              <a:buNone/>
+            </a:pPr>
+            <a:r>
+              <a:rPr lang="en-US" sz="2000" b="1" dirty="0">
+                <a:solidFill>
+                  <a:schemeClr val="tx1"/>
+                </a:solidFill>
+              </a:rPr>
+              <a:t>HiFi-GAN</a:t>
+            </a:r>
+            <a:endParaRPr lang="en-US" sz="2000" dirty="0"/>
+          </a:p>
+        </p:txBody>
+      </p:sp>
+      <p:sp>
+        <p:nvSpPr>
+          <p:cNvPr id="11" name="Vocoder 2 how"/>
+          <p:cNvSpPr txBox="1"/>
+          <p:nvPr/>
+        </p:nvSpPr>
+        <p:spPr>
+          <a:xfrm>
+            <a:off x="4937760" y="1645920"/>
+            <a:ext cx="3474720" cy="320040"/>
+          </a:xfrm>
+          <a:prstGeom prst="rect">
+            <a:avLst/>
+          </a:prstGeom>
+          <a:noFill/>
+          <a:ln/>
+        </p:spPr>
+        <p:txBody>
+          <a:bodyPr wrap="square" lIns="0" tIns="0" rIns="0" bIns="0" rtlCol="0" anchor="ctr"/>
+          <a:lstStyle/>
+          <a:p>
+            <a:pPr indent="0" marL="0">
+              <a:buNone/>
+            </a:pPr>
+            <a:r>
               <a:rPr lang="en-US" sz="1300" dirty="0">
                 <a:solidFill>
                   <a:schemeClr val="accent6"/>
                 </a:solidFill>
               </a:rPr>
-              <a:t>of decoder steps never move backwards in the text</a:t>
+              <a:t>neural network (GAN), all frames in parallel</a:t>
             </a:r>
             <a:endParaRPr lang="en-US" sz="1300" dirty="0"/>
           </a:p>
@@ -4638,14 +5253,14 @@
       </p:sp>
       <p:sp>
         <p:nvSpPr>
-          <p:cNvPr id="6" name="Coverage value"/>
+          <p:cNvPr id="12" name="Vocoder 2 time"/>
           <p:cNvSpPr txBox="1"/>
           <p:nvPr/>
         </p:nvSpPr>
         <p:spPr>
           <a:xfrm>
-            <a:off x="5852160" y="2377440"/>
-            <a:ext cx="2834640" cy="640080"/>
+            <a:off x="4937760" y="2057400"/>
+            <a:ext cx="3474720" cy="731520"/>
           </a:xfrm>
           <a:prstGeom prst="rect">
             <a:avLst/>
@@ -4661,30 +5276,30 @@
               <a:buNone/>
             </a:pPr>
             <a:r>
-              <a:rPr lang="en-US" sz="4000" b="1" dirty="0">
-                <a:solidFill>
-                  <a:schemeClr val="accent1"/>
+              <a:rPr lang="en-US" sz="4400" b="1" dirty="0">
+                <a:solidFill>
+                  <a:schemeClr val="accent4"/>
                 </a:solidFill>
                 <a:latin typeface="Arial" pitchFamily="34" charset="0"/>
                 <a:ea typeface="Arial" pitchFamily="34" charset="-122"/>
                 <a:cs typeface="Arial" pitchFamily="34" charset="-120"/>
               </a:rPr>
-              <a:t>84–88%</a:t>
-            </a:r>
-            <a:endParaRPr lang="en-US" sz="4000" dirty="0"/>
-          </a:p>
-        </p:txBody>
-      </p:sp>
-      <p:sp>
-        <p:nvSpPr>
-          <p:cNvPr id="7" name="Coverage label"/>
+              <a:t>0.65 s</a:t>
+            </a:r>
+            <a:endParaRPr lang="en-US" sz="4400" dirty="0"/>
+          </a:p>
+        </p:txBody>
+      </p:sp>
+      <p:sp>
+        <p:nvSpPr>
+          <p:cNvPr id="13" name="Vocoder 2 unit"/>
           <p:cNvSpPr txBox="1"/>
           <p:nvPr/>
         </p:nvSpPr>
         <p:spPr>
           <a:xfrm>
-            <a:off x="5852160" y="3017520"/>
-            <a:ext cx="2834640" cy="594360"/>
+            <a:off x="4937760" y="2743200"/>
+            <a:ext cx="3474720" cy="274320"/>
           </a:xfrm>
           <a:prstGeom prst="rect">
             <a:avLst/>
@@ -4700,27 +5315,27 @@
               <a:buNone/>
             </a:pPr>
             <a:r>
-              <a:rPr lang="en-US" sz="1300" dirty="0">
+              <a:rPr lang="en-US" sz="1200" dirty="0">
                 <a:solidFill>
                   <a:schemeClr val="accent6"/>
                 </a:solidFill>
               </a:rPr>
-              <a:t>of characters become the main focus (spaces and punctuation are passed quickly)</a:t>
-            </a:r>
-            <a:endParaRPr lang="en-US" sz="1300" dirty="0"/>
-          </a:p>
-        </p:txBody>
-      </p:sp>
-      <p:sp>
-        <p:nvSpPr>
-          <p:cNvPr id="8" name="Attention takeaway"/>
+              <a:t>to make 3.3 s of speech</a:t>
+            </a:r>
+            <a:endParaRPr lang="en-US" sz="1200" dirty="0"/>
+          </a:p>
+        </p:txBody>
+      </p:sp>
+      <p:sp>
+        <p:nvSpPr>
+          <p:cNvPr id="14" name="Vocoder 2 verdict"/>
           <p:cNvSpPr txBox="1"/>
           <p:nvPr/>
         </p:nvSpPr>
         <p:spPr>
           <a:xfrm>
-            <a:off x="5852160" y="3749040"/>
-            <a:ext cx="2834640" cy="822960"/>
+            <a:off x="4937760" y="3154680"/>
+            <a:ext cx="3474720" cy="731520"/>
           </a:xfrm>
           <a:prstGeom prst="rect">
             <a:avLst/>
@@ -4736,14 +5351,50 @@
               <a:buNone/>
             </a:pPr>
             <a:r>
-              <a:rPr lang="en-US" sz="1400" b="1" dirty="0">
+              <a:rPr lang="en-US" sz="1400" dirty="0">
                 <a:solidFill>
                   <a:schemeClr val="tx1"/>
                 </a:solidFill>
               </a:rPr>
-              <a:t>A clean diagonal means no repeated or skipped words, which is exactly what the 2018 model got wrong.</a:t>
+              <a:t>Natural sounding, and still about 5× faster than real time</a:t>
             </a:r>
             <a:endParaRPr lang="en-US" sz="1400" dirty="0"/>
+          </a:p>
+        </p:txBody>
+      </p:sp>
+      <p:sp>
+        <p:nvSpPr>
+          <p:cNvPr id="15" name="Vocoder method"/>
+          <p:cNvSpPr txBox="1"/>
+          <p:nvPr/>
+        </p:nvSpPr>
+        <p:spPr>
+          <a:xfrm>
+            <a:off x="457200" y="4114800"/>
+            <a:ext cx="8229600" cy="548640"/>
+          </a:xfrm>
+          <a:prstGeom prst="rect">
+            <a:avLst/>
+          </a:prstGeom>
+          <a:noFill/>
+          <a:ln/>
+        </p:spPr>
+        <p:txBody>
+          <a:bodyPr wrap="square" lIns="0" tIns="0" rIns="0" bIns="0" rtlCol="0" anchor="ctr"/>
+          <a:lstStyle/>
+          <a:p>
+            <a:pPr indent="0" marL="0">
+              <a:buNone/>
+            </a:pPr>
+            <a:r>
+              <a:rPr lang="en-US" sz="1200" dirty="0">
+                <a:solidFill>
+                  <a:schemeClr val="accent6"/>
+                </a:solidFill>
+              </a:rPr>
+              <a:t>Same sentence on a laptop CPU, identical mel into both vocoders, so only the vocoder differs. Colatron's mels work with both, because all parts share one mel format.</a:t>
+            </a:r>
+            <a:endParaRPr lang="en-US" sz="1200" dirty="0"/>
           </a:p>
         </p:txBody>
       </p:sp>
@@ -4852,7 +5503,7 @@
                 <a:ea typeface="Arial" pitchFamily="34" charset="-122"/>
                 <a:cs typeface="Arial" pitchFamily="34" charset="-120"/>
               </a:rPr>
-              <a:t>Objective score: mel distance</a:t>
+              <a:t>Can a listener understand it?</a:t>
             </a:r>
             <a:endParaRPr lang="en-US" sz="3000" dirty="0"/>
           </a:p>
@@ -4860,13 +5511,13 @@
       </p:sp>
       <p:graphicFrame>
         <p:nvGraphicFramePr>
-          <p:cNvPr id="3" name="Mel distance chart" descr=""/>
+          <p:cNvPr id="3" name="Word error rate chart" descr=""/>
           <p:cNvGraphicFramePr/>
           <p:nvPr/>
         </p:nvGraphicFramePr>
         <p:xfrm>
           <a:off x="457200" y="1005840"/>
-          <a:ext cx="4937760" cy="3566160"/>
+          <a:ext cx="5120640" cy="3566160"/>
         </p:xfrm>
         <a:graphic xmlns:a="http://schemas.openxmlformats.org/drawingml/2006/main">
           <a:graphicData uri="http://schemas.openxmlformats.org/drawingml/2006/chart">
@@ -4876,14 +5527,14 @@
       </p:graphicFrame>
       <p:sp>
         <p:nvSpPr>
-          <p:cNvPr id="4" name="Improvement value"/>
+          <p:cNvPr id="4" name="Colatron WER value"/>
           <p:cNvSpPr txBox="1"/>
           <p:nvPr/>
         </p:nvSpPr>
         <p:spPr>
           <a:xfrm>
-            <a:off x="5669280" y="1097280"/>
-            <a:ext cx="3017520" cy="640080"/>
+            <a:off x="5852160" y="1097280"/>
+            <a:ext cx="2834640" cy="640080"/>
           </a:xfrm>
           <a:prstGeom prst="rect">
             <a:avLst/>
@@ -4899,7 +5550,7 @@
               <a:buNone/>
             </a:pPr>
             <a:r>
-              <a:rPr lang="en-US" sz="3600" b="1" dirty="0">
+              <a:rPr lang="en-US" sz="4000" b="1" dirty="0">
                 <a:solidFill>
                   <a:schemeClr val="accent1"/>
                 </a:solidFill>
@@ -4907,22 +5558,22 @@
                 <a:ea typeface="Arial" pitchFamily="34" charset="-122"/>
                 <a:cs typeface="Arial" pitchFamily="34" charset="-120"/>
               </a:rPr>
-              <a:t>27% lower</a:t>
-            </a:r>
-            <a:endParaRPr lang="en-US" sz="3600" dirty="0"/>
-          </a:p>
-        </p:txBody>
-      </p:sp>
-      <p:sp>
-        <p:nvSpPr>
-          <p:cNvPr id="5" name="Improvement label"/>
+              <a:t>25%</a:t>
+            </a:r>
+            <a:endParaRPr lang="en-US" sz="4000" dirty="0"/>
+          </a:p>
+        </p:txBody>
+      </p:sp>
+      <p:sp>
+        <p:nvSpPr>
+          <p:cNvPr id="5" name="Colatron WER label"/>
           <p:cNvSpPr txBox="1"/>
           <p:nvPr/>
         </p:nvSpPr>
         <p:spPr>
           <a:xfrm>
-            <a:off x="5669280" y="1691640"/>
-            <a:ext cx="3017520" cy="320040"/>
+            <a:off x="5852160" y="1737360"/>
+            <a:ext cx="2834640" cy="548640"/>
           </a:xfrm>
           <a:prstGeom prst="rect">
             <a:avLst/>
@@ -4943,7 +5594,7 @@
                   <a:schemeClr val="accent6"/>
                 </a:solidFill>
               </a:rPr>
-              <a:t>mel L1 distance than our baseline</a:t>
+              <a:t>word error rate for Colatron + HiFi-GAN, versus 100% for the baseline</a:t>
             </a:r>
             <a:endParaRPr lang="en-US" sz="1300" dirty="0"/>
           </a:p>
@@ -4951,14 +5602,14 @@
       </p:sp>
       <p:sp>
         <p:nvSpPr>
-          <p:cNvPr id="6" name="Method list"/>
+          <p:cNvPr id="6" name="WER method"/>
           <p:cNvSpPr txBox="1"/>
           <p:nvPr/>
         </p:nvSpPr>
         <p:spPr>
           <a:xfrm>
-            <a:off x="5669280" y="2194560"/>
-            <a:ext cx="3017520" cy="1280160"/>
+            <a:off x="5852160" y="2468880"/>
+            <a:ext cx="2834640" cy="2103120"/>
           </a:xfrm>
           <a:prstGeom prst="rect">
             <a:avLst/>
@@ -4978,14 +5629,14 @@
               <a:buChar char="•"/>
             </a:pPr>
             <a:r>
-              <a:rPr lang="en-US" sz="1300" dirty="0">
+              <a:rPr lang="en-US" sz="1200" dirty="0">
                 <a:solidFill>
                   <a:schemeClr val="tx1"/>
                 </a:solidFill>
               </a:rPr>
-              <a:t>20 held-out test clips</a:t>
-            </a:r>
-            <a:endParaRPr lang="en-US" sz="1300" dirty="0"/>
+              <a:t>wav2vec 2.0 recogniser (never trained on LJ Speech) transcribes each clip</a:t>
+            </a:r>
+            <a:endParaRPr lang="en-US" sz="1200" dirty="0"/>
           </a:p>
           <a:p>
             <a:pPr marL="342900" indent="-342900">
@@ -4996,14 +5647,14 @@
               <a:buChar char="•"/>
             </a:pPr>
             <a:r>
-              <a:rPr lang="en-US" sz="1300" dirty="0">
+              <a:rPr lang="en-US" sz="1200" dirty="0">
                 <a:solidFill>
                   <a:schemeClr val="tx1"/>
                 </a:solidFill>
               </a:rPr>
-              <a:t>Generated audio → mel with the same settings</a:t>
-            </a:r>
-            <a:endParaRPr lang="en-US" sz="1300" dirty="0"/>
+              <a:t>Compared word by word with the sentence we asked for</a:t>
+            </a:r>
+            <a:endParaRPr lang="en-US" sz="1200" dirty="0"/>
           </a:p>
           <a:p>
             <a:pPr marL="342900" indent="-342900">
@@ -5014,59 +5665,12 @@
               <a:buChar char="•"/>
             </a:pPr>
             <a:r>
-              <a:rPr lang="en-US" sz="1300" dirty="0">
+              <a:rPr lang="en-US" sz="1200" dirty="0">
                 <a:solidFill>
                   <a:schemeClr val="tx1"/>
                 </a:solidFill>
               </a:rPr>
-              <a:t>DTW lines up the two mels in time before comparing</a:t>
-            </a:r>
-            <a:endParaRPr lang="en-US" sz="1300" dirty="0"/>
-          </a:p>
-        </p:txBody>
-      </p:sp>
-      <p:sp>
-        <p:nvSpPr>
-          <p:cNvPr id="7" name="Caveat"/>
-          <p:cNvSpPr txBox="1"/>
-          <p:nvPr/>
-        </p:nvSpPr>
-        <p:spPr>
-          <a:xfrm>
-            <a:off x="5669280" y="3520440"/>
-            <a:ext cx="3017520" cy="1188720"/>
-          </a:xfrm>
-          <a:prstGeom prst="rect">
-            <a:avLst/>
-          </a:prstGeom>
-          <a:noFill/>
-          <a:ln/>
-        </p:spPr>
-        <p:txBody>
-          <a:bodyPr wrap="square" lIns="0" tIns="0" rIns="0" bIns="0" rtlCol="0" anchor="t"/>
-          <a:lstStyle/>
-          <a:p>
-            <a:pPr indent="0" marL="0">
-              <a:buNone/>
-            </a:pPr>
-            <a:r>
-              <a:rPr lang="en-US" sz="1200" b="1" dirty="0">
-                <a:solidFill>
-                  <a:schemeClr val="accent6"/>
-                </a:solidFill>
-              </a:rPr>
-              <a:t>Caveats: </a:t>
-            </a:r>
-            <a:pPr indent="0" marL="0">
-              <a:buNone/>
-            </a:pPr>
-            <a:r>
-              <a:rPr lang="en-US" sz="1200" dirty="0">
-                <a:solidFill>
-                  <a:schemeClr val="accent6"/>
-                </a:solidFill>
-              </a:rPr>
-              <a:t>our baseline used Griffin-Lim while the main system used HiFi-GAN, and Tacotron 2 may have seen these clips in pretraining. Both favour the main system.</a:t>
+              <a:t>20 held-out test clips; real recordings give the floor</a:t>
             </a:r>
             <a:endParaRPr lang="en-US" sz="1200" dirty="0"/>
           </a:p>
@@ -5177,46 +5781,113 @@
                 <a:ea typeface="Arial" pitchFamily="34" charset="-122"/>
                 <a:cs typeface="Arial" pitchFamily="34" charset="-120"/>
               </a:rPr>
-              <a:t>Why the baseline sounds like noise</a:t>
+              <a:t>Distance to the real recording</a:t>
             </a:r>
             <a:endParaRPr lang="en-US" sz="3000" dirty="0"/>
           </a:p>
         </p:txBody>
       </p:sp>
-      <p:pic>
-        <p:nvPicPr>
-          <p:cNvPr id="3" name="Baseline vs main mel plot" descr="Mel spectrograms of the same sentence: the baseline is a smooth blur with no syllables, while Tacotron 2 plus HiFi-GAN shows separate syllables, pauses and pitch harmonics.">    </p:cNvPr>
-          <p:cNvPicPr>
-            <a:picLocks noChangeAspect="1"/>
-          </p:cNvPicPr>
-          <p:nvPr/>
-        </p:nvPicPr>
-        <p:blipFill>
-          <a:blip r:embed="rId1"/>
-          <a:stretch>
-            <a:fillRect/>
-          </a:stretch>
-        </p:blipFill>
-        <p:spPr>
-          <a:xfrm>
-            <a:off x="457200" y="1097280"/>
-            <a:ext cx="5486400" cy="3072384"/>
-          </a:xfrm>
-          <a:prstGeom prst="rect">
-            <a:avLst/>
-          </a:prstGeom>
-        </p:spPr>
-      </p:pic>
-      <p:sp>
-        <p:nvSpPr>
-          <p:cNvPr id="4" name="Main reads"/>
+      <p:graphicFrame>
+        <p:nvGraphicFramePr>
+          <p:cNvPr id="3" name="Mel distance chart" descr=""/>
+          <p:cNvGraphicFramePr/>
+          <p:nvPr/>
+        </p:nvGraphicFramePr>
+        <p:xfrm>
+          <a:off x="457200" y="1005840"/>
+          <a:ext cx="5120640" cy="3566160"/>
+        </p:xfrm>
+        <a:graphic xmlns:a="http://schemas.openxmlformats.org/drawingml/2006/main">
+          <a:graphicData uri="http://schemas.openxmlformats.org/drawingml/2006/chart">
+            <c:chart xmlns:c="http://schemas.openxmlformats.org/drawingml/2006/chart" r:id="rId1"/>
+          </a:graphicData>
+        </a:graphic>
+      </p:graphicFrame>
+      <p:sp>
+        <p:nvSpPr>
+          <p:cNvPr id="4" name="Improvement value"/>
           <p:cNvSpPr txBox="1"/>
           <p:nvPr/>
         </p:nvSpPr>
         <p:spPr>
           <a:xfrm>
-            <a:off x="6035040" y="1051560"/>
-            <a:ext cx="2651760" cy="1188720"/>
+            <a:off x="5852160" y="1097280"/>
+            <a:ext cx="2834640" cy="640080"/>
+          </a:xfrm>
+          <a:prstGeom prst="rect">
+            <a:avLst/>
+          </a:prstGeom>
+          <a:noFill/>
+          <a:ln/>
+        </p:spPr>
+        <p:txBody>
+          <a:bodyPr wrap="square" lIns="0" tIns="0" rIns="0" bIns="0" rtlCol="0" anchor="ctr"/>
+          <a:lstStyle/>
+          <a:p>
+            <a:pPr indent="0" marL="0">
+              <a:buNone/>
+            </a:pPr>
+            <a:r>
+              <a:rPr lang="en-US" sz="3600" b="1" dirty="0">
+                <a:solidFill>
+                  <a:schemeClr val="accent1"/>
+                </a:solidFill>
+                <a:latin typeface="Arial" pitchFamily="34" charset="0"/>
+                <a:ea typeface="Arial" pitchFamily="34" charset="-122"/>
+                <a:cs typeface="Arial" pitchFamily="34" charset="-120"/>
+              </a:rPr>
+              <a:t>28% lower</a:t>
+            </a:r>
+            <a:endParaRPr lang="en-US" sz="3600" dirty="0"/>
+          </a:p>
+        </p:txBody>
+      </p:sp>
+      <p:sp>
+        <p:nvSpPr>
+          <p:cNvPr id="5" name="Improvement label"/>
+          <p:cNvSpPr txBox="1"/>
+          <p:nvPr/>
+        </p:nvSpPr>
+        <p:spPr>
+          <a:xfrm>
+            <a:off x="5852160" y="1691640"/>
+            <a:ext cx="2834640" cy="594360"/>
+          </a:xfrm>
+          <a:prstGeom prst="rect">
+            <a:avLst/>
+          </a:prstGeom>
+          <a:noFill/>
+          <a:ln/>
+        </p:spPr>
+        <p:txBody>
+          <a:bodyPr wrap="square" lIns="0" tIns="0" rIns="0" bIns="0" rtlCol="0" anchor="ctr"/>
+          <a:lstStyle/>
+          <a:p>
+            <a:pPr indent="0" marL="0">
+              <a:buNone/>
+            </a:pPr>
+            <a:r>
+              <a:rPr lang="en-US" sz="1300" dirty="0">
+                <a:solidFill>
+                  <a:schemeClr val="accent6"/>
+                </a:solidFill>
+              </a:rPr>
+              <a:t>Colatron vs baseline, both through Griffin-Lim (a fair, same-vocoder comparison)</a:t>
+            </a:r>
+            <a:endParaRPr lang="en-US" sz="1300" dirty="0"/>
+          </a:p>
+        </p:txBody>
+      </p:sp>
+      <p:sp>
+        <p:nvSpPr>
+          <p:cNvPr id="6" name="Method list"/>
+          <p:cNvSpPr txBox="1"/>
+          <p:nvPr/>
+        </p:nvSpPr>
+        <p:spPr>
+          <a:xfrm>
+            <a:off x="5852160" y="2423160"/>
+            <a:ext cx="2834640" cy="1097280"/>
           </a:xfrm>
           <a:prstGeom prst="rect">
             <a:avLst/>
@@ -5228,118 +5899,105 @@
           <a:bodyPr wrap="square" lIns="0" tIns="0" rIns="0" bIns="0" rtlCol="0" anchor="t"/>
           <a:lstStyle/>
           <a:p>
+            <a:pPr marL="342900" indent="-342900">
+              <a:spcAft>
+                <a:spcPts val="400"/>
+              </a:spcAft>
+              <a:buSzPct val="100000"/>
+              <a:buChar char="•"/>
+            </a:pPr>
+            <a:r>
+              <a:rPr lang="en-US" sz="1200" dirty="0">
+                <a:solidFill>
+                  <a:schemeClr val="tx1"/>
+                </a:solidFill>
+              </a:rPr>
+              <a:t>Same 20 held-out test clips</a:t>
+            </a:r>
+            <a:endParaRPr lang="en-US" sz="1200" dirty="0"/>
+          </a:p>
+          <a:p>
+            <a:pPr marL="342900" indent="-342900">
+              <a:spcAft>
+                <a:spcPts val="400"/>
+              </a:spcAft>
+              <a:buSzPct val="100000"/>
+              <a:buChar char="•"/>
+            </a:pPr>
+            <a:r>
+              <a:rPr lang="en-US" sz="1200" dirty="0">
+                <a:solidFill>
+                  <a:schemeClr val="tx1"/>
+                </a:solidFill>
+              </a:rPr>
+              <a:t>Generated audio → mel with the same settings</a:t>
+            </a:r>
+            <a:endParaRPr lang="en-US" sz="1200" dirty="0"/>
+          </a:p>
+          <a:p>
+            <a:pPr marL="342900" indent="-342900">
+              <a:spcAft>
+                <a:spcPts val="400"/>
+              </a:spcAft>
+              <a:buSzPct val="100000"/>
+              <a:buChar char="•"/>
+            </a:pPr>
+            <a:r>
+              <a:rPr lang="en-US" sz="1200" dirty="0">
+                <a:solidFill>
+                  <a:schemeClr val="tx1"/>
+                </a:solidFill>
+              </a:rPr>
+              <a:t>DTW lines up the two mels in time before comparing</a:t>
+            </a:r>
+            <a:endParaRPr lang="en-US" sz="1200" dirty="0"/>
+          </a:p>
+        </p:txBody>
+      </p:sp>
+      <p:sp>
+        <p:nvSpPr>
+          <p:cNvPr id="7" name="Caveat"/>
+          <p:cNvSpPr txBox="1"/>
+          <p:nvPr/>
+        </p:nvSpPr>
+        <p:spPr>
+          <a:xfrm>
+            <a:off x="5852160" y="3611880"/>
+            <a:ext cx="2834640" cy="914400"/>
+          </a:xfrm>
+          <a:prstGeom prst="rect">
+            <a:avLst/>
+          </a:prstGeom>
+          <a:noFill/>
+          <a:ln/>
+        </p:spPr>
+        <p:txBody>
+          <a:bodyPr wrap="square" lIns="0" tIns="0" rIns="0" bIns="0" rtlCol="0" anchor="t"/>
+          <a:lstStyle/>
+          <a:p>
             <a:pPr indent="0" marL="0">
               <a:buNone/>
             </a:pPr>
             <a:r>
-              <a:rPr lang="en-US" sz="1300" b="1" dirty="0">
-                <a:solidFill>
-                  <a:schemeClr val="accent1"/>
-                </a:solidFill>
-              </a:rPr>
-              <a:t>Tacotron 2</a:t>
-            </a:r>
-            <a:endParaRPr lang="en-US" sz="1300" dirty="0"/>
-          </a:p>
-          <a:p>
+              <a:rPr lang="en-US" sz="1200" b="1" dirty="0">
+                <a:solidFill>
+                  <a:schemeClr val="accent6"/>
+                </a:solidFill>
+              </a:rPr>
+              <a:t>Caveat: </a:t>
+            </a:r>
             <a:pPr indent="0" marL="0">
               <a:buNone/>
             </a:pPr>
             <a:r>
-              <a:rPr lang="en-US" sz="1300" dirty="0">
-                <a:solidFill>
-                  <a:schemeClr val="tx1"/>
-                </a:solidFill>
-              </a:rPr>
-              <a:t>Separate syllables, pauses between words, pitch stripes, and the hiss of each "s" and "sh".</a:t>
-            </a:r>
-            <a:endParaRPr lang="en-US" sz="1300" dirty="0"/>
-          </a:p>
-        </p:txBody>
-      </p:sp>
-      <p:sp>
-        <p:nvSpPr>
-          <p:cNvPr id="5" name="Baseline reads"/>
-          <p:cNvSpPr txBox="1"/>
-          <p:nvPr/>
-        </p:nvSpPr>
-        <p:spPr>
-          <a:xfrm>
-            <a:off x="6035040" y="2286000"/>
-            <a:ext cx="2651760" cy="1188720"/>
-          </a:xfrm>
-          <a:prstGeom prst="rect">
-            <a:avLst/>
-          </a:prstGeom>
-          <a:noFill/>
-          <a:ln/>
-        </p:spPr>
-        <p:txBody>
-          <a:bodyPr wrap="square" lIns="0" tIns="0" rIns="0" bIns="0" rtlCol="0" anchor="t"/>
-          <a:lstStyle/>
-          <a:p>
-            <a:pPr indent="0" marL="0">
-              <a:buNone/>
-            </a:pPr>
-            <a:r>
-              <a:rPr lang="en-US" sz="1300" b="1" dirty="0">
-                <a:solidFill>
-                  <a:schemeClr val="accent2"/>
-                </a:solidFill>
-              </a:rPr>
-              <a:t>Our baseline</a:t>
-            </a:r>
-            <a:endParaRPr lang="en-US" sz="1300" dirty="0"/>
-          </a:p>
-          <a:p>
-            <a:pPr indent="0" marL="0">
-              <a:buNone/>
-            </a:pPr>
-            <a:r>
-              <a:rPr lang="en-US" sz="1300" dirty="0">
-                <a:solidFill>
-                  <a:schemeClr val="tx1"/>
-                </a:solidFill>
-              </a:rPr>
-              <a:t>One smooth blur. It cannot learn when each sound happens, so it predicts the average spectrum.</a:t>
-            </a:r>
-            <a:endParaRPr lang="en-US" sz="1300" dirty="0"/>
-          </a:p>
-        </p:txBody>
-      </p:sp>
-      <p:sp>
-        <p:nvSpPr>
-          <p:cNvPr id="6" name="Compare takeaway"/>
-          <p:cNvSpPr txBox="1"/>
-          <p:nvPr/>
-        </p:nvSpPr>
-        <p:spPr>
-          <a:xfrm>
-            <a:off x="6035040" y="3520440"/>
-            <a:ext cx="2651760" cy="1051560"/>
-          </a:xfrm>
-          <a:prstGeom prst="rect">
-            <a:avLst/>
-          </a:prstGeom>
-          <a:noFill/>
-          <a:ln/>
-        </p:spPr>
-        <p:txBody>
-          <a:bodyPr wrap="square" lIns="0" tIns="0" rIns="0" bIns="0" rtlCol="0" anchor="t"/>
-          <a:lstStyle/>
-          <a:p>
-            <a:pPr indent="0" marL="0">
-              <a:buNone/>
-            </a:pPr>
-            <a:r>
-              <a:rPr lang="en-US" sz="1300" b="1" dirty="0">
-                <a:solidFill>
-                  <a:schemeClr val="tx1"/>
-                </a:solidFill>
-              </a:rPr>
-              <a:t>Without learned timing (attention), the model collapses to the mean: the 2018 paper's failure, reproduced.</a:t>
-            </a:r>
-            <a:endParaRPr lang="en-US" sz="1300" dirty="0"/>
+              <a:rPr lang="en-US" sz="1200" dirty="0">
+                <a:solidFill>
+                  <a:schemeClr val="accent6"/>
+                </a:solidFill>
+              </a:rPr>
+              <a:t>Tacotron 2 was pretrained on all of LJ Speech, so it may have seen these clips. Colatron never did.</a:t>
+            </a:r>
+            <a:endParaRPr lang="en-US" sz="1200" dirty="0"/>
           </a:p>
         </p:txBody>
       </p:sp>
@@ -5448,119 +6106,146 @@
                 <a:ea typeface="Arial" pitchFamily="34" charset="-122"/>
                 <a:cs typeface="Arial" pitchFamily="34" charset="-120"/>
               </a:rPr>
-              <a:t>Conclusions</a:t>
+              <a:t>What the three models produce</a:t>
             </a:r>
             <a:endParaRPr lang="en-US" sz="3000" dirty="0"/>
           </a:p>
         </p:txBody>
       </p:sp>
-      <p:sp>
-        <p:nvSpPr>
-          <p:cNvPr id="3" name="Conclusion 1 circle"/>
-          <p:cNvSpPr/>
-          <p:nvPr/>
-        </p:nvSpPr>
-        <p:spPr>
-          <a:xfrm>
-            <a:off x="457200" y="1097280"/>
-            <a:ext cx="384048" cy="384048"/>
-          </a:xfrm>
-          <a:prstGeom prst="ellipse">
-            <a:avLst/>
-          </a:prstGeom>
-          <a:solidFill>
-            <a:schemeClr val="accent1"/>
-          </a:solidFill>
-          <a:ln w="12700">
-            <a:solidFill>
-              <a:schemeClr val="accent1"/>
-            </a:solidFill>
-            <a:prstDash val="solid"/>
-          </a:ln>
-        </p:spPr>
-      </p:sp>
-      <p:sp>
-        <p:nvSpPr>
-          <p:cNvPr id="4" name="Conclusion 1 label"/>
+      <p:pic>
+        <p:nvPicPr>
+          <p:cNvPr id="3" name="Three system mel plot" descr="Mel spectrograms of the same sentence from the baseline, Colatron and Tacotron 2.">    </p:cNvPr>
+          <p:cNvPicPr>
+            <a:picLocks noChangeAspect="1"/>
+          </p:cNvPicPr>
+          <p:nvPr/>
+        </p:nvPicPr>
+        <p:blipFill>
+          <a:blip r:embed="rId1"/>
+          <a:stretch>
+            <a:fillRect/>
+          </a:stretch>
+        </p:blipFill>
+        <p:spPr>
+          <a:xfrm>
+            <a:off x="457200" y="1005840"/>
+            <a:ext cx="5120640" cy="3584448"/>
+          </a:xfrm>
+          <a:prstGeom prst="rect">
+            <a:avLst/>
+          </a:prstGeom>
+        </p:spPr>
+      </p:pic>
+      <p:sp>
+        <p:nvSpPr>
+          <p:cNvPr id="4" name="Baseline reads"/>
           <p:cNvSpPr txBox="1"/>
           <p:nvPr/>
         </p:nvSpPr>
         <p:spPr>
           <a:xfrm>
-            <a:off x="457200" y="1097280"/>
-            <a:ext cx="384048" cy="384048"/>
-          </a:xfrm>
-          <a:prstGeom prst="rect">
-            <a:avLst/>
-          </a:prstGeom>
-          <a:noFill/>
-          <a:ln/>
-        </p:spPr>
-        <p:txBody>
-          <a:bodyPr wrap="square" lIns="0" tIns="0" rIns="0" bIns="0" rtlCol="0" anchor="ctr"/>
-          <a:lstStyle/>
-          <a:p>
-            <a:pPr algn="ctr" indent="0" marL="0">
-              <a:buNone/>
-            </a:pPr>
-            <a:r>
-              <a:rPr lang="en-US" sz="1400" b="1" dirty="0">
-                <a:solidFill>
-                  <a:schemeClr val="bg1"/>
-                </a:solidFill>
-              </a:rPr>
-              <a:t>1</a:t>
-            </a:r>
-            <a:endParaRPr lang="en-US" sz="1400" dirty="0"/>
-          </a:p>
-        </p:txBody>
-      </p:sp>
-      <p:sp>
-        <p:nvSpPr>
-          <p:cNvPr id="5" name="Conclusion 1 head"/>
+            <a:off x="5852160" y="1051560"/>
+            <a:ext cx="2834640" cy="960120"/>
+          </a:xfrm>
+          <a:prstGeom prst="rect">
+            <a:avLst/>
+          </a:prstGeom>
+          <a:noFill/>
+          <a:ln/>
+        </p:spPr>
+        <p:txBody>
+          <a:bodyPr wrap="square" lIns="0" tIns="0" rIns="0" bIns="0" rtlCol="0" anchor="t"/>
+          <a:lstStyle/>
+          <a:p>
+            <a:pPr indent="0" marL="0">
+              <a:buNone/>
+            </a:pPr>
+            <a:r>
+              <a:rPr lang="en-US" sz="1300" b="1" dirty="0">
+                <a:solidFill>
+                  <a:schemeClr val="accent2"/>
+                </a:solidFill>
+              </a:rPr>
+              <a:t>Baseline</a:t>
+            </a:r>
+            <a:endParaRPr lang="en-US" sz="1300" dirty="0"/>
+          </a:p>
+          <a:p>
+            <a:pPr indent="0" marL="0">
+              <a:buNone/>
+            </a:pPr>
+            <a:r>
+              <a:rPr lang="en-US" sz="1300" dirty="0">
+                <a:solidFill>
+                  <a:schemeClr val="tx1"/>
+                </a:solidFill>
+              </a:rPr>
+              <a:t>One smooth blur: without timing it predicts the average sound.</a:t>
+            </a:r>
+            <a:endParaRPr lang="en-US" sz="1300" dirty="0"/>
+          </a:p>
+        </p:txBody>
+      </p:sp>
+      <p:sp>
+        <p:nvSpPr>
+          <p:cNvPr id="5" name="Colatron reads"/>
           <p:cNvSpPr txBox="1"/>
           <p:nvPr/>
         </p:nvSpPr>
         <p:spPr>
           <a:xfrm>
-            <a:off x="1005840" y="1051560"/>
-            <a:ext cx="4572000" cy="301752"/>
-          </a:xfrm>
-          <a:prstGeom prst="rect">
-            <a:avLst/>
-          </a:prstGeom>
-          <a:noFill/>
-          <a:ln/>
-        </p:spPr>
-        <p:txBody>
-          <a:bodyPr wrap="square" lIns="0" tIns="0" rIns="0" bIns="0" rtlCol="0" anchor="ctr"/>
+            <a:off x="5852160" y="2057400"/>
+            <a:ext cx="2834640" cy="960120"/>
+          </a:xfrm>
+          <a:prstGeom prst="rect">
+            <a:avLst/>
+          </a:prstGeom>
+          <a:noFill/>
+          <a:ln/>
+        </p:spPr>
+        <p:txBody>
+          <a:bodyPr wrap="square" lIns="0" tIns="0" rIns="0" bIns="0" rtlCol="0" anchor="t"/>
           <a:lstStyle/>
           <a:p>
             <a:pPr indent="0" marL="0">
               <a:buNone/>
             </a:pPr>
             <a:r>
-              <a:rPr lang="en-US" sz="1500" b="1" dirty="0">
+              <a:rPr lang="en-US" sz="1300" b="1" dirty="0">
+                <a:solidFill>
+                  <a:schemeClr val="accent1"/>
+                </a:solidFill>
+              </a:rPr>
+              <a:t>Colatron (ours)</a:t>
+            </a:r>
+            <a:endParaRPr lang="en-US" sz="1300" dirty="0"/>
+          </a:p>
+          <a:p>
+            <a:pPr indent="0" marL="0">
+              <a:buNone/>
+            </a:pPr>
+            <a:r>
+              <a:rPr lang="en-US" sz="1300" dirty="0">
                 <a:solidFill>
                   <a:schemeClr val="tx1"/>
                 </a:solidFill>
               </a:rPr>
-              <a:t>Data and depth matter most</a:t>
-            </a:r>
-            <a:endParaRPr lang="en-US" sz="1500" dirty="0"/>
-          </a:p>
-        </p:txBody>
-      </p:sp>
-      <p:sp>
-        <p:nvSpPr>
-          <p:cNvPr id="6" name="Conclusion 1 body"/>
+              <a:t>Syllables, pauses and pitch stripes appear: attention gives it timing.</a:t>
+            </a:r>
+            <a:endParaRPr lang="en-US" sz="1300" dirty="0"/>
+          </a:p>
+        </p:txBody>
+      </p:sp>
+      <p:sp>
+        <p:nvSpPr>
+          <p:cNvPr id="6" name="Tacotron reads"/>
           <p:cNvSpPr txBox="1"/>
           <p:nvPr/>
         </p:nvSpPr>
         <p:spPr>
           <a:xfrm>
-            <a:off x="1005840" y="1353312"/>
-            <a:ext cx="4572000" cy="384048"/>
+            <a:off x="5852160" y="3063240"/>
+            <a:ext cx="2834640" cy="960120"/>
           </a:xfrm>
           <a:prstGeom prst="rect">
             <a:avLst/>
@@ -5576,600 +6261,26 @@
               <a:buNone/>
             </a:pPr>
             <a:r>
-              <a:rPr lang="en-US" sz="1200" dirty="0">
+              <a:rPr lang="en-US" sz="1300" b="1" dirty="0">
                 <a:solidFill>
                   <a:schemeClr val="accent6"/>
                 </a:solidFill>
               </a:rPr>
-              <a:t>Our from-scratch baseline (324 training clips) has a 37% higher mel distance to real speech than Tacotron 2.</a:t>
-            </a:r>
-            <a:endParaRPr lang="en-US" sz="1200" dirty="0"/>
-          </a:p>
-        </p:txBody>
-      </p:sp>
-      <p:sp>
-        <p:nvSpPr>
-          <p:cNvPr id="7" name="Conclusion 2 circle"/>
-          <p:cNvSpPr/>
-          <p:nvPr/>
-        </p:nvSpPr>
-        <p:spPr>
-          <a:xfrm>
-            <a:off x="457200" y="1810512"/>
-            <a:ext cx="384048" cy="384048"/>
-          </a:xfrm>
-          <a:prstGeom prst="ellipse">
-            <a:avLst/>
-          </a:prstGeom>
-          <a:solidFill>
-            <a:schemeClr val="accent1"/>
-          </a:solidFill>
-          <a:ln w="12700">
-            <a:solidFill>
-              <a:schemeClr val="accent1"/>
-            </a:solidFill>
-            <a:prstDash val="solid"/>
-          </a:ln>
-        </p:spPr>
-      </p:sp>
-      <p:sp>
-        <p:nvSpPr>
-          <p:cNvPr id="8" name="Conclusion 2 label"/>
-          <p:cNvSpPr txBox="1"/>
-          <p:nvPr/>
-        </p:nvSpPr>
-        <p:spPr>
-          <a:xfrm>
-            <a:off x="457200" y="1810512"/>
-            <a:ext cx="384048" cy="384048"/>
-          </a:xfrm>
-          <a:prstGeom prst="rect">
-            <a:avLst/>
-          </a:prstGeom>
-          <a:noFill/>
-          <a:ln/>
-        </p:spPr>
-        <p:txBody>
-          <a:bodyPr wrap="square" lIns="0" tIns="0" rIns="0" bIns="0" rtlCol="0" anchor="ctr"/>
-          <a:lstStyle/>
-          <a:p>
-            <a:pPr algn="ctr" indent="0" marL="0">
-              <a:buNone/>
-            </a:pPr>
-            <a:r>
-              <a:rPr lang="en-US" sz="1400" b="1" dirty="0">
-                <a:solidFill>
-                  <a:schemeClr val="bg1"/>
-                </a:solidFill>
-              </a:rPr>
-              <a:t>2</a:t>
-            </a:r>
-            <a:endParaRPr lang="en-US" sz="1400" dirty="0"/>
-          </a:p>
-        </p:txBody>
-      </p:sp>
-      <p:sp>
-        <p:nvSpPr>
-          <p:cNvPr id="9" name="Conclusion 2 head"/>
-          <p:cNvSpPr txBox="1"/>
-          <p:nvPr/>
-        </p:nvSpPr>
-        <p:spPr>
-          <a:xfrm>
-            <a:off x="1005840" y="1764792"/>
-            <a:ext cx="4572000" cy="301752"/>
-          </a:xfrm>
-          <a:prstGeom prst="rect">
-            <a:avLst/>
-          </a:prstGeom>
-          <a:noFill/>
-          <a:ln/>
-        </p:spPr>
-        <p:txBody>
-          <a:bodyPr wrap="square" lIns="0" tIns="0" rIns="0" bIns="0" rtlCol="0" anchor="ctr"/>
-          <a:lstStyle/>
+              <a:t>Tacotron 2 (reference)</a:t>
+            </a:r>
+            <a:endParaRPr lang="en-US" sz="1300" dirty="0"/>
+          </a:p>
           <a:p>
             <a:pPr indent="0" marL="0">
               <a:buNone/>
             </a:pPr>
             <a:r>
-              <a:rPr lang="en-US" sz="1500" b="1" dirty="0">
+              <a:rPr lang="en-US" sz="1300" dirty="0">
                 <a:solidFill>
                   <a:schemeClr val="tx1"/>
                 </a:solidFill>
               </a:rPr>
-              <a:t>Alignment is the key</a:t>
-            </a:r>
-            <a:endParaRPr lang="en-US" sz="1500" dirty="0"/>
-          </a:p>
-        </p:txBody>
-      </p:sp>
-      <p:sp>
-        <p:nvSpPr>
-          <p:cNvPr id="10" name="Conclusion 2 body"/>
-          <p:cNvSpPr txBox="1"/>
-          <p:nvPr/>
-        </p:nvSpPr>
-        <p:spPr>
-          <a:xfrm>
-            <a:off x="1005840" y="2066544"/>
-            <a:ext cx="4572000" cy="384048"/>
-          </a:xfrm>
-          <a:prstGeom prst="rect">
-            <a:avLst/>
-          </a:prstGeom>
-          <a:noFill/>
-          <a:ln/>
-        </p:spPr>
-        <p:txBody>
-          <a:bodyPr wrap="square" lIns="0" tIns="0" rIns="0" bIns="0" rtlCol="0" anchor="t"/>
-          <a:lstStyle/>
-          <a:p>
-            <a:pPr indent="0" marL="0">
-              <a:buNone/>
-            </a:pPr>
-            <a:r>
-              <a:rPr lang="en-US" sz="1200" dirty="0">
-                <a:solidFill>
-                  <a:schemeClr val="accent6"/>
-                </a:solidFill>
-              </a:rPr>
-              <a:t>Tacotron 2's attention forms a clean diagonal (95–97% monotonic), so no repeated words.</a:t>
-            </a:r>
-            <a:endParaRPr lang="en-US" sz="1200" dirty="0"/>
-          </a:p>
-        </p:txBody>
-      </p:sp>
-      <p:sp>
-        <p:nvSpPr>
-          <p:cNvPr id="11" name="Conclusion 3 circle"/>
-          <p:cNvSpPr/>
-          <p:nvPr/>
-        </p:nvSpPr>
-        <p:spPr>
-          <a:xfrm>
-            <a:off x="457200" y="2523744"/>
-            <a:ext cx="384048" cy="384048"/>
-          </a:xfrm>
-          <a:prstGeom prst="ellipse">
-            <a:avLst/>
-          </a:prstGeom>
-          <a:solidFill>
-            <a:schemeClr val="accent1"/>
-          </a:solidFill>
-          <a:ln w="12700">
-            <a:solidFill>
-              <a:schemeClr val="accent1"/>
-            </a:solidFill>
-            <a:prstDash val="solid"/>
-          </a:ln>
-        </p:spPr>
-      </p:sp>
-      <p:sp>
-        <p:nvSpPr>
-          <p:cNvPr id="12" name="Conclusion 3 label"/>
-          <p:cNvSpPr txBox="1"/>
-          <p:nvPr/>
-        </p:nvSpPr>
-        <p:spPr>
-          <a:xfrm>
-            <a:off x="457200" y="2523744"/>
-            <a:ext cx="384048" cy="384048"/>
-          </a:xfrm>
-          <a:prstGeom prst="rect">
-            <a:avLst/>
-          </a:prstGeom>
-          <a:noFill/>
-          <a:ln/>
-        </p:spPr>
-        <p:txBody>
-          <a:bodyPr wrap="square" lIns="0" tIns="0" rIns="0" bIns="0" rtlCol="0" anchor="ctr"/>
-          <a:lstStyle/>
-          <a:p>
-            <a:pPr algn="ctr" indent="0" marL="0">
-              <a:buNone/>
-            </a:pPr>
-            <a:r>
-              <a:rPr lang="en-US" sz="1400" b="1" dirty="0">
-                <a:solidFill>
-                  <a:schemeClr val="bg1"/>
-                </a:solidFill>
-              </a:rPr>
-              <a:t>3</a:t>
-            </a:r>
-            <a:endParaRPr lang="en-US" sz="1400" dirty="0"/>
-          </a:p>
-        </p:txBody>
-      </p:sp>
-      <p:sp>
-        <p:nvSpPr>
-          <p:cNvPr id="13" name="Conclusion 3 head"/>
-          <p:cNvSpPr txBox="1"/>
-          <p:nvPr/>
-        </p:nvSpPr>
-        <p:spPr>
-          <a:xfrm>
-            <a:off x="1005840" y="2478024"/>
-            <a:ext cx="4572000" cy="301752"/>
-          </a:xfrm>
-          <a:prstGeom prst="rect">
-            <a:avLst/>
-          </a:prstGeom>
-          <a:noFill/>
-          <a:ln/>
-        </p:spPr>
-        <p:txBody>
-          <a:bodyPr wrap="square" lIns="0" tIns="0" rIns="0" bIns="0" rtlCol="0" anchor="ctr"/>
-          <a:lstStyle/>
-          <a:p>
-            <a:pPr indent="0" marL="0">
-              <a:buNone/>
-            </a:pPr>
-            <a:r>
-              <a:rPr lang="en-US" sz="1500" b="1" dirty="0">
-                <a:solidFill>
-                  <a:schemeClr val="tx1"/>
-                </a:solidFill>
-              </a:rPr>
-              <a:t>Vocoder sets the sound quality</a:t>
-            </a:r>
-            <a:endParaRPr lang="en-US" sz="1500" dirty="0"/>
-          </a:p>
-        </p:txBody>
-      </p:sp>
-      <p:sp>
-        <p:nvSpPr>
-          <p:cNvPr id="14" name="Conclusion 3 body"/>
-          <p:cNvSpPr txBox="1"/>
-          <p:nvPr/>
-        </p:nvSpPr>
-        <p:spPr>
-          <a:xfrm>
-            <a:off x="1005840" y="2779776"/>
-            <a:ext cx="4572000" cy="384048"/>
-          </a:xfrm>
-          <a:prstGeom prst="rect">
-            <a:avLst/>
-          </a:prstGeom>
-          <a:noFill/>
-          <a:ln/>
-        </p:spPr>
-        <p:txBody>
-          <a:bodyPr wrap="square" lIns="0" tIns="0" rIns="0" bIns="0" rtlCol="0" anchor="t"/>
-          <a:lstStyle/>
-          <a:p>
-            <a:pPr indent="0" marL="0">
-              <a:buNone/>
-            </a:pPr>
-            <a:r>
-              <a:rPr lang="en-US" sz="1200" dirty="0">
-                <a:solidFill>
-                  <a:schemeClr val="accent6"/>
-                </a:solidFill>
-              </a:rPr>
-              <a:t>On identical mels, HiFi-GAN avoids Griffin-Lim's metallic phase artefacts.</a:t>
-            </a:r>
-            <a:endParaRPr lang="en-US" sz="1200" dirty="0"/>
-          </a:p>
-        </p:txBody>
-      </p:sp>
-      <p:sp>
-        <p:nvSpPr>
-          <p:cNvPr id="15" name="Conclusion 4 circle"/>
-          <p:cNvSpPr/>
-          <p:nvPr/>
-        </p:nvSpPr>
-        <p:spPr>
-          <a:xfrm>
-            <a:off x="457200" y="3236976"/>
-            <a:ext cx="384048" cy="384048"/>
-          </a:xfrm>
-          <a:prstGeom prst="ellipse">
-            <a:avLst/>
-          </a:prstGeom>
-          <a:solidFill>
-            <a:schemeClr val="accent1"/>
-          </a:solidFill>
-          <a:ln w="12700">
-            <a:solidFill>
-              <a:schemeClr val="accent1"/>
-            </a:solidFill>
-            <a:prstDash val="solid"/>
-          </a:ln>
-        </p:spPr>
-      </p:sp>
-      <p:sp>
-        <p:nvSpPr>
-          <p:cNvPr id="16" name="Conclusion 4 label"/>
-          <p:cNvSpPr txBox="1"/>
-          <p:nvPr/>
-        </p:nvSpPr>
-        <p:spPr>
-          <a:xfrm>
-            <a:off x="457200" y="3236976"/>
-            <a:ext cx="384048" cy="384048"/>
-          </a:xfrm>
-          <a:prstGeom prst="rect">
-            <a:avLst/>
-          </a:prstGeom>
-          <a:noFill/>
-          <a:ln/>
-        </p:spPr>
-        <p:txBody>
-          <a:bodyPr wrap="square" lIns="0" tIns="0" rIns="0" bIns="0" rtlCol="0" anchor="ctr"/>
-          <a:lstStyle/>
-          <a:p>
-            <a:pPr algn="ctr" indent="0" marL="0">
-              <a:buNone/>
-            </a:pPr>
-            <a:r>
-              <a:rPr lang="en-US" sz="1400" b="1" dirty="0">
-                <a:solidFill>
-                  <a:schemeClr val="bg1"/>
-                </a:solidFill>
-              </a:rPr>
-              <a:t>4</a:t>
-            </a:r>
-            <a:endParaRPr lang="en-US" sz="1400" dirty="0"/>
-          </a:p>
-        </p:txBody>
-      </p:sp>
-      <p:sp>
-        <p:nvSpPr>
-          <p:cNvPr id="17" name="Conclusion 4 head"/>
-          <p:cNvSpPr txBox="1"/>
-          <p:nvPr/>
-        </p:nvSpPr>
-        <p:spPr>
-          <a:xfrm>
-            <a:off x="1005840" y="3191256"/>
-            <a:ext cx="4572000" cy="301752"/>
-          </a:xfrm>
-          <a:prstGeom prst="rect">
-            <a:avLst/>
-          </a:prstGeom>
-          <a:noFill/>
-          <a:ln/>
-        </p:spPr>
-        <p:txBody>
-          <a:bodyPr wrap="square" lIns="0" tIns="0" rIns="0" bIns="0" rtlCol="0" anchor="ctr"/>
-          <a:lstStyle/>
-          <a:p>
-            <a:pPr indent="0" marL="0">
-              <a:buNone/>
-            </a:pPr>
-            <a:r>
-              <a:rPr lang="en-US" sz="1500" b="1" dirty="0">
-                <a:solidFill>
-                  <a:schemeClr val="tx1"/>
-                </a:solidFill>
-              </a:rPr>
-              <a:t>It runs live on a laptop</a:t>
-            </a:r>
-            <a:endParaRPr lang="en-US" sz="1500" dirty="0"/>
-          </a:p>
-        </p:txBody>
-      </p:sp>
-      <p:sp>
-        <p:nvSpPr>
-          <p:cNvPr id="18" name="Conclusion 4 body"/>
-          <p:cNvSpPr txBox="1"/>
-          <p:nvPr/>
-        </p:nvSpPr>
-        <p:spPr>
-          <a:xfrm>
-            <a:off x="1005840" y="3493008"/>
-            <a:ext cx="4572000" cy="384048"/>
-          </a:xfrm>
-          <a:prstGeom prst="rect">
-            <a:avLst/>
-          </a:prstGeom>
-          <a:noFill/>
-          <a:ln/>
-        </p:spPr>
-        <p:txBody>
-          <a:bodyPr wrap="square" lIns="0" tIns="0" rIns="0" bIns="0" rtlCol="0" anchor="t"/>
-          <a:lstStyle/>
-          <a:p>
-            <a:pPr indent="0" marL="0">
-              <a:buNone/>
-            </a:pPr>
-            <a:r>
-              <a:rPr lang="en-US" sz="1200" dirty="0">
-                <a:solidFill>
-                  <a:schemeClr val="accent6"/>
-                </a:solidFill>
-              </a:rPr>
-              <a:t>Tacotron 2 + HiFi-GAN is faster than real time on CPU.</a:t>
-            </a:r>
-            <a:endParaRPr lang="en-US" sz="1200" dirty="0"/>
-          </a:p>
-        </p:txBody>
-      </p:sp>
-      <p:sp>
-        <p:nvSpPr>
-          <p:cNvPr id="19" name="Limitations card"/>
-          <p:cNvSpPr/>
-          <p:nvPr/>
-        </p:nvSpPr>
-        <p:spPr>
-          <a:xfrm>
-            <a:off x="5852160" y="1051560"/>
-            <a:ext cx="2834640" cy="2788920"/>
-          </a:xfrm>
-          <a:prstGeom prst="roundRect">
-            <a:avLst>
-              <a:gd name="adj" fmla="val 2623"/>
-            </a:avLst>
-          </a:prstGeom>
-          <a:solidFill>
-            <a:schemeClr val="bg2"/>
-          </a:solidFill>
-          <a:ln w="12700">
-            <a:solidFill>
-              <a:schemeClr val="bg2"/>
-            </a:solidFill>
-            <a:prstDash val="solid"/>
-          </a:ln>
-        </p:spPr>
-      </p:sp>
-      <p:sp>
-        <p:nvSpPr>
-          <p:cNvPr id="20" name="Limitations"/>
-          <p:cNvSpPr txBox="1"/>
-          <p:nvPr/>
-        </p:nvSpPr>
-        <p:spPr>
-          <a:xfrm>
-            <a:off x="6035040" y="1188720"/>
-            <a:ext cx="2514600" cy="2560320"/>
-          </a:xfrm>
-          <a:prstGeom prst="rect">
-            <a:avLst/>
-          </a:prstGeom>
-          <a:noFill/>
-          <a:ln/>
-        </p:spPr>
-        <p:txBody>
-          <a:bodyPr wrap="square" lIns="0" tIns="0" rIns="0" bIns="0" rtlCol="0" anchor="t"/>
-          <a:lstStyle/>
-          <a:p>
-            <a:pPr indent="0" marL="0">
-              <a:spcAft>
-                <a:spcPts val="400"/>
-              </a:spcAft>
-              <a:buNone/>
-            </a:pPr>
-            <a:r>
-              <a:rPr lang="en-US" sz="1600" b="1" dirty="0">
-                <a:solidFill>
-                  <a:schemeClr val="accent1"/>
-                </a:solidFill>
-              </a:rPr>
-              <a:t>Limitations</a:t>
-            </a:r>
-            <a:endParaRPr lang="en-US" sz="1300" dirty="0"/>
-          </a:p>
-          <a:p>
-            <a:pPr indent="0" marL="0">
-              <a:spcAft>
-                <a:spcPts val="400"/>
-              </a:spcAft>
-              <a:buNone/>
-            </a:pPr>
-            <a:r>
-              <a:rPr lang="en-US" sz="600" dirty="0">
-                <a:solidFill>
-                  <a:schemeClr val="tx1"/>
-                </a:solidFill>
-              </a:rPr>
-              <a:t> </a:t>
-            </a:r>
-            <a:endParaRPr lang="en-US" sz="1300" dirty="0"/>
-          </a:p>
-          <a:p>
-            <a:pPr marL="342900" indent="-342900">
-              <a:spcAft>
-                <a:spcPts val="400"/>
-              </a:spcAft>
-              <a:buSzPct val="100000"/>
-              <a:buChar char="•"/>
-            </a:pPr>
-            <a:r>
-              <a:rPr lang="en-US" sz="1300" dirty="0">
-                <a:solidFill>
-                  <a:schemeClr val="tx1"/>
-                </a:solidFill>
-              </a:rPr>
-              <a:t>Main models are pretrained, not trained by us</a:t>
-            </a:r>
-            <a:endParaRPr lang="en-US" sz="1300" dirty="0"/>
-          </a:p>
-          <a:p>
-            <a:pPr marL="342900" indent="-342900">
-              <a:spcAft>
-                <a:spcPts val="400"/>
-              </a:spcAft>
-              <a:buSzPct val="100000"/>
-              <a:buChar char="•"/>
-            </a:pPr>
-            <a:r>
-              <a:rPr lang="en-US" sz="1300" dirty="0">
-                <a:solidFill>
-                  <a:schemeClr val="tx1"/>
-                </a:solidFill>
-              </a:rPr>
-              <a:t>Pretrained model may have seen test clips</a:t>
-            </a:r>
-            <a:endParaRPr lang="en-US" sz="1300" dirty="0"/>
-          </a:p>
-          <a:p>
-            <a:pPr marL="342900" indent="-342900">
-              <a:spcAft>
-                <a:spcPts val="400"/>
-              </a:spcAft>
-              <a:buSzPct val="100000"/>
-              <a:buChar char="•"/>
-            </a:pPr>
-            <a:r>
-              <a:rPr lang="en-US" sz="1300" dirty="0">
-                <a:solidFill>
-                  <a:schemeClr val="tx1"/>
-                </a:solidFill>
-              </a:rPr>
-              <a:t>One speaker, English only</a:t>
-            </a:r>
-            <a:endParaRPr lang="en-US" sz="1300" dirty="0"/>
-          </a:p>
-          <a:p>
-            <a:pPr marL="342900" indent="-342900">
-              <a:spcAft>
-                <a:spcPts val="400"/>
-              </a:spcAft>
-              <a:buSzPct val="100000"/>
-              <a:buChar char="•"/>
-            </a:pPr>
-            <a:r>
-              <a:rPr lang="en-US" sz="1300" dirty="0">
-                <a:solidFill>
-                  <a:schemeClr val="tx1"/>
-                </a:solidFill>
-              </a:rPr>
-              <a:t>No formal listening test (MOS)</a:t>
-            </a:r>
-            <a:endParaRPr lang="en-US" sz="1300" dirty="0"/>
-          </a:p>
-          <a:p>
-            <a:pPr indent="0" marL="0">
-              <a:spcAft>
-                <a:spcPts val="400"/>
-              </a:spcAft>
-              <a:buNone/>
-            </a:pPr>
-            <a:r>
-              <a:rPr lang="en-US" sz="600" dirty="0">
-                <a:solidFill>
-                  <a:schemeClr val="tx1"/>
-                </a:solidFill>
-              </a:rPr>
-              <a:t> </a:t>
-            </a:r>
-            <a:endParaRPr lang="en-US" sz="1300" dirty="0"/>
-          </a:p>
-          <a:p>
-            <a:pPr indent="0" marL="0">
-              <a:spcAft>
-                <a:spcPts val="400"/>
-              </a:spcAft>
-              <a:buNone/>
-            </a:pPr>
-            <a:r>
-              <a:rPr lang="en-US" sz="1300" i="1" dirty="0">
-                <a:solidFill>
-                  <a:schemeClr val="tx1"/>
-                </a:solidFill>
-              </a:rPr>
-              <a:t>Next: fine-tune Tacotron 2 on a GPU</a:t>
+              <a:t>Sharper detail from 4× the parameters and days of GPU training.</a:t>
             </a:r>
             <a:endParaRPr lang="en-US" sz="1300" dirty="0"/>
           </a:p>
@@ -6255,6 +6366,838 @@
         </p:nvSpPr>
         <p:spPr>
           <a:xfrm>
+            <a:off x="457200" y="274320"/>
+            <a:ext cx="8229600" cy="685800"/>
+          </a:xfrm>
+          <a:prstGeom prst="rect">
+            <a:avLst/>
+          </a:prstGeom>
+          <a:noFill/>
+          <a:ln/>
+        </p:spPr>
+        <p:txBody>
+          <a:bodyPr wrap="square" lIns="0" tIns="0" rIns="0" bIns="0" rtlCol="0" anchor="ctr"/>
+          <a:lstStyle/>
+          <a:p>
+            <a:pPr algn="l" indent="0" marL="0">
+              <a:buNone/>
+            </a:pPr>
+            <a:r>
+              <a:rPr lang="en-US" sz="3000" b="1" dirty="0">
+                <a:solidFill>
+                  <a:schemeClr val="tx2"/>
+                </a:solidFill>
+                <a:latin typeface="Arial" pitchFamily="34" charset="0"/>
+                <a:ea typeface="Arial" pitchFamily="34" charset="-122"/>
+                <a:cs typeface="Arial" pitchFamily="34" charset="-120"/>
+              </a:rPr>
+              <a:t>Conclusions</a:t>
+            </a:r>
+            <a:endParaRPr lang="en-US" sz="3000" dirty="0"/>
+          </a:p>
+        </p:txBody>
+      </p:sp>
+      <p:sp>
+        <p:nvSpPr>
+          <p:cNvPr id="3" name="Conclusion 1 circle"/>
+          <p:cNvSpPr/>
+          <p:nvPr/>
+        </p:nvSpPr>
+        <p:spPr>
+          <a:xfrm>
+            <a:off x="457200" y="1097280"/>
+            <a:ext cx="384048" cy="384048"/>
+          </a:xfrm>
+          <a:prstGeom prst="ellipse">
+            <a:avLst/>
+          </a:prstGeom>
+          <a:solidFill>
+            <a:schemeClr val="accent1"/>
+          </a:solidFill>
+          <a:ln w="12700">
+            <a:solidFill>
+              <a:schemeClr val="accent1"/>
+            </a:solidFill>
+            <a:prstDash val="solid"/>
+          </a:ln>
+        </p:spPr>
+      </p:sp>
+      <p:sp>
+        <p:nvSpPr>
+          <p:cNvPr id="4" name="Conclusion 1 label"/>
+          <p:cNvSpPr txBox="1"/>
+          <p:nvPr/>
+        </p:nvSpPr>
+        <p:spPr>
+          <a:xfrm>
+            <a:off x="457200" y="1097280"/>
+            <a:ext cx="384048" cy="384048"/>
+          </a:xfrm>
+          <a:prstGeom prst="rect">
+            <a:avLst/>
+          </a:prstGeom>
+          <a:noFill/>
+          <a:ln/>
+        </p:spPr>
+        <p:txBody>
+          <a:bodyPr wrap="square" lIns="0" tIns="0" rIns="0" bIns="0" rtlCol="0" anchor="ctr"/>
+          <a:lstStyle/>
+          <a:p>
+            <a:pPr algn="ctr" indent="0" marL="0">
+              <a:buNone/>
+            </a:pPr>
+            <a:r>
+              <a:rPr lang="en-US" sz="1400" b="1" dirty="0">
+                <a:solidFill>
+                  <a:schemeClr val="bg1"/>
+                </a:solidFill>
+              </a:rPr>
+              <a:t>1</a:t>
+            </a:r>
+            <a:endParaRPr lang="en-US" sz="1400" dirty="0"/>
+          </a:p>
+        </p:txBody>
+      </p:sp>
+      <p:sp>
+        <p:nvSpPr>
+          <p:cNvPr id="5" name="Conclusion 1 head"/>
+          <p:cNvSpPr txBox="1"/>
+          <p:nvPr/>
+        </p:nvSpPr>
+        <p:spPr>
+          <a:xfrm>
+            <a:off x="1005840" y="1051560"/>
+            <a:ext cx="4572000" cy="301752"/>
+          </a:xfrm>
+          <a:prstGeom prst="rect">
+            <a:avLst/>
+          </a:prstGeom>
+          <a:noFill/>
+          <a:ln/>
+        </p:spPr>
+        <p:txBody>
+          <a:bodyPr wrap="square" lIns="0" tIns="0" rIns="0" bIns="0" rtlCol="0" anchor="ctr"/>
+          <a:lstStyle/>
+          <a:p>
+            <a:pPr indent="0" marL="0">
+              <a:buNone/>
+            </a:pPr>
+            <a:r>
+              <a:rPr lang="en-US" sz="1500" b="1" dirty="0">
+                <a:solidFill>
+                  <a:schemeClr val="tx1"/>
+                </a:solidFill>
+              </a:rPr>
+              <a:t>Attention + data fix the 2018 failure</a:t>
+            </a:r>
+            <a:endParaRPr lang="en-US" sz="1500" dirty="0"/>
+          </a:p>
+        </p:txBody>
+      </p:sp>
+      <p:sp>
+        <p:nvSpPr>
+          <p:cNvPr id="6" name="Conclusion 1 body"/>
+          <p:cNvSpPr txBox="1"/>
+          <p:nvPr/>
+        </p:nvSpPr>
+        <p:spPr>
+          <a:xfrm>
+            <a:off x="1005840" y="1353312"/>
+            <a:ext cx="4572000" cy="384048"/>
+          </a:xfrm>
+          <a:prstGeom prst="rect">
+            <a:avLst/>
+          </a:prstGeom>
+          <a:noFill/>
+          <a:ln/>
+        </p:spPr>
+        <p:txBody>
+          <a:bodyPr wrap="square" lIns="0" tIns="0" rIns="0" bIns="0" rtlCol="0" anchor="t"/>
+          <a:lstStyle/>
+          <a:p>
+            <a:pPr indent="0" marL="0">
+              <a:buNone/>
+            </a:pPr>
+            <a:r>
+              <a:rPr lang="en-US" sz="1200" dirty="0">
+                <a:solidFill>
+                  <a:schemeClr val="accent6"/>
+                </a:solidFill>
+              </a:rPr>
+              <a:t>Our from-scratch Colatron reads text in order (99–100% monotonic); the paper's attention never aligned.</a:t>
+            </a:r>
+            <a:endParaRPr lang="en-US" sz="1200" dirty="0"/>
+          </a:p>
+        </p:txBody>
+      </p:sp>
+      <p:sp>
+        <p:nvSpPr>
+          <p:cNvPr id="7" name="Conclusion 2 circle"/>
+          <p:cNvSpPr/>
+          <p:nvPr/>
+        </p:nvSpPr>
+        <p:spPr>
+          <a:xfrm>
+            <a:off x="457200" y="1810512"/>
+            <a:ext cx="384048" cy="384048"/>
+          </a:xfrm>
+          <a:prstGeom prst="ellipse">
+            <a:avLst/>
+          </a:prstGeom>
+          <a:solidFill>
+            <a:schemeClr val="accent1"/>
+          </a:solidFill>
+          <a:ln w="12700">
+            <a:solidFill>
+              <a:schemeClr val="accent1"/>
+            </a:solidFill>
+            <a:prstDash val="solid"/>
+          </a:ln>
+        </p:spPr>
+      </p:sp>
+      <p:sp>
+        <p:nvSpPr>
+          <p:cNvPr id="8" name="Conclusion 2 label"/>
+          <p:cNvSpPr txBox="1"/>
+          <p:nvPr/>
+        </p:nvSpPr>
+        <p:spPr>
+          <a:xfrm>
+            <a:off x="457200" y="1810512"/>
+            <a:ext cx="384048" cy="384048"/>
+          </a:xfrm>
+          <a:prstGeom prst="rect">
+            <a:avLst/>
+          </a:prstGeom>
+          <a:noFill/>
+          <a:ln/>
+        </p:spPr>
+        <p:txBody>
+          <a:bodyPr wrap="square" lIns="0" tIns="0" rIns="0" bIns="0" rtlCol="0" anchor="ctr"/>
+          <a:lstStyle/>
+          <a:p>
+            <a:pPr algn="ctr" indent="0" marL="0">
+              <a:buNone/>
+            </a:pPr>
+            <a:r>
+              <a:rPr lang="en-US" sz="1400" b="1" dirty="0">
+                <a:solidFill>
+                  <a:schemeClr val="bg1"/>
+                </a:solidFill>
+              </a:rPr>
+              <a:t>2</a:t>
+            </a:r>
+            <a:endParaRPr lang="en-US" sz="1400" dirty="0"/>
+          </a:p>
+        </p:txBody>
+      </p:sp>
+      <p:sp>
+        <p:nvSpPr>
+          <p:cNvPr id="9" name="Conclusion 2 head"/>
+          <p:cNvSpPr txBox="1"/>
+          <p:nvPr/>
+        </p:nvSpPr>
+        <p:spPr>
+          <a:xfrm>
+            <a:off x="1005840" y="1764792"/>
+            <a:ext cx="4572000" cy="301752"/>
+          </a:xfrm>
+          <a:prstGeom prst="rect">
+            <a:avLst/>
+          </a:prstGeom>
+          <a:noFill/>
+          <a:ln/>
+        </p:spPr>
+        <p:txBody>
+          <a:bodyPr wrap="square" lIns="0" tIns="0" rIns="0" bIns="0" rtlCol="0" anchor="ctr"/>
+          <a:lstStyle/>
+          <a:p>
+            <a:pPr indent="0" marL="0">
+              <a:buNone/>
+            </a:pPr>
+            <a:r>
+              <a:rPr lang="en-US" sz="1500" b="1" dirty="0">
+                <a:solidFill>
+                  <a:schemeClr val="tx1"/>
+                </a:solidFill>
+              </a:rPr>
+              <a:t>Learned timing is essential</a:t>
+            </a:r>
+            <a:endParaRPr lang="en-US" sz="1500" dirty="0"/>
+          </a:p>
+        </p:txBody>
+      </p:sp>
+      <p:sp>
+        <p:nvSpPr>
+          <p:cNvPr id="10" name="Conclusion 2 body"/>
+          <p:cNvSpPr txBox="1"/>
+          <p:nvPr/>
+        </p:nvSpPr>
+        <p:spPr>
+          <a:xfrm>
+            <a:off x="1005840" y="2066544"/>
+            <a:ext cx="4572000" cy="384048"/>
+          </a:xfrm>
+          <a:prstGeom prst="rect">
+            <a:avLst/>
+          </a:prstGeom>
+          <a:noFill/>
+          <a:ln/>
+        </p:spPr>
+        <p:txBody>
+          <a:bodyPr wrap="square" lIns="0" tIns="0" rIns="0" bIns="0" rtlCol="0" anchor="t"/>
+          <a:lstStyle/>
+          <a:p>
+            <a:pPr indent="0" marL="0">
+              <a:buNone/>
+            </a:pPr>
+            <a:r>
+              <a:rPr lang="en-US" sz="1200" dirty="0">
+                <a:solidFill>
+                  <a:schemeClr val="accent6"/>
+                </a:solidFill>
+              </a:rPr>
+              <a:t>Without attention the baseline is 100% word error; Colatron is 25%.</a:t>
+            </a:r>
+            <a:endParaRPr lang="en-US" sz="1200" dirty="0"/>
+          </a:p>
+        </p:txBody>
+      </p:sp>
+      <p:sp>
+        <p:nvSpPr>
+          <p:cNvPr id="11" name="Conclusion 3 circle"/>
+          <p:cNvSpPr/>
+          <p:nvPr/>
+        </p:nvSpPr>
+        <p:spPr>
+          <a:xfrm>
+            <a:off x="457200" y="2523744"/>
+            <a:ext cx="384048" cy="384048"/>
+          </a:xfrm>
+          <a:prstGeom prst="ellipse">
+            <a:avLst/>
+          </a:prstGeom>
+          <a:solidFill>
+            <a:schemeClr val="accent1"/>
+          </a:solidFill>
+          <a:ln w="12700">
+            <a:solidFill>
+              <a:schemeClr val="accent1"/>
+            </a:solidFill>
+            <a:prstDash val="solid"/>
+          </a:ln>
+        </p:spPr>
+      </p:sp>
+      <p:sp>
+        <p:nvSpPr>
+          <p:cNvPr id="12" name="Conclusion 3 label"/>
+          <p:cNvSpPr txBox="1"/>
+          <p:nvPr/>
+        </p:nvSpPr>
+        <p:spPr>
+          <a:xfrm>
+            <a:off x="457200" y="2523744"/>
+            <a:ext cx="384048" cy="384048"/>
+          </a:xfrm>
+          <a:prstGeom prst="rect">
+            <a:avLst/>
+          </a:prstGeom>
+          <a:noFill/>
+          <a:ln/>
+        </p:spPr>
+        <p:txBody>
+          <a:bodyPr wrap="square" lIns="0" tIns="0" rIns="0" bIns="0" rtlCol="0" anchor="ctr"/>
+          <a:lstStyle/>
+          <a:p>
+            <a:pPr algn="ctr" indent="0" marL="0">
+              <a:buNone/>
+            </a:pPr>
+            <a:r>
+              <a:rPr lang="en-US" sz="1400" b="1" dirty="0">
+                <a:solidFill>
+                  <a:schemeClr val="bg1"/>
+                </a:solidFill>
+              </a:rPr>
+              <a:t>3</a:t>
+            </a:r>
+            <a:endParaRPr lang="en-US" sz="1400" dirty="0"/>
+          </a:p>
+        </p:txBody>
+      </p:sp>
+      <p:sp>
+        <p:nvSpPr>
+          <p:cNvPr id="13" name="Conclusion 3 head"/>
+          <p:cNvSpPr txBox="1"/>
+          <p:nvPr/>
+        </p:nvSpPr>
+        <p:spPr>
+          <a:xfrm>
+            <a:off x="1005840" y="2478024"/>
+            <a:ext cx="4572000" cy="301752"/>
+          </a:xfrm>
+          <a:prstGeom prst="rect">
+            <a:avLst/>
+          </a:prstGeom>
+          <a:noFill/>
+          <a:ln/>
+        </p:spPr>
+        <p:txBody>
+          <a:bodyPr wrap="square" lIns="0" tIns="0" rIns="0" bIns="0" rtlCol="0" anchor="ctr"/>
+          <a:lstStyle/>
+          <a:p>
+            <a:pPr indent="0" marL="0">
+              <a:buNone/>
+            </a:pPr>
+            <a:r>
+              <a:rPr lang="en-US" sz="1500" b="1" dirty="0">
+                <a:solidFill>
+                  <a:schemeClr val="tx1"/>
+                </a:solidFill>
+              </a:rPr>
+              <a:t>Scale still matters</a:t>
+            </a:r>
+            <a:endParaRPr lang="en-US" sz="1500" dirty="0"/>
+          </a:p>
+        </p:txBody>
+      </p:sp>
+      <p:sp>
+        <p:nvSpPr>
+          <p:cNvPr id="14" name="Conclusion 3 body"/>
+          <p:cNvSpPr txBox="1"/>
+          <p:nvPr/>
+        </p:nvSpPr>
+        <p:spPr>
+          <a:xfrm>
+            <a:off x="1005840" y="2779776"/>
+            <a:ext cx="4572000" cy="384048"/>
+          </a:xfrm>
+          <a:prstGeom prst="rect">
+            <a:avLst/>
+          </a:prstGeom>
+          <a:noFill/>
+          <a:ln/>
+        </p:spPr>
+        <p:txBody>
+          <a:bodyPr wrap="square" lIns="0" tIns="0" rIns="0" bIns="0" rtlCol="0" anchor="t"/>
+          <a:lstStyle/>
+          <a:p>
+            <a:pPr indent="0" marL="0">
+              <a:buNone/>
+            </a:pPr>
+            <a:r>
+              <a:rPr lang="en-US" sz="1200" dirty="0">
+                <a:solidFill>
+                  <a:schemeClr val="accent6"/>
+                </a:solidFill>
+              </a:rPr>
+              <a:t>Pretrained Tacotron 2 (4× larger, days on GPUs) reaches 16%.</a:t>
+            </a:r>
+            <a:endParaRPr lang="en-US" sz="1200" dirty="0"/>
+          </a:p>
+        </p:txBody>
+      </p:sp>
+      <p:sp>
+        <p:nvSpPr>
+          <p:cNvPr id="15" name="Conclusion 4 circle"/>
+          <p:cNvSpPr/>
+          <p:nvPr/>
+        </p:nvSpPr>
+        <p:spPr>
+          <a:xfrm>
+            <a:off x="457200" y="3236976"/>
+            <a:ext cx="384048" cy="384048"/>
+          </a:xfrm>
+          <a:prstGeom prst="ellipse">
+            <a:avLst/>
+          </a:prstGeom>
+          <a:solidFill>
+            <a:schemeClr val="accent1"/>
+          </a:solidFill>
+          <a:ln w="12700">
+            <a:solidFill>
+              <a:schemeClr val="accent1"/>
+            </a:solidFill>
+            <a:prstDash val="solid"/>
+          </a:ln>
+        </p:spPr>
+      </p:sp>
+      <p:sp>
+        <p:nvSpPr>
+          <p:cNvPr id="16" name="Conclusion 4 label"/>
+          <p:cNvSpPr txBox="1"/>
+          <p:nvPr/>
+        </p:nvSpPr>
+        <p:spPr>
+          <a:xfrm>
+            <a:off x="457200" y="3236976"/>
+            <a:ext cx="384048" cy="384048"/>
+          </a:xfrm>
+          <a:prstGeom prst="rect">
+            <a:avLst/>
+          </a:prstGeom>
+          <a:noFill/>
+          <a:ln/>
+        </p:spPr>
+        <p:txBody>
+          <a:bodyPr wrap="square" lIns="0" tIns="0" rIns="0" bIns="0" rtlCol="0" anchor="ctr"/>
+          <a:lstStyle/>
+          <a:p>
+            <a:pPr algn="ctr" indent="0" marL="0">
+              <a:buNone/>
+            </a:pPr>
+            <a:r>
+              <a:rPr lang="en-US" sz="1400" b="1" dirty="0">
+                <a:solidFill>
+                  <a:schemeClr val="bg1"/>
+                </a:solidFill>
+              </a:rPr>
+              <a:t>4</a:t>
+            </a:r>
+            <a:endParaRPr lang="en-US" sz="1400" dirty="0"/>
+          </a:p>
+        </p:txBody>
+      </p:sp>
+      <p:sp>
+        <p:nvSpPr>
+          <p:cNvPr id="17" name="Conclusion 4 head"/>
+          <p:cNvSpPr txBox="1"/>
+          <p:nvPr/>
+        </p:nvSpPr>
+        <p:spPr>
+          <a:xfrm>
+            <a:off x="1005840" y="3191256"/>
+            <a:ext cx="4572000" cy="301752"/>
+          </a:xfrm>
+          <a:prstGeom prst="rect">
+            <a:avLst/>
+          </a:prstGeom>
+          <a:noFill/>
+          <a:ln/>
+        </p:spPr>
+        <p:txBody>
+          <a:bodyPr wrap="square" lIns="0" tIns="0" rIns="0" bIns="0" rtlCol="0" anchor="ctr"/>
+          <a:lstStyle/>
+          <a:p>
+            <a:pPr indent="0" marL="0">
+              <a:buNone/>
+            </a:pPr>
+            <a:r>
+              <a:rPr lang="en-US" sz="1500" b="1" dirty="0">
+                <a:solidFill>
+                  <a:schemeClr val="tx1"/>
+                </a:solidFill>
+              </a:rPr>
+              <a:t>Cheap to train, runs on a laptop</a:t>
+            </a:r>
+            <a:endParaRPr lang="en-US" sz="1500" dirty="0"/>
+          </a:p>
+        </p:txBody>
+      </p:sp>
+      <p:sp>
+        <p:nvSpPr>
+          <p:cNvPr id="18" name="Conclusion 4 body"/>
+          <p:cNvSpPr txBox="1"/>
+          <p:nvPr/>
+        </p:nvSpPr>
+        <p:spPr>
+          <a:xfrm>
+            <a:off x="1005840" y="3493008"/>
+            <a:ext cx="4572000" cy="384048"/>
+          </a:xfrm>
+          <a:prstGeom prst="rect">
+            <a:avLst/>
+          </a:prstGeom>
+          <a:noFill/>
+          <a:ln/>
+        </p:spPr>
+        <p:txBody>
+          <a:bodyPr wrap="square" lIns="0" tIns="0" rIns="0" bIns="0" rtlCol="0" anchor="t"/>
+          <a:lstStyle/>
+          <a:p>
+            <a:pPr indent="0" marL="0">
+              <a:buNone/>
+            </a:pPr>
+            <a:r>
+              <a:rPr lang="en-US" sz="1200" dirty="0">
+                <a:solidFill>
+                  <a:schemeClr val="accent6"/>
+                </a:solidFill>
+              </a:rPr>
+              <a:t>2.2 h of training (laptop CPU + free Colab GPU); speaks on a laptop CPU.</a:t>
+            </a:r>
+            <a:endParaRPr lang="en-US" sz="1200" dirty="0"/>
+          </a:p>
+        </p:txBody>
+      </p:sp>
+      <p:sp>
+        <p:nvSpPr>
+          <p:cNvPr id="19" name="Limitations card"/>
+          <p:cNvSpPr/>
+          <p:nvPr/>
+        </p:nvSpPr>
+        <p:spPr>
+          <a:xfrm>
+            <a:off x="5852160" y="1051560"/>
+            <a:ext cx="2834640" cy="2788920"/>
+          </a:xfrm>
+          <a:prstGeom prst="roundRect">
+            <a:avLst>
+              <a:gd name="adj" fmla="val 2623"/>
+            </a:avLst>
+          </a:prstGeom>
+          <a:solidFill>
+            <a:schemeClr val="bg2"/>
+          </a:solidFill>
+          <a:ln w="12700">
+            <a:solidFill>
+              <a:schemeClr val="bg2"/>
+            </a:solidFill>
+            <a:prstDash val="solid"/>
+          </a:ln>
+        </p:spPr>
+      </p:sp>
+      <p:sp>
+        <p:nvSpPr>
+          <p:cNvPr id="20" name="Limitations"/>
+          <p:cNvSpPr txBox="1"/>
+          <p:nvPr/>
+        </p:nvSpPr>
+        <p:spPr>
+          <a:xfrm>
+            <a:off x="6035040" y="1188720"/>
+            <a:ext cx="2514600" cy="2560320"/>
+          </a:xfrm>
+          <a:prstGeom prst="rect">
+            <a:avLst/>
+          </a:prstGeom>
+          <a:noFill/>
+          <a:ln/>
+        </p:spPr>
+        <p:txBody>
+          <a:bodyPr wrap="square" lIns="0" tIns="0" rIns="0" bIns="0" rtlCol="0" anchor="t"/>
+          <a:lstStyle/>
+          <a:p>
+            <a:pPr indent="0" marL="0">
+              <a:spcAft>
+                <a:spcPts val="400"/>
+              </a:spcAft>
+              <a:buNone/>
+            </a:pPr>
+            <a:r>
+              <a:rPr lang="en-US" sz="1600" b="1" dirty="0">
+                <a:solidFill>
+                  <a:schemeClr val="accent1"/>
+                </a:solidFill>
+              </a:rPr>
+              <a:t>Limitations</a:t>
+            </a:r>
+            <a:endParaRPr lang="en-US" sz="1300" dirty="0"/>
+          </a:p>
+          <a:p>
+            <a:pPr indent="0" marL="0">
+              <a:spcAft>
+                <a:spcPts val="400"/>
+              </a:spcAft>
+              <a:buNone/>
+            </a:pPr>
+            <a:r>
+              <a:rPr lang="en-US" sz="600" dirty="0">
+                <a:solidFill>
+                  <a:schemeClr val="tx1"/>
+                </a:solidFill>
+              </a:rPr>
+              <a:t> </a:t>
+            </a:r>
+            <a:endParaRPr lang="en-US" sz="1300" dirty="0"/>
+          </a:p>
+          <a:p>
+            <a:pPr marL="342900" indent="-342900">
+              <a:spcAft>
+                <a:spcPts val="400"/>
+              </a:spcAft>
+              <a:buSzPct val="100000"/>
+              <a:buChar char="•"/>
+            </a:pPr>
+            <a:r>
+              <a:rPr lang="en-US" sz="1300" dirty="0">
+                <a:solidFill>
+                  <a:schemeClr val="tx1"/>
+                </a:solidFill>
+              </a:rPr>
+              <a:t>Colatron trained for only 2.2 h: still robotic</a:t>
+            </a:r>
+            <a:endParaRPr lang="en-US" sz="1300" dirty="0"/>
+          </a:p>
+          <a:p>
+            <a:pPr marL="342900" indent="-342900">
+              <a:spcAft>
+                <a:spcPts val="400"/>
+              </a:spcAft>
+              <a:buSzPct val="100000"/>
+              <a:buChar char="•"/>
+            </a:pPr>
+            <a:r>
+              <a:rPr lang="en-US" sz="1300" dirty="0">
+                <a:solidFill>
+                  <a:schemeClr val="tx1"/>
+                </a:solidFill>
+              </a:rPr>
+              <a:t>Uses a pretrained HiFi-GAN vocoder</a:t>
+            </a:r>
+            <a:endParaRPr lang="en-US" sz="1300" dirty="0"/>
+          </a:p>
+          <a:p>
+            <a:pPr marL="342900" indent="-342900">
+              <a:spcAft>
+                <a:spcPts val="400"/>
+              </a:spcAft>
+              <a:buSzPct val="100000"/>
+              <a:buChar char="•"/>
+            </a:pPr>
+            <a:r>
+              <a:rPr lang="en-US" sz="1300" dirty="0">
+                <a:solidFill>
+                  <a:schemeClr val="tx1"/>
+                </a:solidFill>
+              </a:rPr>
+              <a:t>One speaker, English only</a:t>
+            </a:r>
+            <a:endParaRPr lang="en-US" sz="1300" dirty="0"/>
+          </a:p>
+          <a:p>
+            <a:pPr marL="342900" indent="-342900">
+              <a:spcAft>
+                <a:spcPts val="400"/>
+              </a:spcAft>
+              <a:buSzPct val="100000"/>
+              <a:buChar char="•"/>
+            </a:pPr>
+            <a:r>
+              <a:rPr lang="en-US" sz="1300" dirty="0">
+                <a:solidFill>
+                  <a:schemeClr val="tx1"/>
+                </a:solidFill>
+              </a:rPr>
+              <a:t>No human listening test (MOS)</a:t>
+            </a:r>
+            <a:endParaRPr lang="en-US" sz="1300" dirty="0"/>
+          </a:p>
+          <a:p>
+            <a:pPr indent="0" marL="0">
+              <a:spcAft>
+                <a:spcPts val="400"/>
+              </a:spcAft>
+              <a:buNone/>
+            </a:pPr>
+            <a:r>
+              <a:rPr lang="en-US" sz="600" dirty="0">
+                <a:solidFill>
+                  <a:schemeClr val="tx1"/>
+                </a:solidFill>
+              </a:rPr>
+              <a:t> </a:t>
+            </a:r>
+            <a:endParaRPr lang="en-US" sz="1300" dirty="0"/>
+          </a:p>
+          <a:p>
+            <a:pPr indent="0" marL="0">
+              <a:spcAft>
+                <a:spcPts val="400"/>
+              </a:spcAft>
+              <a:buNone/>
+            </a:pPr>
+            <a:r>
+              <a:rPr lang="en-US" sz="1300" i="1" dirty="0">
+                <a:solidFill>
+                  <a:schemeClr val="tx1"/>
+                </a:solidFill>
+              </a:rPr>
+              <a:t>Next: train longer on a GPU</a:t>
+            </a:r>
+            <a:endParaRPr lang="en-US" sz="1300" dirty="0"/>
+          </a:p>
+        </p:txBody>
+      </p:sp>
+      <p:sp>
+        <p:nvSpPr>
+          <p:cNvPr id="25" name="Slide Number Placeholder 0"/>
+          <p:cNvSpPr>
+            <a:spLocks noGrp="1"/>
+          </p:cNvSpPr>
+          <p:nvPr>
+            <p:ph type="sldNum" sz="quarter" idx="4294967295"/>
+          </p:nvPr>
+        </p:nvSpPr>
+        <p:spPr>
+          <a:xfrm>
+            <a:off x="8229600" y="4754880"/>
+            <a:ext cx="457200" cy="274320"/>
+          </a:xfrm>
+          <a:prstGeom prst="rect">
+            <a:avLst/>
+          </a:prstGeom>
+          <a:extLst>
+            <a:ext uri="{C572A759-6A51-4108-AA02-DFA0A04FC94B}">
+              <ma14:wrappingTextBoxFlag xmlns:ma14="http://schemas.microsoft.com/office/mac/drawingml/2011/main" val="0"/>
+            </a:ext>
+          </a:extLst>
+        </p:spPr>
+        <p:txBody>
+          <a:bodyPr/>
+          <a:lstStyle>
+            <a:lvl1pPr>
+              <a:defRPr sz="1000">
+                <a:solidFill>
+                  <a:schemeClr val="accent6"/>
+                </a:solidFill>
+              </a:defRPr>
+            </a:lvl1pPr>
+          </a:lstStyle>
+          <a:p>
+            <a:pPr algn="r"/>
+            <a:fld id="{F7021451-1387-4CA6-816F-3879F97B5CBC}" type="slidenum">
+              <a:rPr b="0" lang="en-US"/>
+              <a:t>14</a:t>
+            </a:fld>
+            <a:endParaRPr lang="en-US"/>
+          </a:p>
+        </p:txBody>
+      </p:sp>
+    </p:spTree>
+  </p:cSld>
+  <p:clrMapOvr>
+    <a:masterClrMapping/>
+  </p:clrMapOvr>
+</p:sld>
+</file>
+
+<file path=ppt/slides/slide15.xml><?xml version="1.0" encoding="utf-8"?>
+<p:sld xmlns:a="http://schemas.openxmlformats.org/drawingml/2006/main" xmlns:r="http://schemas.openxmlformats.org/officeDocument/2006/relationships" xmlns:p="http://schemas.openxmlformats.org/presentationml/2006/main">
+  <p:cSld name="Slide 15">
+    <p:spTree>
+      <p:nvGrpSpPr>
+        <p:cNvPr id="1" name=""/>
+        <p:cNvGrpSpPr/>
+        <p:nvPr/>
+      </p:nvGrpSpPr>
+      <p:grpSpPr>
+        <a:xfrm>
+          <a:off x="0" y="0"/>
+          <a:ext cx="0" cy="0"/>
+          <a:chOff x="0" y="0"/>
+          <a:chExt cx="0" cy="0"/>
+        </a:xfrm>
+      </p:grpSpPr>
+      <p:sp>
+        <p:nvSpPr>
+          <p:cNvPr id="2" name="Text 0"/>
+          <p:cNvSpPr/>
+          <p:nvPr>
+            <p:ph idx="100" type="title" hasCustomPrompt="1"/>
+          </p:nvPr>
+        </p:nvSpPr>
+        <p:spPr>
+          <a:xfrm>
             <a:off x="548640" y="1417320"/>
             <a:ext cx="8046720" cy="1005840"/>
           </a:xfrm>
@@ -6515,7 +7458,7 @@
                   <a:schemeClr val="bg1"/>
                 </a:solidFill>
               </a:rPr>
-              <a:t>Choose a vocoder</a:t>
+              <a:t>Choose a system</a:t>
             </a:r>
             <a:endParaRPr lang="en-US" sz="1500" dirty="0"/>
           </a:p>
@@ -6612,7 +7555,7 @@
                   <a:schemeClr val="bg1"/>
                 </a:solidFill>
               </a:rPr>
-              <a:t>Hear it, see the alignment</a:t>
+              <a:t>Hear it, see the attention</a:t>
             </a:r>
             <a:endParaRPr lang="en-US" sz="1500" dirty="0"/>
           </a:p>
@@ -7185,7 +8128,7 @@
                   <a:schemeClr val="accent6"/>
                 </a:solidFill>
               </a:rPr>
-              <a:t>200 sentences, versus 13,100 clips for a real TTS model</a:t>
+              <a:t>About 200 sentences, versus 13,100 clips in LJ Speech</a:t>
             </a:r>
             <a:endParaRPr lang="en-US" sz="1200" dirty="0"/>
           </a:p>
@@ -7232,7 +8175,7 @@
                   <a:schemeClr val="tx1"/>
                 </a:solidFill>
               </a:rPr>
-              <a:t>Use a Tacotron 2 trained on all of LJ Speech</a:t>
+              <a:t>Train on all 13,100 clips (24 hours)</a:t>
             </a:r>
             <a:endParaRPr lang="en-US" sz="1300" dirty="0"/>
           </a:p>
@@ -7439,7 +8382,7 @@
                   <a:schemeClr val="tx1"/>
                 </a:solidFill>
               </a:rPr>
-              <a:t>Deep encoder, attention decoder and post-net</a:t>
+              <a:t>Deep seq2seq: conv + BiLSTM encoder, LSTM decoder, post-net</a:t>
             </a:r>
             <a:endParaRPr lang="en-US" sz="1300" dirty="0"/>
           </a:p>
@@ -7599,7 +8542,7 @@
                   <a:schemeClr val="accent6"/>
                 </a:solidFill>
               </a:rPr>
-              <a:t>The same word got different inputs each run, and nothing could be cached</a:t>
+              <a:t>The same word got different inputs on each run</a:t>
             </a:r>
             <a:endParaRPr lang="en-US" sz="1200" dirty="0"/>
           </a:p>
@@ -7646,7 +8589,7 @@
                   <a:schemeClr val="tx1"/>
                 </a:solidFill>
               </a:rPr>
-              <a:t>Text cleaning plus a fixed character vocabulary</a:t>
+              <a:t>Text cleaning plus a fixed 37-symbol character vocabulary</a:t>
             </a:r>
             <a:endParaRPr lang="en-US" sz="1300" dirty="0"/>
           </a:p>
@@ -7853,7 +8796,7 @@
                   <a:schemeClr val="tx1"/>
                 </a:solidFill>
               </a:rPr>
-              <a:t>Location-sensitive attention; we measure the alignment</a:t>
+              <a:t>Location-sensitive attention + guided attention loss</a:t>
             </a:r>
             <a:endParaRPr lang="en-US" sz="1300" dirty="0"/>
           </a:p>
@@ -8311,7 +9254,7 @@
                   <a:schemeClr val="accent6"/>
                 </a:solidFill>
               </a:rPr>
-              <a:t>Tacotron 2 (pretrained) or our baseline</a:t>
+              <a:t>Colatron (ours), baseline (ours) or Tacotron 2 (reference)</a:t>
             </a:r>
             <a:endParaRPr lang="en-US" sz="1100" dirty="0"/>
           </a:p>
@@ -9048,110 +9991,110 @@
           <a:p>
             <a:pPr marL="342900" indent="-342900">
               <a:spcAft>
-                <a:spcPts val="1000"/>
+                <a:spcPts val="900"/>
               </a:spcAft>
               <a:buSzPct val="100000"/>
               <a:buChar char="•"/>
             </a:pPr>
             <a:r>
-              <a:rPr lang="en-US" sz="1500" dirty="0">
+              <a:rPr lang="en-US" sz="1400" dirty="0">
                 <a:solidFill>
                   <a:schemeClr val="tx1"/>
                 </a:solidFill>
               </a:rPr>
-              <a:t>Data download, text cleaning, fixed vocabulary</a:t>
-            </a:r>
-            <a:endParaRPr lang="en-US" sz="1500" dirty="0"/>
+              <a:t>Colatron: seq2seq + attention, trained from scratch on 13,100 clips</a:t>
+            </a:r>
+            <a:endParaRPr lang="en-US" sz="1400" dirty="0"/>
           </a:p>
           <a:p>
             <a:pPr marL="342900" indent="-342900">
               <a:spcAft>
-                <a:spcPts val="1000"/>
+                <a:spcPts val="900"/>
               </a:spcAft>
               <a:buSzPct val="100000"/>
               <a:buChar char="•"/>
             </a:pPr>
             <a:r>
-              <a:rPr lang="en-US" sz="1500" dirty="0">
+              <a:rPr lang="en-US" sz="1400" dirty="0">
                 <a:solidFill>
                   <a:schemeClr val="tx1"/>
                 </a:solidFill>
               </a:rPr>
-              <a:t>Mel extraction and train / val / test split</a:t>
-            </a:r>
-            <a:endParaRPr lang="en-US" sz="1500" dirty="0"/>
+              <a:t>Baseline without attention (the lower bound)</a:t>
+            </a:r>
+            <a:endParaRPr lang="en-US" sz="1400" dirty="0"/>
           </a:p>
           <a:p>
             <a:pPr marL="342900" indent="-342900">
               <a:spcAft>
-                <a:spcPts val="1000"/>
+                <a:spcPts val="900"/>
               </a:spcAft>
               <a:buSzPct val="100000"/>
               <a:buChar char="•"/>
             </a:pPr>
             <a:r>
-              <a:rPr lang="en-US" sz="1500" dirty="0">
+              <a:rPr lang="en-US" sz="1400" dirty="0">
                 <a:solidFill>
                   <a:schemeClr val="tx1"/>
                 </a:solidFill>
               </a:rPr>
-              <a:t>Baseline text-to-mel model, trained from scratch</a:t>
-            </a:r>
-            <a:endParaRPr lang="en-US" sz="1500" dirty="0"/>
+              <a:t>Data pipeline: cleaning, fixed vocabulary, mels, splits</a:t>
+            </a:r>
+            <a:endParaRPr lang="en-US" sz="1400" dirty="0"/>
           </a:p>
           <a:p>
             <a:pPr marL="342900" indent="-342900">
               <a:spcAft>
-                <a:spcPts val="1000"/>
+                <a:spcPts val="900"/>
               </a:spcAft>
               <a:buSzPct val="100000"/>
               <a:buChar char="•"/>
             </a:pPr>
             <a:r>
-              <a:rPr lang="en-US" sz="1500" dirty="0">
+              <a:rPr lang="en-US" sz="1400" dirty="0">
                 <a:solidFill>
                   <a:schemeClr val="tx1"/>
                 </a:solidFill>
               </a:rPr>
               <a:t>Griffin-Lim vocoder and shared audio settings</a:t>
             </a:r>
-            <a:endParaRPr lang="en-US" sz="1500" dirty="0"/>
+            <a:endParaRPr lang="en-US" sz="1400" dirty="0"/>
           </a:p>
           <a:p>
             <a:pPr marL="342900" indent="-342900">
               <a:spcAft>
-                <a:spcPts val="1000"/>
+                <a:spcPts val="900"/>
               </a:spcAft>
               <a:buSzPct val="100000"/>
               <a:buChar char="•"/>
             </a:pPr>
             <a:r>
-              <a:rPr lang="en-US" sz="1500" dirty="0">
+              <a:rPr lang="en-US" sz="1400" dirty="0">
                 <a:solidFill>
                   <a:schemeClr val="tx1"/>
                 </a:solidFill>
               </a:rPr>
-              <a:t>Inference CLI and Gradio demo</a:t>
-            </a:r>
-            <a:endParaRPr lang="en-US" sz="1500" dirty="0"/>
+              <a:t>Evaluation: intelligibility, mel distance, alignment</a:t>
+            </a:r>
+            <a:endParaRPr lang="en-US" sz="1400" dirty="0"/>
           </a:p>
           <a:p>
             <a:pPr marL="342900" indent="-342900">
               <a:spcAft>
-                <a:spcPts val="1000"/>
+                <a:spcPts val="900"/>
               </a:spcAft>
               <a:buSzPct val="100000"/>
               <a:buChar char="•"/>
             </a:pPr>
             <a:r>
-              <a:rPr lang="en-US" sz="1500" dirty="0">
+              <a:rPr lang="en-US" sz="1400" dirty="0">
                 <a:solidFill>
                   <a:schemeClr val="tx1"/>
                 </a:solidFill>
               </a:rPr>
-              <a:t>Alignment analysis and mel-distance evaluation</a:t>
-            </a:r>
-            <a:endParaRPr lang="en-US" sz="1500" dirty="0"/>
+              <a:t>Gradio demo with every system</a:t>
+            </a:r>
+            <a:endParaRPr lang="en-US" sz="1400" dirty="0"/>
           </a:p>
         </p:txBody>
       </p:sp>
@@ -9164,11 +10107,11 @@
         <p:spPr>
           <a:xfrm>
             <a:off x="5577840" y="1097280"/>
-            <a:ext cx="3108960" cy="2103120"/>
+            <a:ext cx="3108960" cy="2514600"/>
           </a:xfrm>
           <a:prstGeom prst="roundRect">
             <a:avLst>
-              <a:gd name="adj" fmla="val 3478"/>
+              <a:gd name="adj" fmla="val 2909"/>
             </a:avLst>
           </a:prstGeom>
           <a:solidFill>
@@ -9212,7 +10155,7 @@
                   <a:schemeClr val="accent6"/>
                 </a:solidFill>
               </a:rPr>
-              <a:t>Pretrained (not trained by us)</a:t>
+              <a:t>Pretrained (not ours)</a:t>
             </a:r>
             <a:endParaRPr lang="en-US" sz="1600" dirty="0"/>
           </a:p>
@@ -9226,8 +10169,8 @@
         </p:nvSpPr>
         <p:spPr>
           <a:xfrm>
-            <a:off x="5760720" y="1691640"/>
-            <a:ext cx="2743200" cy="1371600"/>
+            <a:off x="5760720" y="1645920"/>
+            <a:ext cx="2743200" cy="1920240"/>
           </a:xfrm>
           <a:prstGeom prst="rect">
             <a:avLst/>
@@ -9243,28 +10186,28 @@
               <a:buNone/>
             </a:pPr>
             <a:r>
-              <a:rPr lang="en-US" sz="1300" b="1" dirty="0">
+              <a:rPr lang="en-US" sz="1200" b="1" dirty="0">
                 <a:solidFill>
                   <a:schemeClr val="tx1"/>
                 </a:solidFill>
               </a:rPr>
-              <a:t>Tacotron 2</a:t>
-            </a:r>
-            <a:endParaRPr lang="en-US" sz="1300" dirty="0"/>
+              <a:t>Tacotron 2: reference only</a:t>
+            </a:r>
+            <a:endParaRPr lang="en-US" sz="1200" dirty="0"/>
           </a:p>
           <a:p>
             <a:pPr indent="0" marL="0">
               <a:buNone/>
             </a:pPr>
             <a:r>
-              <a:rPr lang="en-US" sz="1300" dirty="0">
+              <a:rPr lang="en-US" sz="1200" dirty="0">
                 <a:solidFill>
                   <a:schemeClr val="tx1"/>
                 </a:solidFill>
               </a:rPr>
-              <a:t>torchaudio, trained on LJ Speech</a:t>
-            </a:r>
-            <a:endParaRPr lang="en-US" sz="1300" dirty="0"/>
+              <a:t>torchaudio, trained for days on GPUs</a:t>
+            </a:r>
+            <a:endParaRPr lang="en-US" sz="1200" dirty="0"/>
           </a:p>
           <a:p>
             <a:pPr indent="0" marL="0">
@@ -9278,35 +10221,77 @@
               </a:rPr>
               <a:t> </a:t>
             </a:r>
-            <a:endParaRPr lang="en-US" sz="1300" dirty="0"/>
+            <a:endParaRPr lang="en-US" sz="1200" dirty="0"/>
           </a:p>
           <a:p>
             <a:pPr indent="0" marL="0">
               <a:buNone/>
             </a:pPr>
             <a:r>
-              <a:rPr lang="en-US" sz="1300" b="1" dirty="0">
+              <a:rPr lang="en-US" sz="1200" b="1" dirty="0">
                 <a:solidFill>
                   <a:schemeClr val="tx1"/>
                 </a:solidFill>
               </a:rPr>
               <a:t>HiFi-GAN vocoder</a:t>
             </a:r>
-            <a:endParaRPr lang="en-US" sz="1300" dirty="0"/>
+            <a:endParaRPr lang="en-US" sz="1200" dirty="0"/>
           </a:p>
           <a:p>
             <a:pPr indent="0" marL="0">
               <a:buNone/>
             </a:pPr>
             <a:r>
-              <a:rPr lang="en-US" sz="1300" dirty="0">
+              <a:rPr lang="en-US" sz="1200" dirty="0">
                 <a:solidFill>
                   <a:schemeClr val="tx1"/>
                 </a:solidFill>
               </a:rPr>
-              <a:t>SpeechBrain, trained on LJ Speech</a:t>
-            </a:r>
-            <a:endParaRPr lang="en-US" sz="1300" dirty="0"/>
+              <a:t>SpeechBrain, mel → audio</a:t>
+            </a:r>
+            <a:endParaRPr lang="en-US" sz="1200" dirty="0"/>
+          </a:p>
+          <a:p>
+            <a:pPr indent="0" marL="0">
+              <a:buNone/>
+            </a:pPr>
+            <a:r>
+              <a:rPr lang="en-US" sz="600" dirty="0">
+                <a:solidFill>
+                  <a:schemeClr val="tx1"/>
+                </a:solidFill>
+              </a:rPr>
+              <a:t> </a:t>
+            </a:r>
+            <a:endParaRPr lang="en-US" sz="1200" dirty="0"/>
+          </a:p>
+          <a:p>
+            <a:pPr indent="0" marL="0">
+              <a:buNone/>
+            </a:pPr>
+            <a:r>
+              <a:rPr lang="en-US" sz="1200" b="1" dirty="0">
+                <a:solidFill>
+                  <a:schemeClr val="tx1"/>
+                </a:solidFill>
+              </a:rPr>
+              <a:t>wav2vec 2.0 recogniser</a:t>
+            </a:r>
+            <a:endParaRPr lang="en-US" sz="1200" dirty="0"/>
+          </a:p>
+          <a:p>
+            <a:pPr indent="0" marL="0">
+              <a:buNone/>
+            </a:pPr>
+            <a:r>
+              <a:rPr lang="en-US" sz="1200" dirty="0">
+                <a:solidFill>
+                  <a:schemeClr val="tx1"/>
+                </a:solidFill>
+              </a:rPr>
+              <a:t>only used to score intelligibility</a:t>
+            </a:r>
+            <a:endParaRPr lang="en-US" sz="1200" dirty="0"/>
           </a:p>
         </p:txBody>
       </p:sp>
@@ -9318,8 +10303,8 @@
         </p:nvSpPr>
         <p:spPr>
           <a:xfrm>
-            <a:off x="5577840" y="3383280"/>
-            <a:ext cx="3108960" cy="1097280"/>
+            <a:off x="5577840" y="3749040"/>
+            <a:ext cx="3108960" cy="777240"/>
           </a:xfrm>
           <a:prstGeom prst="rect">
             <a:avLst/>
@@ -9335,25 +10320,25 @@
               <a:buNone/>
             </a:pPr>
             <a:r>
-              <a:rPr lang="en-US" sz="1300" b="1" dirty="0">
+              <a:rPr lang="en-US" sz="1200" b="1" dirty="0">
                 <a:solidFill>
                   <a:schemeClr val="tx1"/>
                 </a:solidFill>
               </a:rPr>
-              <a:t>Why: </a:t>
+              <a:t>Tacotron 2 is the yardstick: </a:t>
             </a:r>
             <a:pPr indent="0" marL="0">
               <a:buNone/>
             </a:pPr>
             <a:r>
-              <a:rPr lang="en-US" sz="1300" dirty="0">
+              <a:rPr lang="en-US" sz="1200" dirty="0">
                 <a:solidFill>
                   <a:schemeClr val="tx1"/>
                 </a:solidFill>
               </a:rPr>
-              <a:t>training Tacotron 2 takes days on GPUs. We had one week and laptop CPUs.</a:t>
-            </a:r>
-            <a:endParaRPr lang="en-US" sz="1300" dirty="0"/>
+              <a:t>the same model family as Colatron, at full scale.</a:t>
+            </a:r>
+            <a:endParaRPr lang="en-US" sz="1200" dirty="0"/>
           </a:p>
         </p:txBody>
       </p:sp>
@@ -9576,7 +10561,7 @@
                 <a:ea typeface="Arial" pitchFamily="34" charset="-122"/>
                 <a:cs typeface="Arial" pitchFamily="34" charset="-120"/>
               </a:rPr>
-              <a:t>~24 h</a:t>
+              <a:t>23.9 h</a:t>
             </a:r>
             <a:endParaRPr lang="en-US" sz="2800" dirty="0"/>
           </a:p>
@@ -9651,7 +10636,7 @@
                 <a:ea typeface="Arial" pitchFamily="34" charset="-122"/>
                 <a:cs typeface="Arial" pitchFamily="34" charset="-120"/>
               </a:rPr>
-              <a:t>404</a:t>
+              <a:t>12,960</a:t>
             </a:r>
             <a:endParaRPr lang="en-US" sz="2800" dirty="0"/>
           </a:p>
@@ -9687,7 +10672,7 @@
                   <a:schemeClr val="accent6"/>
                 </a:solidFill>
               </a:rPr>
-              <a:t>clips in our subset</a:t>
+              <a:t>clips used for training</a:t>
             </a:r>
             <a:endParaRPr lang="en-US" sz="1200" dirty="0"/>
           </a:p>
@@ -9726,7 +10711,7 @@
                 <a:ea typeface="Arial" pitchFamily="34" charset="-122"/>
                 <a:cs typeface="Arial" pitchFamily="34" charset="-120"/>
               </a:rPr>
-              <a:t>324 / 40 / 40</a:t>
+              <a:t>100 / 40</a:t>
             </a:r>
             <a:endParaRPr lang="en-US" sz="2800" dirty="0"/>
           </a:p>
@@ -9762,7 +10747,7 @@
                   <a:schemeClr val="accent6"/>
                 </a:solidFill>
               </a:rPr>
-              <a:t>train / val / test clips</a:t>
+              <a:t>validation / test clips</a:t>
             </a:r>
             <a:endParaRPr lang="en-US" sz="1200" dirty="0"/>
           </a:p>
@@ -9956,7 +10941,7 @@
                   <a:schemeClr val="tx1"/>
                 </a:solidFill>
               </a:rPr>
-              <a:t>Cached to disk once, instead of recomputed every run</a:t>
+              <a:t>All 13,100 mels computed once in parallel, kept in memory (1.2 GB)</a:t>
             </a:r>
             <a:endParaRPr lang="en-US" sz="1400" dirty="0"/>
           </a:p>
@@ -9974,7 +10959,7 @@
                   <a:schemeClr val="tx1"/>
                 </a:solidFill>
               </a:rPr>
-              <a:t>Sanity check: plot a real mel and turn it back into audio</a:t>
+              <a:t>Same 40 test clips as the baseline; never used for training</a:t>
             </a:r>
             <a:endParaRPr lang="en-US" sz="1400" dirty="0"/>
           </a:p>
@@ -10085,7 +11070,7 @@
                 <a:ea typeface="Arial" pitchFamily="34" charset="-122"/>
                 <a:cs typeface="Arial" pitchFamily="34" charset="-120"/>
               </a:rPr>
-              <a:t>Baseline: trained from scratch</a:t>
+              <a:t>Baseline: no attention</a:t>
             </a:r>
             <a:endParaRPr lang="en-US" sz="3000" dirty="0"/>
           </a:p>
@@ -10539,7 +11524,7 @@
                   <a:schemeClr val="tx1"/>
                 </a:solidFill>
               </a:rPr>
-              <a:t>L1 loss on normalised mel frames</a:t>
+              <a:t>324 training clips, 911k parameters</a:t>
             </a:r>
             <a:endParaRPr lang="en-US" sz="1400" dirty="0"/>
           </a:p>
@@ -10557,7 +11542,7 @@
                   <a:schemeClr val="tx1"/>
                 </a:solidFill>
               </a:rPr>
-              <a:t>Adam, learning rate 1e-3, gradient clipping 1.0</a:t>
+              <a:t>L1 loss on normalised mel frames</a:t>
             </a:r>
             <a:endParaRPr lang="en-US" sz="1400" dirty="0"/>
           </a:p>
@@ -10575,7 +11560,7 @@
                   <a:schemeClr val="tx1"/>
                 </a:solidFill>
               </a:rPr>
-              <a:t>60 epochs, batch 16, best validation checkpoint</a:t>
+              <a:t>Adam, learning rate 1e-3, gradient clipping 1.0</a:t>
             </a:r>
             <a:endParaRPr lang="en-US" sz="1400" dirty="0"/>
           </a:p>
@@ -10593,7 +11578,7 @@
                   <a:schemeClr val="tx1"/>
                 </a:solidFill>
               </a:rPr>
-              <a:t>Mels normalised per band (mean / std)</a:t>
+              <a:t>60 epochs, batch 16, best validation checkpoint</a:t>
             </a:r>
             <a:endParaRPr lang="en-US" sz="1400" dirty="0"/>
           </a:p>
@@ -10640,7 +11625,7 @@
                   <a:schemeClr val="tx1"/>
                 </a:solidFill>
               </a:rPr>
-              <a:t>Like the paper's simple models, it has no learned alignment: each character just gets an equal share of time. It shows what happens without attention and data.</a:t>
+              <a:t>Like the paper's simple models, it has no learned alignment: each character gets an equal share of time. It shows what happens without attention.</a:t>
             </a:r>
             <a:endParaRPr lang="en-US" sz="1400" dirty="0"/>
           </a:p>
@@ -10751,7 +11736,7 @@
                 <a:ea typeface="Arial" pitchFamily="34" charset="-122"/>
                 <a:cs typeface="Arial" pitchFamily="34" charset="-120"/>
               </a:rPr>
-              <a:t>Main system: Tacotron 2</a:t>
+              <a:t>Colatron: our seq2seq model</a:t>
             </a:r>
             <a:endParaRPr lang="en-US" sz="3000" dirty="0"/>
           </a:p>
@@ -10759,7 +11744,7 @@
       </p:sp>
       <p:sp>
         <p:nvSpPr>
-          <p:cNvPr id="3" name="Tacotron part 1 circle"/>
+          <p:cNvPr id="3" name="Colatron part 1 circle"/>
           <p:cNvSpPr/>
           <p:nvPr/>
         </p:nvSpPr>
@@ -10784,7 +11769,7 @@
       </p:sp>
       <p:sp>
         <p:nvSpPr>
-          <p:cNvPr id="4" name="Tacotron part 1 label"/>
+          <p:cNvPr id="4" name="Colatron part 1 label"/>
           <p:cNvSpPr txBox="1"/>
           <p:nvPr/>
         </p:nvSpPr>
@@ -10820,14 +11805,14 @@
       </p:sp>
       <p:sp>
         <p:nvSpPr>
-          <p:cNvPr id="5" name="Tacotron part 1 name"/>
+          <p:cNvPr id="5" name="Colatron part 1 name"/>
           <p:cNvSpPr txBox="1"/>
           <p:nvPr/>
         </p:nvSpPr>
         <p:spPr>
           <a:xfrm>
             <a:off x="1005840" y="1097280"/>
-            <a:ext cx="3657600" cy="320040"/>
+            <a:ext cx="3840480" cy="320040"/>
           </a:xfrm>
           <a:prstGeom prst="rect">
             <a:avLst/>
@@ -10856,14 +11841,14 @@
       </p:sp>
       <p:sp>
         <p:nvSpPr>
-          <p:cNvPr id="6" name="Tacotron part 1 body"/>
+          <p:cNvPr id="6" name="Colatron part 1 body"/>
           <p:cNvSpPr txBox="1"/>
           <p:nvPr/>
         </p:nvSpPr>
         <p:spPr>
           <a:xfrm>
             <a:off x="1005840" y="1417320"/>
-            <a:ext cx="3657600" cy="457200"/>
+            <a:ext cx="3840480" cy="457200"/>
           </a:xfrm>
           <a:prstGeom prst="rect">
             <a:avLst/>
@@ -10892,7 +11877,7 @@
       </p:sp>
       <p:sp>
         <p:nvSpPr>
-          <p:cNvPr id="7" name="Tacotron part 2 circle"/>
+          <p:cNvPr id="7" name="Colatron part 2 circle"/>
           <p:cNvSpPr/>
           <p:nvPr/>
         </p:nvSpPr>
@@ -10917,7 +11902,7 @@
       </p:sp>
       <p:sp>
         <p:nvSpPr>
-          <p:cNvPr id="8" name="Tacotron part 2 label"/>
+          <p:cNvPr id="8" name="Colatron part 2 label"/>
           <p:cNvSpPr txBox="1"/>
           <p:nvPr/>
         </p:nvSpPr>
@@ -10953,14 +11938,14 @@
       </p:sp>
       <p:sp>
         <p:nvSpPr>
-          <p:cNvPr id="9" name="Tacotron part 2 name"/>
+          <p:cNvPr id="9" name="Colatron part 2 name"/>
           <p:cNvSpPr txBox="1"/>
           <p:nvPr/>
         </p:nvSpPr>
         <p:spPr>
           <a:xfrm>
             <a:off x="1005840" y="1938528"/>
-            <a:ext cx="3657600" cy="320040"/>
+            <a:ext cx="3840480" cy="320040"/>
           </a:xfrm>
           <a:prstGeom prst="rect">
             <a:avLst/>
@@ -10981,7 +11966,7 @@
                   <a:schemeClr val="tx1"/>
                 </a:solidFill>
               </a:rPr>
-              <a:t>Attention</a:t>
+              <a:t>Location-sensitive attention</a:t>
             </a:r>
             <a:endParaRPr lang="en-US" sz="1600" dirty="0"/>
           </a:p>
@@ -10989,14 +11974,14 @@
       </p:sp>
       <p:sp>
         <p:nvSpPr>
-          <p:cNvPr id="10" name="Tacotron part 2 body"/>
+          <p:cNvPr id="10" name="Colatron part 2 body"/>
           <p:cNvSpPr txBox="1"/>
           <p:nvPr/>
         </p:nvSpPr>
         <p:spPr>
           <a:xfrm>
             <a:off x="1005840" y="2258568"/>
-            <a:ext cx="3657600" cy="457200"/>
+            <a:ext cx="3840480" cy="457200"/>
           </a:xfrm>
           <a:prstGeom prst="rect">
             <a:avLst/>
@@ -11017,7 +12002,7 @@
                   <a:schemeClr val="accent6"/>
                 </a:solidFill>
               </a:rPr>
-              <a:t>location-sensitive: uses where it looked last step, so it moves forward</a:t>
+              <a:t>sees where it looked before, so it moves forward through the text</a:t>
             </a:r>
             <a:endParaRPr lang="en-US" sz="1300" dirty="0"/>
           </a:p>
@@ -11025,7 +12010,7 @@
       </p:sp>
       <p:sp>
         <p:nvSpPr>
-          <p:cNvPr id="11" name="Tacotron part 3 circle"/>
+          <p:cNvPr id="11" name="Colatron part 3 circle"/>
           <p:cNvSpPr/>
           <p:nvPr/>
         </p:nvSpPr>
@@ -11050,7 +12035,7 @@
       </p:sp>
       <p:sp>
         <p:nvSpPr>
-          <p:cNvPr id="12" name="Tacotron part 3 label"/>
+          <p:cNvPr id="12" name="Colatron part 3 label"/>
           <p:cNvSpPr txBox="1"/>
           <p:nvPr/>
         </p:nvSpPr>
@@ -11086,14 +12071,14 @@
       </p:sp>
       <p:sp>
         <p:nvSpPr>
-          <p:cNvPr id="13" name="Tacotron part 3 name"/>
+          <p:cNvPr id="13" name="Colatron part 3 name"/>
           <p:cNvSpPr txBox="1"/>
           <p:nvPr/>
         </p:nvSpPr>
         <p:spPr>
           <a:xfrm>
             <a:off x="1005840" y="2779776"/>
-            <a:ext cx="3657600" cy="320040"/>
+            <a:ext cx="3840480" cy="320040"/>
           </a:xfrm>
           <a:prstGeom prst="rect">
             <a:avLst/>
@@ -11122,14 +12107,14 @@
       </p:sp>
       <p:sp>
         <p:nvSpPr>
-          <p:cNvPr id="14" name="Tacotron part 3 body"/>
+          <p:cNvPr id="14" name="Colatron part 3 body"/>
           <p:cNvSpPr txBox="1"/>
           <p:nvPr/>
         </p:nvSpPr>
         <p:spPr>
           <a:xfrm>
             <a:off x="1005840" y="3099816"/>
-            <a:ext cx="3657600" cy="457200"/>
+            <a:ext cx="3840480" cy="457200"/>
           </a:xfrm>
           <a:prstGeom prst="rect">
             <a:avLst/>
@@ -11150,7 +12135,7 @@
                   <a:schemeClr val="accent6"/>
                 </a:solidFill>
               </a:rPr>
-              <a:t>LSTMs predict one mel frame at a time, plus a stop signal</a:t>
+              <a:t>LSTMs predict 3 mel frames per step, plus a stop signal</a:t>
             </a:r>
             <a:endParaRPr lang="en-US" sz="1300" dirty="0"/>
           </a:p>
@@ -11158,7 +12143,7 @@
       </p:sp>
       <p:sp>
         <p:nvSpPr>
-          <p:cNvPr id="15" name="Tacotron part 4 circle"/>
+          <p:cNvPr id="15" name="Colatron part 4 circle"/>
           <p:cNvSpPr/>
           <p:nvPr/>
         </p:nvSpPr>
@@ -11183,7 +12168,7 @@
       </p:sp>
       <p:sp>
         <p:nvSpPr>
-          <p:cNvPr id="16" name="Tacotron part 4 label"/>
+          <p:cNvPr id="16" name="Colatron part 4 label"/>
           <p:cNvSpPr txBox="1"/>
           <p:nvPr/>
         </p:nvSpPr>
@@ -11219,14 +12204,14 @@
       </p:sp>
       <p:sp>
         <p:nvSpPr>
-          <p:cNvPr id="17" name="Tacotron part 4 name"/>
+          <p:cNvPr id="17" name="Colatron part 4 name"/>
           <p:cNvSpPr txBox="1"/>
           <p:nvPr/>
         </p:nvSpPr>
         <p:spPr>
           <a:xfrm>
             <a:off x="1005840" y="3621024"/>
-            <a:ext cx="3657600" cy="320040"/>
+            <a:ext cx="3840480" cy="320040"/>
           </a:xfrm>
           <a:prstGeom prst="rect">
             <a:avLst/>
@@ -11255,14 +12240,14 @@
       </p:sp>
       <p:sp>
         <p:nvSpPr>
-          <p:cNvPr id="18" name="Tacotron part 4 body"/>
+          <p:cNvPr id="18" name="Colatron part 4 body"/>
           <p:cNvSpPr txBox="1"/>
           <p:nvPr/>
         </p:nvSpPr>
         <p:spPr>
           <a:xfrm>
             <a:off x="1005840" y="3941064"/>
-            <a:ext cx="3657600" cy="457200"/>
+            <a:ext cx="3840480" cy="457200"/>
           </a:xfrm>
           <a:prstGeom prst="rect">
             <a:avLst/>
@@ -11283,7 +12268,7 @@
                   <a:schemeClr val="accent6"/>
                 </a:solidFill>
               </a:rPr>
-              <a:t>5 convolutions refine the whole spectrogram</a:t>
+              <a:t>5 convolutions sharpen the whole spectrogram</a:t>
             </a:r>
             <a:endParaRPr lang="en-US" sz="1300" dirty="0"/>
           </a:p>
@@ -11291,18 +12276,18 @@
       </p:sp>
       <p:sp>
         <p:nvSpPr>
-          <p:cNvPr id="19" name="Wrapper card"/>
+          <p:cNvPr id="19" name="Training card"/>
           <p:cNvSpPr/>
           <p:nvPr/>
         </p:nvSpPr>
         <p:spPr>
           <a:xfrm>
             <a:off x="5120640" y="1097280"/>
-            <a:ext cx="3566160" cy="2743200"/>
+            <a:ext cx="3566160" cy="3429000"/>
           </a:xfrm>
           <a:prstGeom prst="roundRect">
             <a:avLst>
-              <a:gd name="adj" fmla="val 2667"/>
+              <a:gd name="adj" fmla="val 2133"/>
             </a:avLst>
           </a:prstGeom>
           <a:solidFill>
@@ -11318,14 +12303,14 @@
       </p:sp>
       <p:sp>
         <p:nvSpPr>
-          <p:cNvPr id="20" name="Wrapper text"/>
+          <p:cNvPr id="20" name="Training text"/>
           <p:cNvSpPr txBox="1"/>
           <p:nvPr/>
         </p:nvSpPr>
         <p:spPr>
           <a:xfrm>
             <a:off x="5303520" y="1234440"/>
-            <a:ext cx="3200400" cy="2514600"/>
+            <a:ext cx="3200400" cy="3200400"/>
           </a:xfrm>
           <a:prstGeom prst="rect">
             <a:avLst/>
@@ -11349,7 +12334,7 @@
                   <a:schemeClr val="accent1"/>
                 </a:solidFill>
               </a:rPr>
-              <a:t>What we did with it</a:t>
+              <a:t>Training, from scratch</a:t>
             </a:r>
             <a:endParaRPr lang="en-US" sz="1300" dirty="0"/>
           </a:p>
@@ -11384,7 +12369,7 @@
                   <a:schemeClr val="tx1"/>
                 </a:solidFill>
               </a:rPr>
-              <a:t>Loaded torchaudio's LJ Speech checkpoint</a:t>
+              <a:t>7.4M parameters (Tacotron 2: 28M)</a:t>
             </a:r>
             <a:endParaRPr lang="en-US" sz="1300" dirty="0"/>
           </a:p>
@@ -11402,7 +12387,7 @@
                   <a:schemeClr val="tx1"/>
                 </a:solidFill>
               </a:rPr>
-              <a:t>Chose the standard mel format so Griffin-Lim and HiFi-GAN read the same mel</a:t>
+              <a:t>Loss: L1 + MSE on mels, stop-token BCE, guided attention</a:t>
             </a:r>
             <a:endParaRPr lang="en-US" sz="1300" dirty="0"/>
           </a:p>
@@ -11420,7 +12405,7 @@
                   <a:schemeClr val="tx1"/>
                 </a:solidFill>
               </a:rPr>
-              <a:t>Exposed mel + alignment for analysis</a:t>
+              <a:t>Guided attention penalises weights far from the diagonal</a:t>
             </a:r>
             <a:endParaRPr lang="en-US" sz="1300" dirty="0"/>
           </a:p>
@@ -11438,7 +12423,25 @@
                   <a:schemeClr val="tx1"/>
                 </a:solidFill>
               </a:rPr>
-              <a:t>Fixed seeds so samples are reproducible (its prenet keeps dropout on)</a:t>
+              <a:t>Adam 1e-3, gradient clipping 1.0</a:t>
+            </a:r>
+            <a:endParaRPr lang="en-US" sz="1300" dirty="0"/>
+          </a:p>
+          <a:p>
+            <a:pPr marL="342900" indent="-342900">
+              <a:spcAft>
+                <a:spcPts val="600"/>
+              </a:spcAft>
+              <a:buSzPct val="100000"/>
+              <a:buChar char="•"/>
+            </a:pPr>
+            <a:r>
+              <a:rPr lang="en-US" sz="1300" dirty="0">
+                <a:solidFill>
+                  <a:schemeClr val="tx1"/>
+                </a:solidFill>
+              </a:rPr>
+              <a:t>5,000 steps, 2.2 h: laptop CPU, then a free Colab T4 GPU</a:t>
             </a:r>
             <a:endParaRPr lang="en-US" sz="1300" dirty="0"/>
           </a:p>
@@ -11549,49 +12552,46 @@
                 <a:ea typeface="Arial" pitchFamily="34" charset="-122"/>
                 <a:cs typeface="Arial" pitchFamily="34" charset="-120"/>
               </a:rPr>
-              <a:t>Vocoders: speed and quality</a:t>
+              <a:t>Attention learns to read in order</a:t>
             </a:r>
             <a:endParaRPr lang="en-US" sz="3000" dirty="0"/>
           </a:p>
         </p:txBody>
       </p:sp>
-      <p:sp>
-        <p:nvSpPr>
-          <p:cNvPr id="3" name="Vocoder card 1"/>
-          <p:cNvSpPr/>
-          <p:nvPr/>
-        </p:nvSpPr>
-        <p:spPr>
-          <a:xfrm>
-            <a:off x="457200" y="1097280"/>
-            <a:ext cx="4023360" cy="2880360"/>
-          </a:xfrm>
-          <a:prstGeom prst="roundRect">
-            <a:avLst>
-              <a:gd name="adj" fmla="val 2540"/>
-            </a:avLst>
-          </a:prstGeom>
-          <a:solidFill>
-            <a:schemeClr val="bg2"/>
-          </a:solidFill>
-          <a:ln w="12700">
-            <a:solidFill>
-              <a:schemeClr val="bg2"/>
-            </a:solidFill>
-            <a:prstDash val="solid"/>
-          </a:ln>
-        </p:spPr>
-      </p:sp>
-      <p:sp>
-        <p:nvSpPr>
-          <p:cNvPr id="4" name="Vocoder 1 name"/>
+      <p:pic>
+        <p:nvPicPr>
+          <p:cNvPr id="3" name="Training progress figure" descr="Colatron's attention at three training steps, validation mel loss and word error rate over training.">    </p:cNvPr>
+          <p:cNvPicPr>
+            <a:picLocks noChangeAspect="1"/>
+          </p:cNvPicPr>
+          <p:nvPr/>
+        </p:nvPicPr>
+        <p:blipFill>
+          <a:blip r:embed="rId1"/>
+          <a:stretch>
+            <a:fillRect/>
+          </a:stretch>
+        </p:blipFill>
+        <p:spPr>
+          <a:xfrm>
+            <a:off x="457200" y="1005840"/>
+            <a:ext cx="5852160" cy="3172968"/>
+          </a:xfrm>
+          <a:prstGeom prst="rect">
+            <a:avLst/>
+          </a:prstGeom>
+        </p:spPr>
+      </p:pic>
+      <p:sp>
+        <p:nvSpPr>
+          <p:cNvPr id="4" name="Monotonic value"/>
           <p:cNvSpPr txBox="1"/>
           <p:nvPr/>
         </p:nvSpPr>
         <p:spPr>
           <a:xfrm>
-            <a:off x="731520" y="1280160"/>
-            <a:ext cx="3474720" cy="365760"/>
+            <a:off x="6537960" y="1097280"/>
+            <a:ext cx="2148840" cy="640080"/>
           </a:xfrm>
           <a:prstGeom prst="rect">
             <a:avLst/>
@@ -11607,79 +12607,7 @@
               <a:buNone/>
             </a:pPr>
             <a:r>
-              <a:rPr lang="en-US" sz="2000" b="1" dirty="0">
-                <a:solidFill>
-                  <a:schemeClr val="tx1"/>
-                </a:solidFill>
-              </a:rPr>
-              <a:t>Griffin-Lim</a:t>
-            </a:r>
-            <a:endParaRPr lang="en-US" sz="2000" dirty="0"/>
-          </a:p>
-        </p:txBody>
-      </p:sp>
-      <p:sp>
-        <p:nvSpPr>
-          <p:cNvPr id="5" name="Vocoder 1 how"/>
-          <p:cNvSpPr txBox="1"/>
-          <p:nvPr/>
-        </p:nvSpPr>
-        <p:spPr>
-          <a:xfrm>
-            <a:off x="731520" y="1645920"/>
-            <a:ext cx="3474720" cy="320040"/>
-          </a:xfrm>
-          <a:prstGeom prst="rect">
-            <a:avLst/>
-          </a:prstGeom>
-          <a:noFill/>
-          <a:ln/>
-        </p:spPr>
-        <p:txBody>
-          <a:bodyPr wrap="square" lIns="0" tIns="0" rIns="0" bIns="0" rtlCol="0" anchor="ctr"/>
-          <a:lstStyle/>
-          <a:p>
-            <a:pPr indent="0" marL="0">
-              <a:buNone/>
-            </a:pPr>
-            <a:r>
-              <a:rPr lang="en-US" sz="1300" dirty="0">
-                <a:solidFill>
-                  <a:schemeClr val="accent6"/>
-                </a:solidFill>
-              </a:rPr>
-              <a:t>signal processing, no learning</a:t>
-            </a:r>
-            <a:endParaRPr lang="en-US" sz="1300" dirty="0"/>
-          </a:p>
-        </p:txBody>
-      </p:sp>
-      <p:sp>
-        <p:nvSpPr>
-          <p:cNvPr id="6" name="Vocoder 1 time"/>
-          <p:cNvSpPr txBox="1"/>
-          <p:nvPr/>
-        </p:nvSpPr>
-        <p:spPr>
-          <a:xfrm>
-            <a:off x="731520" y="2057400"/>
-            <a:ext cx="3474720" cy="731520"/>
-          </a:xfrm>
-          <a:prstGeom prst="rect">
-            <a:avLst/>
-          </a:prstGeom>
-          <a:noFill/>
-          <a:ln/>
-        </p:spPr>
-        <p:txBody>
-          <a:bodyPr wrap="square" lIns="0" tIns="0" rIns="0" bIns="0" rtlCol="0" anchor="ctr"/>
-          <a:lstStyle/>
-          <a:p>
-            <a:pPr indent="0" marL="0">
-              <a:buNone/>
-            </a:pPr>
-            <a:r>
-              <a:rPr lang="en-US" sz="4400" b="1" dirty="0">
+              <a:rPr lang="en-US" sz="3400" b="1" dirty="0">
                 <a:solidFill>
                   <a:schemeClr val="accent1"/>
                 </a:solidFill>
@@ -11687,22 +12615,22 @@
                 <a:ea typeface="Arial" pitchFamily="34" charset="-122"/>
                 <a:cs typeface="Arial" pitchFamily="34" charset="-120"/>
               </a:rPr>
-              <a:t>0.08 s</a:t>
-            </a:r>
-            <a:endParaRPr lang="en-US" sz="4400" dirty="0"/>
-          </a:p>
-        </p:txBody>
-      </p:sp>
-      <p:sp>
-        <p:nvSpPr>
-          <p:cNvPr id="7" name="Vocoder 1 unit"/>
+              <a:t>99–100%</a:t>
+            </a:r>
+            <a:endParaRPr lang="en-US" sz="3400" dirty="0"/>
+          </a:p>
+        </p:txBody>
+      </p:sp>
+      <p:sp>
+        <p:nvSpPr>
+          <p:cNvPr id="5" name="Monotonic label"/>
           <p:cNvSpPr txBox="1"/>
           <p:nvPr/>
         </p:nvSpPr>
         <p:spPr>
           <a:xfrm>
-            <a:off x="731520" y="2743200"/>
-            <a:ext cx="3474720" cy="274320"/>
+            <a:off x="6537960" y="1737360"/>
+            <a:ext cx="2148840" cy="685800"/>
           </a:xfrm>
           <a:prstGeom prst="rect">
             <a:avLst/>
@@ -11723,7 +12651,7 @@
                   <a:schemeClr val="accent6"/>
                 </a:solidFill>
               </a:rPr>
-              <a:t>to make 3.3 s of speech</a:t>
+              <a:t>of decoder steps never move backwards in the text</a:t>
             </a:r>
             <a:endParaRPr lang="en-US" sz="1200" dirty="0"/>
           </a:p>
@@ -11731,14 +12659,14 @@
       </p:sp>
       <p:sp>
         <p:nvSpPr>
-          <p:cNvPr id="8" name="Vocoder 1 verdict"/>
+          <p:cNvPr id="6" name="Progress takeaway"/>
           <p:cNvSpPr txBox="1"/>
           <p:nvPr/>
         </p:nvSpPr>
         <p:spPr>
           <a:xfrm>
-            <a:off x="731520" y="3154680"/>
-            <a:ext cx="3474720" cy="731520"/>
+            <a:off x="6537960" y="2651760"/>
+            <a:ext cx="2148840" cy="1463040"/>
           </a:xfrm>
           <a:prstGeom prst="rect">
             <a:avLst/>
@@ -11754,260 +12682,14 @@
               <a:buNone/>
             </a:pPr>
             <a:r>
-              <a:rPr lang="en-US" sz="1400" dirty="0">
+              <a:rPr lang="en-US" sz="1300" b="1" dirty="0">
                 <a:solidFill>
                   <a:schemeClr val="tx1"/>
                 </a:solidFill>
               </a:rPr>
-              <a:t>Fast and intelligible, but slightly metallic: it has to guess the phase the mel throws away</a:t>
-            </a:r>
-            <a:endParaRPr lang="en-US" sz="1400" dirty="0"/>
-          </a:p>
-        </p:txBody>
-      </p:sp>
-      <p:sp>
-        <p:nvSpPr>
-          <p:cNvPr id="9" name="Vocoder card 2"/>
-          <p:cNvSpPr/>
-          <p:nvPr/>
-        </p:nvSpPr>
-        <p:spPr>
-          <a:xfrm>
-            <a:off x="4663440" y="1097280"/>
-            <a:ext cx="4023360" cy="2880360"/>
-          </a:xfrm>
-          <a:prstGeom prst="roundRect">
-            <a:avLst>
-              <a:gd name="adj" fmla="val 2540"/>
-            </a:avLst>
-          </a:prstGeom>
-          <a:solidFill>
-            <a:schemeClr val="bg2"/>
-          </a:solidFill>
-          <a:ln w="12700">
-            <a:solidFill>
-              <a:schemeClr val="bg2"/>
-            </a:solidFill>
-            <a:prstDash val="solid"/>
-          </a:ln>
-        </p:spPr>
-      </p:sp>
-      <p:sp>
-        <p:nvSpPr>
-          <p:cNvPr id="10" name="Vocoder 2 name"/>
-          <p:cNvSpPr txBox="1"/>
-          <p:nvPr/>
-        </p:nvSpPr>
-        <p:spPr>
-          <a:xfrm>
-            <a:off x="4937760" y="1280160"/>
-            <a:ext cx="3474720" cy="365760"/>
-          </a:xfrm>
-          <a:prstGeom prst="rect">
-            <a:avLst/>
-          </a:prstGeom>
-          <a:noFill/>
-          <a:ln/>
-        </p:spPr>
-        <p:txBody>
-          <a:bodyPr wrap="square" lIns="0" tIns="0" rIns="0" bIns="0" rtlCol="0" anchor="ctr"/>
-          <a:lstStyle/>
-          <a:p>
-            <a:pPr indent="0" marL="0">
-              <a:buNone/>
-            </a:pPr>
-            <a:r>
-              <a:rPr lang="en-US" sz="2000" b="1" dirty="0">
-                <a:solidFill>
-                  <a:schemeClr val="tx1"/>
-                </a:solidFill>
-              </a:rPr>
-              <a:t>HiFi-GAN</a:t>
-            </a:r>
-            <a:endParaRPr lang="en-US" sz="2000" dirty="0"/>
-          </a:p>
-        </p:txBody>
-      </p:sp>
-      <p:sp>
-        <p:nvSpPr>
-          <p:cNvPr id="11" name="Vocoder 2 how"/>
-          <p:cNvSpPr txBox="1"/>
-          <p:nvPr/>
-        </p:nvSpPr>
-        <p:spPr>
-          <a:xfrm>
-            <a:off x="4937760" y="1645920"/>
-            <a:ext cx="3474720" cy="320040"/>
-          </a:xfrm>
-          <a:prstGeom prst="rect">
-            <a:avLst/>
-          </a:prstGeom>
-          <a:noFill/>
-          <a:ln/>
-        </p:spPr>
-        <p:txBody>
-          <a:bodyPr wrap="square" lIns="0" tIns="0" rIns="0" bIns="0" rtlCol="0" anchor="ctr"/>
-          <a:lstStyle/>
-          <a:p>
-            <a:pPr indent="0" marL="0">
-              <a:buNone/>
-            </a:pPr>
-            <a:r>
-              <a:rPr lang="en-US" sz="1300" dirty="0">
-                <a:solidFill>
-                  <a:schemeClr val="accent6"/>
-                </a:solidFill>
-              </a:rPr>
-              <a:t>neural network (GAN), all frames in parallel</a:t>
+              <a:t>The diagonal appears within the first 500 steps: the guided attention loss fixes the 2018 failure.</a:t>
             </a:r>
             <a:endParaRPr lang="en-US" sz="1300" dirty="0"/>
-          </a:p>
-        </p:txBody>
-      </p:sp>
-      <p:sp>
-        <p:nvSpPr>
-          <p:cNvPr id="12" name="Vocoder 2 time"/>
-          <p:cNvSpPr txBox="1"/>
-          <p:nvPr/>
-        </p:nvSpPr>
-        <p:spPr>
-          <a:xfrm>
-            <a:off x="4937760" y="2057400"/>
-            <a:ext cx="3474720" cy="731520"/>
-          </a:xfrm>
-          <a:prstGeom prst="rect">
-            <a:avLst/>
-          </a:prstGeom>
-          <a:noFill/>
-          <a:ln/>
-        </p:spPr>
-        <p:txBody>
-          <a:bodyPr wrap="square" lIns="0" tIns="0" rIns="0" bIns="0" rtlCol="0" anchor="ctr"/>
-          <a:lstStyle/>
-          <a:p>
-            <a:pPr indent="0" marL="0">
-              <a:buNone/>
-            </a:pPr>
-            <a:r>
-              <a:rPr lang="en-US" sz="4400" b="1" dirty="0">
-                <a:solidFill>
-                  <a:schemeClr val="accent4"/>
-                </a:solidFill>
-                <a:latin typeface="Arial" pitchFamily="34" charset="0"/>
-                <a:ea typeface="Arial" pitchFamily="34" charset="-122"/>
-                <a:cs typeface="Arial" pitchFamily="34" charset="-120"/>
-              </a:rPr>
-              <a:t>0.65 s</a:t>
-            </a:r>
-            <a:endParaRPr lang="en-US" sz="4400" dirty="0"/>
-          </a:p>
-        </p:txBody>
-      </p:sp>
-      <p:sp>
-        <p:nvSpPr>
-          <p:cNvPr id="13" name="Vocoder 2 unit"/>
-          <p:cNvSpPr txBox="1"/>
-          <p:nvPr/>
-        </p:nvSpPr>
-        <p:spPr>
-          <a:xfrm>
-            <a:off x="4937760" y="2743200"/>
-            <a:ext cx="3474720" cy="274320"/>
-          </a:xfrm>
-          <a:prstGeom prst="rect">
-            <a:avLst/>
-          </a:prstGeom>
-          <a:noFill/>
-          <a:ln/>
-        </p:spPr>
-        <p:txBody>
-          <a:bodyPr wrap="square" lIns="0" tIns="0" rIns="0" bIns="0" rtlCol="0" anchor="ctr"/>
-          <a:lstStyle/>
-          <a:p>
-            <a:pPr indent="0" marL="0">
-              <a:buNone/>
-            </a:pPr>
-            <a:r>
-              <a:rPr lang="en-US" sz="1200" dirty="0">
-                <a:solidFill>
-                  <a:schemeClr val="accent6"/>
-                </a:solidFill>
-              </a:rPr>
-              <a:t>to make 3.3 s of speech</a:t>
-            </a:r>
-            <a:endParaRPr lang="en-US" sz="1200" dirty="0"/>
-          </a:p>
-        </p:txBody>
-      </p:sp>
-      <p:sp>
-        <p:nvSpPr>
-          <p:cNvPr id="14" name="Vocoder 2 verdict"/>
-          <p:cNvSpPr txBox="1"/>
-          <p:nvPr/>
-        </p:nvSpPr>
-        <p:spPr>
-          <a:xfrm>
-            <a:off x="4937760" y="3154680"/>
-            <a:ext cx="3474720" cy="731520"/>
-          </a:xfrm>
-          <a:prstGeom prst="rect">
-            <a:avLst/>
-          </a:prstGeom>
-          <a:noFill/>
-          <a:ln/>
-        </p:spPr>
-        <p:txBody>
-          <a:bodyPr wrap="square" lIns="0" tIns="0" rIns="0" bIns="0" rtlCol="0" anchor="t"/>
-          <a:lstStyle/>
-          <a:p>
-            <a:pPr indent="0" marL="0">
-              <a:buNone/>
-            </a:pPr>
-            <a:r>
-              <a:rPr lang="en-US" sz="1400" dirty="0">
-                <a:solidFill>
-                  <a:schemeClr val="tx1"/>
-                </a:solidFill>
-              </a:rPr>
-              <a:t>Natural sounding, and still about 5× faster than real time</a:t>
-            </a:r>
-            <a:endParaRPr lang="en-US" sz="1400" dirty="0"/>
-          </a:p>
-        </p:txBody>
-      </p:sp>
-      <p:sp>
-        <p:nvSpPr>
-          <p:cNvPr id="15" name="Vocoder method"/>
-          <p:cNvSpPr txBox="1"/>
-          <p:nvPr/>
-        </p:nvSpPr>
-        <p:spPr>
-          <a:xfrm>
-            <a:off x="457200" y="4114800"/>
-            <a:ext cx="8229600" cy="548640"/>
-          </a:xfrm>
-          <a:prstGeom prst="rect">
-            <a:avLst/>
-          </a:prstGeom>
-          <a:noFill/>
-          <a:ln/>
-        </p:spPr>
-        <p:txBody>
-          <a:bodyPr wrap="square" lIns="0" tIns="0" rIns="0" bIns="0" rtlCol="0" anchor="ctr"/>
-          <a:lstStyle/>
-          <a:p>
-            <a:pPr indent="0" marL="0">
-              <a:buNone/>
-            </a:pPr>
-            <a:r>
-              <a:rPr lang="en-US" sz="1200" dirty="0">
-                <a:solidFill>
-                  <a:schemeClr val="accent6"/>
-                </a:solidFill>
-              </a:rPr>
-              <a:t>Same sentence on a laptop CPU. Both vocoders get the identical mel from Tacotron 2, so only the vocoder differs. Audio: samples/main_griffinlim/ and samples/main_hifigan/.</a:t>
-            </a:r>
-            <a:endParaRPr lang="en-US" sz="1200" dirty="0"/>
           </a:p>
         </p:txBody>
       </p:sp>

</xml_diff>

<commit_message>
Update results to Colatron step 18,000
</commit_message>
<xml_diff>
--- a/report/Colatron_Slides.pptx
+++ b/report/Colatron_Slides.pptx
@@ -121,14 +121,14 @@
   <p:extLst>
     <p:ext uri="{521415D9-36F7-43E2-AB2F-B90AF26B5E84}">
       <p14:sectionLst xmlns:p14="http://schemas.microsoft.com/office/powerpoint/2010/main">
-        <p14:section name="Introduction" id="{a21c2c4b-f9e5-b764-d6a3-ab6ac27b1da0}">
+        <p14:section name="Introduction" id="{73b817ab-3b8c-a674-44a0-9dcfcf7539a0}">
           <p14:sldIdLst>
             <p14:sldId id="256"/>
             <p14:sldId id="257"/>
             <p14:sldId id="258"/>
           </p14:sldIdLst>
         </p14:section>
-        <p14:section name="Approach" id="{6b08e77d-99e7-0e85-9110-c4dd00c456f3}">
+        <p14:section name="Approach" id="{8309499c-b86a-6c74-b86c-c334858c405e}">
           <p14:sldIdLst>
             <p14:sldId id="259"/>
             <p14:sldId id="260"/>
@@ -137,7 +137,7 @@
             <p14:sldId id="263"/>
           </p14:sldIdLst>
         </p14:section>
-        <p14:section name="Results" id="{7cfe2074-b49f-bba7-efd3-5dec983185ed}">
+        <p14:section name="Results" id="{db1ce793-16e7-b7a0-012a-90e4cb0d710a}">
           <p14:sldIdLst>
             <p14:sldId id="264"/>
             <p14:sldId id="265"/>
@@ -146,7 +146,7 @@
             <p14:sldId id="268"/>
           </p14:sldIdLst>
         </p14:section>
-        <p14:section name="Wrap-up" id="{53427a55-1462-1353-1cd1-23dfdb32f4ea}">
+        <p14:section name="Wrap-up" id="{21ea0b92-548d-ad77-e280-2b376d5be6c7}">
           <p14:sldIdLst>
             <p14:sldId id="269"/>
             <p14:sldId id="270"/>
@@ -659,13 +659,13 @@
                   <c:v>5.050000000000001</c:v>
                 </c:pt>
                 <c:pt idx="1">
-                  <c:v>99.55000000000001</c:v>
+                  <c:v>99.76</c:v>
                 </c:pt>
                 <c:pt idx="2">
-                  <c:v>28.610000000000003</c:v>
+                  <c:v>9.25</c:v>
                 </c:pt>
                 <c:pt idx="3">
-                  <c:v>25.22</c:v>
+                  <c:v>8.85</c:v>
                 </c:pt>
                 <c:pt idx="4">
                   <c:v>16.18</c:v>
@@ -995,13 +995,13 @@
                 <c:formatCode>General</c:formatCode>
                 <c:ptCount val="5"/>
                 <c:pt idx="0">
-                  <c:v>1.218</c:v>
+                  <c:v>1.2174</c:v>
                 </c:pt>
                 <c:pt idx="1">
-                  <c:v>0.8731</c:v>
+                  <c:v>0.8164</c:v>
                 </c:pt>
                 <c:pt idx="2">
-                  <c:v>0.8866</c:v>
+                  <c:v>0.8317</c:v>
                 </c:pt>
                 <c:pt idx="3">
                   <c:v>0.8776</c:v>
@@ -1732,7 +1732,7 @@
           <a:p>
             <a:r>
               <a:rPr lang="en-US" dirty="0"/>
-              <a:t>We have no listening test, so we use a speech recogniser as an objective listener. Word error rate is the share of words it gets wrong. Even real recordings are not 0% because the recogniser makes its own mistakes.</a:t>
+              <a:t>Numbers are for the step-18,000 checkpoint; the submitted write-up reports the earlier step-5,000 checkpoint (25% WER), training continued after submission. We have no listening test, so we use a speech recogniser as an objective listener. Word error rate is the share of words it gets wrong. Even real recordings are not 0% because the recogniser makes its own mistakes.</a:t>
             </a:r>
             <a:endParaRPr lang="en-US" dirty="0"/>
           </a:p>
@@ -5558,7 +5558,7 @@
                 <a:ea typeface="Arial" pitchFamily="34" charset="-122"/>
                 <a:cs typeface="Arial" pitchFamily="34" charset="-120"/>
               </a:rPr>
-              <a:t>25%</a:t>
+              <a:t>9%</a:t>
             </a:r>
             <a:endParaRPr lang="en-US" sz="4000" dirty="0"/>
           </a:p>
@@ -5573,7 +5573,7 @@
         <p:spPr>
           <a:xfrm>
             <a:off x="5852160" y="1737360"/>
-            <a:ext cx="2834640" cy="548640"/>
+            <a:ext cx="2834640" cy="685800"/>
           </a:xfrm>
           <a:prstGeom prst="rect">
             <a:avLst/>
@@ -5594,7 +5594,7 @@
                   <a:schemeClr val="accent6"/>
                 </a:solidFill>
               </a:rPr>
-              <a:t>word error rate for Colatron + HiFi-GAN, versus 100% for the baseline</a:t>
+              <a:t>word error rate for Colatron + HiFi-GAN, versus 100% for the baseline and 16% for Tacotron 2</a:t>
             </a:r>
             <a:endParaRPr lang="en-US" sz="1300" dirty="0"/>
           </a:p>
@@ -5620,6 +5620,24 @@
         <p:txBody>
           <a:bodyPr wrap="square" lIns="0" tIns="0" rIns="0" bIns="0" rtlCol="0" anchor="t"/>
           <a:lstStyle/>
+          <a:p>
+            <a:pPr marL="342900" indent="-342900">
+              <a:spcAft>
+                <a:spcPts val="400"/>
+              </a:spcAft>
+              <a:buSzPct val="100000"/>
+              <a:buChar char="•"/>
+            </a:pPr>
+            <a:r>
+              <a:rPr lang="en-US" sz="1200" dirty="0">
+                <a:solidFill>
+                  <a:schemeClr val="tx1"/>
+                </a:solidFill>
+              </a:rPr>
+              <a:t>Model checkpoint: step 18,000</a:t>
+            </a:r>
+            <a:endParaRPr lang="en-US" sz="1200" dirty="0"/>
+          </a:p>
           <a:p>
             <a:pPr marL="342900" indent="-342900">
               <a:spcAft>
@@ -5836,7 +5854,7 @@
                 <a:ea typeface="Arial" pitchFamily="34" charset="-122"/>
                 <a:cs typeface="Arial" pitchFamily="34" charset="-120"/>
               </a:rPr>
-              <a:t>28% lower</a:t>
+              <a:t>33% lower</a:t>
             </a:r>
             <a:endParaRPr lang="en-US" sz="3600" dirty="0"/>
           </a:p>
@@ -6657,7 +6675,7 @@
                   <a:schemeClr val="accent6"/>
                 </a:solidFill>
               </a:rPr>
-              <a:t>Without attention the baseline is 100% word error; Colatron is 25%.</a:t>
+              <a:t>Without attention the baseline is 100% word error; Colatron is 9%.</a:t>
             </a:r>
             <a:endParaRPr lang="en-US" sz="1200" dirty="0"/>
           </a:p>
@@ -6754,7 +6772,7 @@
                   <a:schemeClr val="tx1"/>
                 </a:solidFill>
               </a:rPr>
-              <a:t>Scale still matters</a:t>
+              <a:t>Understood better than the reference</a:t>
             </a:r>
             <a:endParaRPr lang="en-US" sz="1500" dirty="0"/>
           </a:p>
@@ -6790,7 +6808,7 @@
                   <a:schemeClr val="accent6"/>
                 </a:solidFill>
               </a:rPr>
-              <a:t>Pretrained Tacotron 2 (4× larger, days on GPUs) reaches 16%.</a:t>
+              <a:t>Pretrained Tacotron 2 (4× larger, days on GPUs) scores 16% on the same clips, though it still sounds more natural.</a:t>
             </a:r>
             <a:endParaRPr lang="en-US" sz="1200" dirty="0"/>
           </a:p>
@@ -6923,7 +6941,7 @@
                   <a:schemeClr val="accent6"/>
                 </a:solidFill>
               </a:rPr>
-              <a:t>2.2 h of training (laptop CPU + free Colab GPU); speaks on a laptop CPU.</a:t>
+              <a:t>5.3 h of training (laptop CPU + free Colab GPU); speaks on a laptop CPU.</a:t>
             </a:r>
             <a:endParaRPr lang="en-US" sz="1200" dirty="0"/>
           </a:p>
@@ -7024,7 +7042,7 @@
                   <a:schemeClr val="tx1"/>
                 </a:solidFill>
               </a:rPr>
-              <a:t>Colatron trained for only 2.2 h: still robotic</a:t>
+              <a:t>Less natural than Tacotron 2 (slightly robotic)</a:t>
             </a:r>
             <a:endParaRPr lang="en-US" sz="1300" dirty="0"/>
           </a:p>
@@ -12441,7 +12459,7 @@
                   <a:schemeClr val="tx1"/>
                 </a:solidFill>
               </a:rPr>
-              <a:t>5,000 steps, 2.2 h: laptop CPU, then a free Colab T4 GPU</a:t>
+              <a:t>18,000 steps, 5.3 h: laptop CPU, then a free Colab T4 GPU</a:t>
             </a:r>
             <a:endParaRPr lang="en-US" sz="1300" dirty="0"/>
           </a:p>

</xml_diff>

<commit_message>
Slides: plain-language wording, technical details moved to speaker notes
</commit_message>
<xml_diff>
--- a/report/Colatron_Slides.pptx
+++ b/report/Colatron_Slides.pptx
@@ -122,14 +122,14 @@
   <p:extLst>
     <p:ext uri="{521415D9-36F7-43E2-AB2F-B90AF26B5E84}">
       <p14:sectionLst xmlns:p14="http://schemas.microsoft.com/office/powerpoint/2010/main">
-        <p14:section name="Introduction" id="{9d8a48dd-5f4a-8bfe-09c0-c417560a96fa}">
+        <p14:section name="Introduction" id="{0ca71cc6-c3c8-7163-b21e-60dac038fd29}">
           <p14:sldIdLst>
             <p14:sldId id="256"/>
             <p14:sldId id="257"/>
             <p14:sldId id="258"/>
           </p14:sldIdLst>
         </p14:section>
-        <p14:section name="Approach" id="{6639fbcb-3eda-4bc2-6b43-34b03ad16e6f}">
+        <p14:section name="Approach" id="{c0adb9bb-553e-9821-103b-00b0213e4127}">
           <p14:sldIdLst>
             <p14:sldId id="259"/>
             <p14:sldId id="260"/>
@@ -141,14 +141,14 @@
             <p14:sldId id="266"/>
           </p14:sldIdLst>
         </p14:section>
-        <p14:section name="Results" id="{4206e3a5-c8fc-d746-7bb3-28ebb84c9d6e}">
+        <p14:section name="Results" id="{d3330bde-983d-6550-e31a-671f64f98af1}">
           <p14:sldIdLst>
             <p14:sldId id="267"/>
             <p14:sldId id="268"/>
             <p14:sldId id="269"/>
           </p14:sldIdLst>
         </p14:section>
-        <p14:section name="Wrap-up" id="{f432421e-409f-ce8b-1611-c9f29d8ce676}">
+        <p14:section name="Wrap-up" id="{0033e113-7bf5-252a-4450-52bba9e14d8c}">
           <p14:sldIdLst>
             <p14:sldId id="270"/>
             <p14:sldId id="271"/>
@@ -511,7 +511,7 @@
                 </a:solidFill>
                 <a:latin typeface="+mn-lt"/>
               </a:rPr>
-              <a:t>Word error rate of a speech recogniser (lower is better)</a:t>
+              <a:t>% of words the robot listener got wrong (lower is better)</a:t>
             </a:r>
           </a:p>
         </c:rich>
@@ -633,19 +633,22 @@
                 <c:ptCount val="5"/>
                 <c:lvl>
                   <c:pt idx="0">
-                    <c:v>Real recording</c:v>
+                    <c:v>Real voice</c:v>
                   </c:pt>
                   <c:pt idx="1">
                     <c:v>Baseline</c:v>
                   </c:pt>
                   <c:pt idx="2">
-                    <c:v>Colatron + GL</c:v>
+                    <c:v>Colatron
++ Griffin-Lim</c:v>
                   </c:pt>
                   <c:pt idx="3">
-                    <c:v>Colatron + HiFi-GAN</c:v>
+                    <c:v>Colatron
++ HiFi-GAN</c:v>
                   </c:pt>
                   <c:pt idx="4">
-                    <c:v>Tacotron 2 + HiFi-GAN</c:v>
+                    <c:v>Tacotron 2
++ HiFi-GAN</c:v>
                   </c:pt>
                 </c:lvl>
               </c:multiLvlStrCache>
@@ -850,7 +853,7 @@
                 </a:solidFill>
                 <a:latin typeface="+mn-lt"/>
               </a:rPr>
-              <a:t>Mel L1 distance to the real recording (lower is better)</a:t>
+              <a:t>How different from the real recording (lower is better)</a:t>
             </a:r>
           </a:p>
         </c:rich>
@@ -972,19 +975,24 @@
                 <c:ptCount val="5"/>
                 <c:lvl>
                   <c:pt idx="0">
-                    <c:v>Baseline + GL</c:v>
+                    <c:v>Baseline
++ Griffin-Lim</c:v>
                   </c:pt>
                   <c:pt idx="1">
-                    <c:v>Colatron + GL</c:v>
+                    <c:v>Colatron
++ Griffin-Lim</c:v>
                   </c:pt>
                   <c:pt idx="2">
-                    <c:v>Colatron + HiFi-GAN</c:v>
+                    <c:v>Colatron
++ HiFi-GAN</c:v>
                   </c:pt>
                   <c:pt idx="3">
-                    <c:v>Tacotron 2 + GL</c:v>
+                    <c:v>Tacotron 2
++ Griffin-Lim</c:v>
                   </c:pt>
                   <c:pt idx="4">
-                    <c:v>Tacotron 2 + HiFi-GAN</c:v>
+                    <c:v>Tacotron 2
++ HiFi-GAN</c:v>
                   </c:pt>
                 </c:lvl>
               </c:multiLvlStrCache>
@@ -1822,7 +1830,7 @@
           <a:p>
             <a:r>
               <a:rPr lang="en-US" dirty="0"/>
-              <a:t>Numbers are for the step-18,000 checkpoint; the submitted write-up reports the earlier step-5,000 checkpoint (25% WER), training continued after submission. We have no listening test, so we use a speech recogniser as an objective listener. Word error rate is the share of words it gets wrong. Even real recordings are not 0% because the recogniser makes its own mistakes.</a:t>
+              <a:t>Technical if asked: wav2vec 2.0 base 960h from torchaudio, trained on LibriSpeech audiobooks, never on LJ Speech; greedy decoding; WER = word error rate, CER = character error rate. Numbers are for the step-18,000 checkpoint; the submitted write-up reports the earlier step-5,000 checkpoint (25% WER), training continued after submission. We have no listening test, so we use a speech recogniser as an objective listener. Word error rate is the share of words it gets wrong. Even real recordings are not 0% because the recogniser makes its own mistakes.</a:t>
             </a:r>
             <a:endParaRPr lang="en-US" dirty="0"/>
           </a:p>
@@ -1910,7 +1918,7 @@
           <a:p>
             <a:r>
               <a:rPr lang="en-US" dirty="0"/>
-              <a:t>Mel distance compares each system's output with the real recording of the same sentence, after DTW lines them up in time. Compare bars with the same vocoder: baseline vs Colatron with Griffin-Lim, Colatron vs Tacotron 2 with HiFi-GAN.</a:t>
+              <a:t>Technical if asked: mel L1 and RMSE after DTW (dynamic time warping) alignment. Mel distance compares each system's output with the real recording of the same sentence, after DTW lines them up in time. Compare bars with the same vocoder: baseline vs Colatron with Griffin-Lim, Colatron vs Tacotron 2 with HiFi-GAN.</a:t>
             </a:r>
             <a:endParaRPr lang="en-US" dirty="0"/>
           </a:p>
@@ -2614,7 +2622,7 @@
           <a:p>
             <a:r>
               <a:rPr lang="en-US" dirty="0"/>
-              <a:t>The paper used about 200 sentences; we use all 13,100. The test clips are the same 40 the baseline was evaluated on, and none of them is ever trained on. The baseline itself was trained on a 404-clip subset (324 train).</a:t>
+              <a:t>Technical if asked: 80-band log-mel spectrogram, FFT 1024, hop 256, 0 to 8 kHz, 22,050 Hz audio. The paper used about 200 sentences; we use all 13,100. The test clips are the same 40 the baseline was evaluated on, and none of them is ever trained on. The baseline itself was trained on a 404-clip subset (324 train).</a:t>
             </a:r>
             <a:endParaRPr lang="en-US" dirty="0"/>
           </a:p>
@@ -2702,7 +2710,7 @@
           <a:p>
             <a:r>
               <a:rPr lang="en-US" dirty="0"/>
-              <a:t>This is our lower bound. The highlighted step is the key weakness: instead of learning which character to read when, it stretches the character features evenly over time. Its output is a blur and sounds like static.</a:t>
+              <a:t>Technical if asked: embedding 128, 3 Conv1D layers (256 channels, kernel 5), linear stretch to the target length, MLP to 80 mel bands; L1 loss, Adam 1e-3, batch 16, 60 epochs, 911k parameters. This is our lower bound. The highlighted step is the key weakness: instead of learning which character to read when, it stretches the character features evenly over time. Its output is a blur and sounds like static.</a:t>
             </a:r>
             <a:endParaRPr lang="en-US" dirty="0"/>
           </a:p>
@@ -2790,7 +2798,7 @@
           <a:p>
             <a:r>
               <a:rPr lang="en-US" dirty="0"/>
-              <a:t>This is the model the 2018 paper tried to build: seq2seq with attention. Three things make it work on a laptop. Location-sensitive attention remembers where it looked, so it moves forward. Predicting several frames per step means fewer decoder steps. The guided attention loss (Tachibana et al., 2017) pushes the attention towards the diagonal from the start, which is exactly the paper's failure point.</a:t>
+              <a:t>Technical if asked: embedding 256, 3 convolutions, bidirectional LSTM (2 x 128); location-sensitive attention; prenet 256/128 with dropout; attention LSTM 512 and decoder LSTM 512; 3 mel frames per step; stop token; 5-layer convolutional post-net; 7.4M parameters. This is the model the 2018 paper tried to build: seq2seq with attention. Three things make it work on a laptop. Location-sensitive attention remembers where it looked, so it moves forward. Predicting several frames per step means fewer decoder steps. The guided attention loss (Tachibana et al., 2017) pushes the attention towards the diagonal from the start, which is exactly the paper's failure point.</a:t>
             </a:r>
             <a:endParaRPr lang="en-US" dirty="0"/>
           </a:p>
@@ -2878,7 +2886,7 @@
           <a:p>
             <a:r>
               <a:rPr lang="en-US" dirty="0"/>
-              <a:t>One training step: take 64 clips, let the model draw their spectrograms, measure how wrong it is with three losses, and nudge all 7.4 million weights to be a bit less wrong. During training the decoder sees the real previous frames, which is called teacher forcing. The guided attention loss is the key one: it punishes attention that is far from the diagonal, so the model learns to read in order. Learning rate starts at 0.001 and halves every 8,000 steps after step 8,000. We started on the laptop CPU and moved to a free Colab GPU.</a:t>
+              <a:t>Technical if asked: losses are L1 + MSE on the mel, binary cross-entropy on the stop token, and guided attention loss (Tachibana et al. 2017). Adam optimiser, gradient clipping 1.0, batch 64. One training step: take 64 clips, let the model draw their spectrograms, measure how wrong it is with three losses, and nudge all 7.4 million weights to be a bit less wrong. During training the decoder sees the real previous frames, which is called teacher forcing. The guided attention loss is the key one: it punishes attention that is far from the diagonal, so the model learns to read in order. Learning rate starts at 0.001 and halves every 8,000 steps after step 8,000. We started on the laptop CPU and moved to a free Colab GPU.</a:t>
             </a:r>
             <a:endParaRPr lang="en-US" dirty="0"/>
           </a:p>
@@ -5125,7 +5133,7 @@
                   <a:schemeClr val="accent6"/>
                 </a:solidFill>
               </a:rPr>
-              <a:t>of decoder steps never move backwards in the text</a:t>
+              <a:t>of the time the finger moves forward, never back</a:t>
             </a:r>
             <a:endParaRPr lang="en-US" sz="1200" dirty="0"/>
           </a:p>
@@ -5161,7 +5169,7 @@
                   <a:schemeClr val="tx1"/>
                 </a:solidFill>
               </a:rPr>
-              <a:t>The diagonal appears within the first 500 steps: the guided attention loss fixes the 2018 failure.</a:t>
+              <a:t>The diagonal line means reading the text in order. It appeared within the first 500 rounds, which the 2018 project never managed.</a:t>
             </a:r>
             <a:endParaRPr lang="en-US" sz="1300" dirty="0"/>
           </a:p>
@@ -5371,7 +5379,7 @@
                   <a:schemeClr val="accent6"/>
                 </a:solidFill>
               </a:rPr>
-              <a:t>numbers and abbreviations to words, then ids</a:t>
+              <a:t>"$42" → "forty two dollars"</a:t>
             </a:r>
             <a:endParaRPr lang="en-US" sz="1100" dirty="0"/>
           </a:p>
@@ -5583,7 +5591,7 @@
                   <a:schemeClr val="bg1"/>
                 </a:solidFill>
               </a:rPr>
-              <a:t>Decoder loop</a:t>
+              <a:t>Decoder</a:t>
             </a:r>
             <a:endParaRPr lang="en-US" sz="1400" dirty="0"/>
           </a:p>
@@ -5619,7 +5627,7 @@
                   <a:schemeClr val="accent6"/>
                 </a:solidFill>
               </a:rPr>
-              <a:t>attention picks the letter, draws 3 frames, feeds them back in</a:t>
+              <a:t>finger on a letter, draw a few columns, repeat</a:t>
             </a:r>
             <a:endParaRPr lang="en-US" sz="1100" dirty="0"/>
           </a:p>
@@ -5743,7 +5751,7 @@
                   <a:schemeClr val="accent6"/>
                 </a:solidFill>
               </a:rPr>
-              <a:t>only stop once attention reaches the last letters</a:t>
+              <a:t>only stop once it reaches the end of the text</a:t>
             </a:r>
             <a:endParaRPr lang="en-US" sz="1100" dirty="0"/>
           </a:p>
@@ -5867,7 +5875,7 @@
                   <a:schemeClr val="accent6"/>
                 </a:solidFill>
               </a:rPr>
-              <a:t>sharpens the whole mel</a:t>
+              <a:t>cleans up the picture</a:t>
             </a:r>
             <a:endParaRPr lang="en-US" sz="1100" dirty="0"/>
           </a:p>
@@ -5991,7 +5999,7 @@
                   <a:schemeClr val="accent6"/>
                 </a:solidFill>
               </a:rPr>
-              <a:t>mel → audio</a:t>
+              <a:t>picture → audio</a:t>
             </a:r>
             <a:endParaRPr lang="en-US" sz="1100" dirty="0"/>
           </a:p>
@@ -6068,7 +6076,7 @@
                   <a:schemeClr val="tx1"/>
                 </a:solidFill>
               </a:rPr>
-              <a:t>In training the decoder saw the real previous frames. Now it feeds itself its own output, frame by frame, until the stop rule fires.</a:t>
+              <a:t>In training it could peek at the real recording. Now it only has its own drawing to continue from, until it reaches the end of the text.</a:t>
             </a:r>
             <a:endParaRPr lang="en-US" sz="1200" dirty="0"/>
           </a:p>
@@ -6131,7 +6139,7 @@
                   <a:schemeClr val="accent4"/>
                 </a:solidFill>
               </a:rPr>
-              <a:t>The vocoder only turns our mel into sound</a:t>
+              <a:t>The vocoder only turns our picture into sound</a:t>
             </a:r>
             <a:endParaRPr lang="en-US" sz="1200" dirty="0"/>
           </a:p>
@@ -6146,7 +6154,7 @@
                   <a:schemeClr val="tx1"/>
                 </a:solidFill>
               </a:rPr>
-              <a:t>Griffin-Lim (a formula, no learning): 9.3% WER, robotic.</a:t>
+              <a:t>Griffin-Lim (simple, no AI): 9.3% of words wrong, robotic</a:t>
             </a:r>
             <a:endParaRPr lang="en-US" sz="1200" dirty="0"/>
           </a:p>
@@ -6161,7 +6169,7 @@
                   <a:schemeClr val="tx1"/>
                 </a:solidFill>
               </a:rPr>
-              <a:t>HiFi-GAN (pretrained): 8.8% WER, natural.</a:t>
+              <a:t>HiFi-GAN (pretrained AI): 8.8% wrong, natural</a:t>
             </a:r>
             <a:endParaRPr lang="en-US" sz="1200" dirty="0"/>
           </a:p>
@@ -6175,7 +6183,7 @@
                   <a:schemeClr val="tx1"/>
                 </a:solidFill>
               </a:rPr>
-              <a:t>Same mel in both, so the words come from Colatron.</a:t>
+              <a:t>Same picture in both, so the words come from our model.</a:t>
             </a:r>
             <a:endParaRPr lang="en-US" sz="1200" dirty="0"/>
           </a:p>
@@ -6377,7 +6385,7 @@
                   <a:schemeClr val="accent6"/>
                 </a:solidFill>
               </a:rPr>
-              <a:t>word error rate for Colatron + HiFi-GAN, versus 100% for the baseline and 16% for Tacotron 2</a:t>
+              <a:t>of words wrong for our model, versus 100% for the baseline and 16% for Tacotron 2</a:t>
             </a:r>
             <a:endParaRPr lang="en-US" sz="1300" dirty="0"/>
           </a:p>
@@ -6417,7 +6425,7 @@
                   <a:schemeClr val="tx1"/>
                 </a:solidFill>
               </a:rPr>
-              <a:t>Model checkpoint: step 18,000</a:t>
+              <a:t>A speech-to-text program listens and types what it hears</a:t>
             </a:r>
             <a:endParaRPr lang="en-US" sz="1200" dirty="0"/>
           </a:p>
@@ -6435,7 +6443,7 @@
                   <a:schemeClr val="tx1"/>
                 </a:solidFill>
               </a:rPr>
-              <a:t>wav2vec 2.0 recogniser (never trained on LJ Speech) transcribes each clip</a:t>
+              <a:t>We count the words it gets wrong (WER)</a:t>
             </a:r>
             <a:endParaRPr lang="en-US" sz="1200" dirty="0"/>
           </a:p>
@@ -6453,7 +6461,7 @@
                   <a:schemeClr val="tx1"/>
                 </a:solidFill>
               </a:rPr>
-              <a:t>Compared word by word with the sentence we asked for</a:t>
+              <a:t>20 test sentences the model never saw</a:t>
             </a:r>
             <a:endParaRPr lang="en-US" sz="1200" dirty="0"/>
           </a:p>
@@ -6471,7 +6479,7 @@
                   <a:schemeClr val="tx1"/>
                 </a:solidFill>
               </a:rPr>
-              <a:t>20 held-out test clips; real recordings give the floor</a:t>
+              <a:t>Even real recordings get 5% wrong</a:t>
             </a:r>
             <a:endParaRPr lang="en-US" sz="1200" dirty="0"/>
           </a:p>
@@ -6673,7 +6681,7 @@
                   <a:schemeClr val="accent6"/>
                 </a:solidFill>
               </a:rPr>
-              <a:t>Colatron vs baseline, both through Griffin-Lim (a fair, same-vocoder comparison)</a:t>
+              <a:t>closer to the real recording than the baseline (same vocoder for both)</a:t>
             </a:r>
             <a:endParaRPr lang="en-US" sz="1300" dirty="0"/>
           </a:p>
@@ -6713,7 +6721,7 @@
                   <a:schemeClr val="tx1"/>
                 </a:solidFill>
               </a:rPr>
-              <a:t>Same 20 held-out test clips</a:t>
+              <a:t>Same 20 test sentences</a:t>
             </a:r>
             <a:endParaRPr lang="en-US" sz="1200" dirty="0"/>
           </a:p>
@@ -6731,7 +6739,7 @@
                   <a:schemeClr val="tx1"/>
                 </a:solidFill>
               </a:rPr>
-              <a:t>Generated audio → mel with the same settings</a:t>
+              <a:t>Compare our sound picture with the real recording's</a:t>
             </a:r>
             <a:endParaRPr lang="en-US" sz="1200" dirty="0"/>
           </a:p>
@@ -6749,7 +6757,7 @@
                   <a:schemeClr val="tx1"/>
                 </a:solidFill>
               </a:rPr>
-              <a:t>DTW lines up the two mels in time before comparing</a:t>
+              <a:t>Line them up in time first, since speed can differ</a:t>
             </a:r>
             <a:endParaRPr lang="en-US" sz="1200" dirty="0"/>
           </a:p>
@@ -7031,7 +7039,7 @@
                   <a:schemeClr val="tx1"/>
                 </a:solidFill>
               </a:rPr>
-              <a:t>Syllables, pauses and pitch stripes appear: attention gives it timing.</a:t>
+              <a:t>You can see syllables and pauses: attention gives it timing.</a:t>
             </a:r>
             <a:endParaRPr lang="en-US" sz="1300" dirty="0"/>
           </a:p>
@@ -7081,7 +7089,7 @@
                   <a:schemeClr val="tx1"/>
                 </a:solidFill>
               </a:rPr>
-              <a:t>Sharper detail from 4× the parameters and days of GPU training.</a:t>
+              <a:t>Even sharper: 4× bigger and trained for days on big GPUs.</a:t>
             </a:r>
             <a:endParaRPr lang="en-US" sz="1300" dirty="0"/>
           </a:p>
@@ -7325,7 +7333,7 @@
                   <a:schemeClr val="accent6"/>
                 </a:solidFill>
               </a:rPr>
-              <a:t>Our from-scratch Colatron reads text in order (99–100% monotonic); the paper's attention never aligned.</a:t>
+              <a:t>Our model reads the text in order (99–100% of the time); the 2018 model never did.</a:t>
             </a:r>
             <a:endParaRPr lang="en-US" sz="1200" dirty="0"/>
           </a:p>
@@ -7458,7 +7466,7 @@
                   <a:schemeClr val="accent6"/>
                 </a:solidFill>
               </a:rPr>
-              <a:t>Without attention the baseline is 100% word error; Colatron is 9%.</a:t>
+              <a:t>Without attention: 100% of words wrong. With attention: 9%.</a:t>
             </a:r>
             <a:endParaRPr lang="en-US" sz="1200" dirty="0"/>
           </a:p>
@@ -7724,7 +7732,7 @@
                   <a:schemeClr val="accent6"/>
                 </a:solidFill>
               </a:rPr>
-              <a:t>5.3 h of training (laptop CPU + free Colab GPU); speaks on a laptop CPU.</a:t>
+              <a:t>5.3 hours of training on a laptop and a free Google GPU; runs on a normal laptop.</a:t>
             </a:r>
             <a:endParaRPr lang="en-US" sz="1200" dirty="0"/>
           </a:p>
@@ -8498,7 +8506,7 @@
                   <a:schemeClr val="tx1"/>
                 </a:solidFill>
               </a:rPr>
-              <a:t>Text in, speech out, trained on LJ Speech</a:t>
+              <a:t>Goal: type a sentence, hear it spoken</a:t>
             </a:r>
             <a:endParaRPr lang="en-US" sz="1600" dirty="0"/>
           </a:p>
@@ -8516,7 +8524,7 @@
                   <a:schemeClr val="tx1"/>
                 </a:solidFill>
               </a:rPr>
-              <a:t>Only about 200 sentences used for training</a:t>
+              <a:t>Trained on only about 200 sentences</a:t>
             </a:r>
             <a:endParaRPr lang="en-US" sz="1600" dirty="0"/>
           </a:p>
@@ -8534,7 +8542,7 @@
                   <a:schemeClr val="tx1"/>
                 </a:solidFill>
               </a:rPr>
-              <a:t>Words randomly mapped to phonemes or letters</a:t>
+              <a:t>The same word could be fed in differently each time</a:t>
             </a:r>
             <a:endParaRPr lang="en-US" sz="1600" dirty="0"/>
           </a:p>
@@ -8552,25 +8560,7 @@
                   <a:schemeClr val="tx1"/>
                 </a:solidFill>
               </a:rPr>
-              <a:t>Three models: SVR, a 4-layer neural net, seq2seq LSTM with attention</a:t>
-            </a:r>
-            <a:endParaRPr lang="en-US" sz="1600" dirty="0"/>
-          </a:p>
-          <a:p>
-            <a:pPr marL="342900" indent="-342900">
-              <a:spcAft>
-                <a:spcPts val="800"/>
-              </a:spcAft>
-              <a:buSzPct val="100000"/>
-              <a:buChar char="•"/>
-            </a:pPr>
-            <a:r>
-              <a:rPr lang="en-US" sz="1600" dirty="0">
-                <a:solidFill>
-                  <a:schemeClr val="tx1"/>
-                </a:solidFill>
-              </a:rPr>
-              <a:t>Inverse STFT to turn spectrograms into audio</a:t>
+              <a:t>Tried 3 models; even the best one mumbled and repeated words</a:t>
             </a:r>
             <a:endParaRPr lang="en-US" sz="1600" dirty="0"/>
           </a:p>
@@ -9100,7 +9090,7 @@
                   <a:schemeClr val="tx1"/>
                 </a:solidFill>
               </a:rPr>
-              <a:t>Shallow models</a:t>
+              <a:t>Models too simple</a:t>
             </a:r>
             <a:endParaRPr lang="en-US" sz="1600" dirty="0"/>
           </a:p>
@@ -9136,7 +9126,7 @@
                   <a:schemeClr val="accent6"/>
                 </a:solidFill>
               </a:rPr>
-              <a:t>SVR and a 4-layer net cannot map text to a large spectrogram</a:t>
+              <a:t>Too small to turn a sentence into detailed sound</a:t>
             </a:r>
             <a:endParaRPr lang="en-US" sz="1200" dirty="0"/>
           </a:p>
@@ -9183,7 +9173,7 @@
                   <a:schemeClr val="tx1"/>
                 </a:solidFill>
               </a:rPr>
-              <a:t>Deep seq2seq: conv + BiLSTM encoder, LSTM decoder, post-net</a:t>
+              <a:t>A bigger model that reads the whole sentence, then draws the sound step by step</a:t>
             </a:r>
             <a:endParaRPr lang="en-US" sz="1300" dirty="0"/>
           </a:p>
@@ -9390,7 +9380,7 @@
                   <a:schemeClr val="tx1"/>
                 </a:solidFill>
               </a:rPr>
-              <a:t>Text cleaning plus a fixed 37-symbol character vocabulary</a:t>
+              <a:t>Clean the text and give every letter one fixed number</a:t>
             </a:r>
             <a:endParaRPr lang="en-US" sz="1300" dirty="0"/>
           </a:p>
@@ -9514,7 +9504,7 @@
                   <a:schemeClr val="tx1"/>
                 </a:solidFill>
               </a:rPr>
-              <a:t>Attention never aligned</a:t>
+              <a:t>Lost its place in the text</a:t>
             </a:r>
             <a:endParaRPr lang="en-US" sz="1600" dirty="0"/>
           </a:p>
@@ -9550,7 +9540,7 @@
                   <a:schemeClr val="accent6"/>
                 </a:solidFill>
               </a:rPr>
-              <a:t>The decoder lost its place, so words repeated</a:t>
+              <a:t>It didn't know which word it was on, so words repeated</a:t>
             </a:r>
             <a:endParaRPr lang="en-US" sz="1200" dirty="0"/>
           </a:p>
@@ -9597,7 +9587,7 @@
                   <a:schemeClr val="tx1"/>
                 </a:solidFill>
               </a:rPr>
-              <a:t>Location-sensitive attention + guided attention loss</a:t>
+              <a:t>Attention that remembers where it was, plus a training rule to read in order</a:t>
             </a:r>
             <a:endParaRPr lang="en-US" sz="1300" dirty="0"/>
           </a:p>
@@ -9931,7 +9921,7 @@
                   <a:schemeClr val="accent6"/>
                 </a:solidFill>
               </a:rPr>
-              <a:t>numbers, abbreviations, fixed character ids</a:t>
+              <a:t>"$42" → "forty two dollars"</a:t>
             </a:r>
             <a:endParaRPr lang="en-US" sz="1100" dirty="0"/>
           </a:p>
@@ -10019,7 +10009,7 @@
                   <a:schemeClr val="bg1"/>
                 </a:solidFill>
               </a:rPr>
-              <a:t>Acoustic model</a:t>
+              <a:t>Model</a:t>
             </a:r>
             <a:endParaRPr lang="en-US" sz="1400" dirty="0"/>
           </a:p>
@@ -10179,7 +10169,7 @@
                   <a:schemeClr val="accent6"/>
                 </a:solidFill>
               </a:rPr>
-              <a:t>80 bands, 256-sample hop</a:t>
+              <a:t>a picture of the sound</a:t>
             </a:r>
             <a:endParaRPr lang="en-US" sz="1100" dirty="0"/>
           </a:p>
@@ -10303,7 +10293,7 @@
                   <a:schemeClr val="accent6"/>
                 </a:solidFill>
               </a:rPr>
-              <a:t>Griffin-Lim (ours) or HiFi-GAN (pretrained)</a:t>
+              <a:t>turns the picture into audio</a:t>
             </a:r>
             <a:endParaRPr lang="en-US" sz="1100" dirty="0"/>
           </a:p>
@@ -10427,7 +10417,7 @@
                   <a:schemeClr val="accent6"/>
                 </a:solidFill>
               </a:rPr>
-              <a:t>22,050 Hz audio</a:t>
+              <a:t>the speech you hear</a:t>
             </a:r>
             <a:endParaRPr lang="en-US" sz="1100" dirty="0"/>
           </a:p>
@@ -10589,7 +10579,7 @@
                   <a:schemeClr val="tx1"/>
                 </a:solidFill>
               </a:rPr>
-              <a:t>Every part shares one mel format (src/audio_config.py), so any acoustic model can feed any vocoder. That makes fair comparisons possible.</a:t>
+              <a:t>Every model draws the same kind of sound picture, so we can plug any model into any vocoder and compare them fairly.</a:t>
             </a:r>
             <a:endParaRPr lang="en-US" sz="1400" dirty="0"/>
           </a:p>
@@ -10777,8 +10767,8 @@
         </p:nvSpPr>
         <p:spPr>
           <a:xfrm>
-            <a:off x="685800" y="1737360"/>
-            <a:ext cx="4389120" cy="2697480"/>
+            <a:off x="685800" y="1691640"/>
+            <a:ext cx="4389120" cy="2743200"/>
           </a:xfrm>
           <a:prstGeom prst="rect">
             <a:avLst/>
@@ -10792,110 +10782,110 @@
           <a:p>
             <a:pPr marL="342900" indent="-342900">
               <a:spcAft>
-                <a:spcPts val="900"/>
+                <a:spcPts val="500"/>
               </a:spcAft>
               <a:buSzPct val="100000"/>
               <a:buChar char="•"/>
             </a:pPr>
             <a:r>
-              <a:rPr lang="en-US" sz="1400" dirty="0">
+              <a:rPr lang="en-US" sz="1300" dirty="0">
                 <a:solidFill>
                   <a:schemeClr val="tx1"/>
                 </a:solidFill>
               </a:rPr>
-              <a:t>Colatron: seq2seq + attention, trained from scratch on 13,100 clips</a:t>
-            </a:r>
-            <a:endParaRPr lang="en-US" sz="1400" dirty="0"/>
+              <a:t>Colatron: our main model, trained from scratch on 13,100 clips</a:t>
+            </a:r>
+            <a:endParaRPr lang="en-US" sz="1300" dirty="0"/>
           </a:p>
           <a:p>
             <a:pPr marL="342900" indent="-342900">
               <a:spcAft>
-                <a:spcPts val="900"/>
+                <a:spcPts val="500"/>
               </a:spcAft>
               <a:buSzPct val="100000"/>
               <a:buChar char="•"/>
             </a:pPr>
             <a:r>
-              <a:rPr lang="en-US" sz="1400" dirty="0">
+              <a:rPr lang="en-US" sz="1300" dirty="0">
                 <a:solidFill>
                   <a:schemeClr val="tx1"/>
                 </a:solidFill>
               </a:rPr>
-              <a:t>Baseline without attention (the lower bound)</a:t>
-            </a:r>
-            <a:endParaRPr lang="en-US" sz="1400" dirty="0"/>
+              <a:t>Baseline: a simple model without attention, to compare against</a:t>
+            </a:r>
+            <a:endParaRPr lang="en-US" sz="1300" dirty="0"/>
           </a:p>
           <a:p>
             <a:pPr marL="342900" indent="-342900">
               <a:spcAft>
-                <a:spcPts val="900"/>
+                <a:spcPts val="500"/>
               </a:spcAft>
               <a:buSzPct val="100000"/>
               <a:buChar char="•"/>
             </a:pPr>
             <a:r>
-              <a:rPr lang="en-US" sz="1400" dirty="0">
+              <a:rPr lang="en-US" sz="1300" dirty="0">
                 <a:solidFill>
                   <a:schemeClr val="tx1"/>
                 </a:solidFill>
               </a:rPr>
-              <a:t>Data pipeline: cleaning, fixed vocabulary, mels, splits</a:t>
-            </a:r>
-            <a:endParaRPr lang="en-US" sz="1400" dirty="0"/>
+              <a:t>Data preparation: text cleaning, sound pictures, train / test split</a:t>
+            </a:r>
+            <a:endParaRPr lang="en-US" sz="1300" dirty="0"/>
           </a:p>
           <a:p>
             <a:pPr marL="342900" indent="-342900">
               <a:spcAft>
-                <a:spcPts val="900"/>
+                <a:spcPts val="500"/>
               </a:spcAft>
               <a:buSzPct val="100000"/>
               <a:buChar char="•"/>
             </a:pPr>
             <a:r>
-              <a:rPr lang="en-US" sz="1400" dirty="0">
+              <a:rPr lang="en-US" sz="1300" dirty="0">
                 <a:solidFill>
                   <a:schemeClr val="tx1"/>
                 </a:solidFill>
               </a:rPr>
-              <a:t>Griffin-Lim vocoder and shared audio settings</a:t>
-            </a:r>
-            <a:endParaRPr lang="en-US" sz="1400" dirty="0"/>
+              <a:t>Griffin-Lim: a simple, non-AI way to turn pictures into audio</a:t>
+            </a:r>
+            <a:endParaRPr lang="en-US" sz="1300" dirty="0"/>
           </a:p>
           <a:p>
             <a:pPr marL="342900" indent="-342900">
               <a:spcAft>
-                <a:spcPts val="900"/>
+                <a:spcPts val="500"/>
               </a:spcAft>
               <a:buSzPct val="100000"/>
               <a:buChar char="•"/>
             </a:pPr>
             <a:r>
-              <a:rPr lang="en-US" sz="1400" dirty="0">
+              <a:rPr lang="en-US" sz="1300" dirty="0">
                 <a:solidFill>
                   <a:schemeClr val="tx1"/>
                 </a:solidFill>
               </a:rPr>
-              <a:t>Evaluation: intelligibility, mel distance, alignment</a:t>
-            </a:r>
-            <a:endParaRPr lang="en-US" sz="1400" dirty="0"/>
+              <a:t>Scoring: how understandable it is, how close to the real voice</a:t>
+            </a:r>
+            <a:endParaRPr lang="en-US" sz="1300" dirty="0"/>
           </a:p>
           <a:p>
             <a:pPr marL="342900" indent="-342900">
               <a:spcAft>
-                <a:spcPts val="900"/>
+                <a:spcPts val="500"/>
               </a:spcAft>
               <a:buSzPct val="100000"/>
               <a:buChar char="•"/>
             </a:pPr>
             <a:r>
-              <a:rPr lang="en-US" sz="1400" dirty="0">
+              <a:rPr lang="en-US" sz="1300" dirty="0">
                 <a:solidFill>
                   <a:schemeClr val="tx1"/>
                 </a:solidFill>
               </a:rPr>
-              <a:t>Gradio demo with every system</a:t>
-            </a:r>
-            <a:endParaRPr lang="en-US" sz="1400" dirty="0"/>
+              <a:t>A web demo to try every model</a:t>
+            </a:r>
+            <a:endParaRPr lang="en-US" sz="1300" dirty="0"/>
           </a:p>
         </p:txBody>
       </p:sp>
@@ -11006,7 +10996,7 @@
                   <a:schemeClr val="tx1"/>
                 </a:solidFill>
               </a:rPr>
-              <a:t>torchaudio, trained for days on GPUs</a:t>
+              <a:t>Google's model, only to compare against</a:t>
             </a:r>
             <a:endParaRPr lang="en-US" sz="1200" dirty="0"/>
           </a:p>
@@ -11048,7 +11038,7 @@
                   <a:schemeClr val="tx1"/>
                 </a:solidFill>
               </a:rPr>
-              <a:t>SpeechBrain, mel → audio</a:t>
+              <a:t>turns sound pictures into natural audio</a:t>
             </a:r>
             <a:endParaRPr lang="en-US" sz="1200" dirty="0"/>
           </a:p>
@@ -11076,7 +11066,7 @@
                   <a:schemeClr val="tx1"/>
                 </a:solidFill>
               </a:rPr>
-              <a:t>wav2vec 2.0 recogniser</a:t>
+              <a:t>Speech-to-text program</a:t>
             </a:r>
             <a:endParaRPr lang="en-US" sz="1200" dirty="0"/>
           </a:p>
@@ -11090,7 +11080,7 @@
                   <a:schemeClr val="tx1"/>
                 </a:solidFill>
               </a:rPr>
-              <a:t>only used to score intelligibility</a:t>
+              <a:t>only the judge: types what it hears</a:t>
             </a:r>
             <a:endParaRPr lang="en-US" sz="1200" dirty="0"/>
           </a:p>
@@ -11137,7 +11127,7 @@
                   <a:schemeClr val="tx1"/>
                 </a:solidFill>
               </a:rPr>
-              <a:t>the same model family as Colatron, at full scale.</a:t>
+              <a:t>the same kind of model as Colatron, but much bigger.</a:t>
             </a:r>
             <a:endParaRPr lang="en-US" sz="1200" dirty="0"/>
           </a:p>
@@ -11667,7 +11657,7 @@
                   <a:schemeClr val="accent6"/>
                 </a:solidFill>
               </a:rPr>
-              <a:t>Fixed ids (37 symbols)</a:t>
+              <a:t>Each letter → one fixed number (37 symbols)</a:t>
             </a:r>
             <a:endParaRPr lang="en-US" sz="1400" dirty="0"/>
           </a:p>
@@ -11724,7 +11714,7 @@
                   <a:schemeClr val="tx1"/>
                 </a:solidFill>
               </a:rPr>
-              <a:t>Audio → 80-band log-mel spectrogram (FFT 1024, hop 256, 0 to 8 kHz)</a:t>
+              <a:t>Each recording is turned into a picture of the sound</a:t>
             </a:r>
             <a:endParaRPr lang="en-US" sz="1400" dirty="0"/>
           </a:p>
@@ -11742,7 +11732,7 @@
                   <a:schemeClr val="tx1"/>
                 </a:solidFill>
               </a:rPr>
-              <a:t>All 13,100 mels computed once in parallel, kept in memory (1.2 GB)</a:t>
+              <a:t>All 13,100 pictures made once, before training</a:t>
             </a:r>
             <a:endParaRPr lang="en-US" sz="1400" dirty="0"/>
           </a:p>
@@ -11760,7 +11750,7 @@
                   <a:schemeClr val="tx1"/>
                 </a:solidFill>
               </a:rPr>
-              <a:t>Same 40 test clips as the baseline; never used for training</a:t>
+              <a:t>40 test clips kept aside: never used for training</a:t>
             </a:r>
             <a:endParaRPr lang="en-US" sz="1400" dirty="0"/>
           </a:p>
@@ -11934,7 +11924,7 @@
                   <a:schemeClr val="tx1"/>
                 </a:solidFill>
               </a:rPr>
-              <a:t>Characters (fixed ids)</a:t>
+              <a:t>Letters of the sentence</a:t>
             </a:r>
             <a:endParaRPr lang="en-US" sz="1400" dirty="0"/>
           </a:p>
@@ -11997,7 +11987,7 @@
                   <a:schemeClr val="tx1"/>
                 </a:solidFill>
               </a:rPr>
-              <a:t>Embedding, 128-d</a:t>
+              <a:t>Turn each letter into numbers</a:t>
             </a:r>
             <a:endParaRPr lang="en-US" sz="1400" dirty="0"/>
           </a:p>
@@ -12060,7 +12050,7 @@
                   <a:schemeClr val="tx1"/>
                 </a:solidFill>
               </a:rPr>
-              <a:t>3 × Conv1D, 256 channels, kernel 5</a:t>
+              <a:t>Look at neighbouring letters</a:t>
             </a:r>
             <a:endParaRPr lang="en-US" sz="1400" dirty="0"/>
           </a:p>
@@ -12123,7 +12113,7 @@
                   <a:schemeClr val="bg1"/>
                 </a:solidFill>
               </a:rPr>
-              <a:t>Stretch to target length (no attention)</a:t>
+              <a:t>Give every letter the same time (no attention)</a:t>
             </a:r>
             <a:endParaRPr lang="en-US" sz="1400" dirty="0"/>
           </a:p>
@@ -12186,7 +12176,7 @@
                   <a:schemeClr val="tx1"/>
                 </a:solidFill>
               </a:rPr>
-              <a:t>MLP → 80-band mel frames</a:t>
+              <a:t>Draw the sound picture</a:t>
             </a:r>
             <a:endParaRPr lang="en-US" sz="1400" dirty="0"/>
           </a:p>
@@ -12249,7 +12239,7 @@
                   <a:schemeClr val="tx1"/>
                 </a:solidFill>
               </a:rPr>
-              <a:t>Griffin-Lim → audio</a:t>
+              <a:t>Turn the picture into audio</a:t>
             </a:r>
             <a:endParaRPr lang="en-US" sz="1400" dirty="0"/>
           </a:p>
@@ -12325,7 +12315,7 @@
                   <a:schemeClr val="tx1"/>
                 </a:solidFill>
               </a:rPr>
-              <a:t>324 training clips, 911k parameters</a:t>
+              <a:t>Trained on 324 clips</a:t>
             </a:r>
             <a:endParaRPr lang="en-US" sz="1400" dirty="0"/>
           </a:p>
@@ -12343,7 +12333,7 @@
                   <a:schemeClr val="tx1"/>
                 </a:solidFill>
               </a:rPr>
-              <a:t>L1 loss on normalised mel frames</a:t>
+              <a:t>Small: about 0.9 million numbers</a:t>
             </a:r>
             <a:endParaRPr lang="en-US" sz="1400" dirty="0"/>
           </a:p>
@@ -12361,25 +12351,7 @@
                   <a:schemeClr val="tx1"/>
                 </a:solidFill>
               </a:rPr>
-              <a:t>Adam, learning rate 1e-3, gradient clipping 1.0</a:t>
-            </a:r>
-            <a:endParaRPr lang="en-US" sz="1400" dirty="0"/>
-          </a:p>
-          <a:p>
-            <a:pPr marL="342900" indent="-342900">
-              <a:spcAft>
-                <a:spcPts val="400"/>
-              </a:spcAft>
-              <a:buSzPct val="100000"/>
-              <a:buChar char="•"/>
-            </a:pPr>
-            <a:r>
-              <a:rPr lang="en-US" sz="1400" dirty="0">
-                <a:solidFill>
-                  <a:schemeClr val="tx1"/>
-                </a:solidFill>
-              </a:rPr>
-              <a:t>60 epochs, batch 16, best validation checkpoint</a:t>
+              <a:t>Learns by comparing its picture with the real one</a:t>
             </a:r>
             <a:endParaRPr lang="en-US" sz="1400" dirty="0"/>
           </a:p>
@@ -12426,7 +12398,7 @@
                   <a:schemeClr val="tx1"/>
                 </a:solidFill>
               </a:rPr>
-              <a:t>Like the paper's simple models, it has no learned alignment: each character gets an equal share of time. It shows what happens without attention.</a:t>
+              <a:t>Real speech gives some letters more time than others, and has pauses. This model can't learn that, so it sounds like static.</a:t>
             </a:r>
             <a:endParaRPr lang="en-US" sz="1400" dirty="0"/>
           </a:p>
@@ -12670,7 +12642,7 @@
                   <a:schemeClr val="accent6"/>
                 </a:solidFill>
               </a:rPr>
-              <a:t>character embedding, 3 convolutions, bidirectional LSTM</a:t>
+              <a:t>reads the whole sentence, forwards and backwards</a:t>
             </a:r>
             <a:endParaRPr lang="en-US" sz="1300" dirty="0"/>
           </a:p>
@@ -12767,7 +12739,7 @@
                   <a:schemeClr val="tx1"/>
                 </a:solidFill>
               </a:rPr>
-              <a:t>Location-sensitive attention</a:t>
+              <a:t>Attention</a:t>
             </a:r>
             <a:endParaRPr lang="en-US" sz="1600" dirty="0"/>
           </a:p>
@@ -12803,7 +12775,7 @@
                   <a:schemeClr val="accent6"/>
                 </a:solidFill>
               </a:rPr>
-              <a:t>sees where it looked before, so it moves forward through the text</a:t>
+              <a:t>the finger on the text: which letter are we saying now? It remembers where it was, so it moves forward</a:t>
             </a:r>
             <a:endParaRPr lang="en-US" sz="1300" dirty="0"/>
           </a:p>
@@ -12936,7 +12908,7 @@
                   <a:schemeClr val="accent6"/>
                 </a:solidFill>
               </a:rPr>
-              <a:t>LSTMs predict 3 mel frames per step, plus a stop signal</a:t>
+              <a:t>draws the sound picture a few columns at a time, and says when it is done</a:t>
             </a:r>
             <a:endParaRPr lang="en-US" sz="1300" dirty="0"/>
           </a:p>
@@ -13069,7 +13041,7 @@
                   <a:schemeClr val="accent6"/>
                 </a:solidFill>
               </a:rPr>
-              <a:t>5 convolutions sharpen the whole spectrogram</a:t>
+              <a:t>cleans up the finished picture</a:t>
             </a:r>
             <a:endParaRPr lang="en-US" sz="1300" dirty="0"/>
           </a:p>
@@ -13272,7 +13244,7 @@
                   <a:schemeClr val="tx1"/>
                 </a:solidFill>
               </a:rPr>
-              <a:t>7.4M parameters, all starting from random values</a:t>
+              <a:t>7.4M numbers, all starting random: it learned everything itself</a:t>
             </a:r>
             <a:endParaRPr lang="en-US" sz="1300" dirty="0"/>
           </a:p>
@@ -13480,7 +13452,7 @@
                   <a:schemeClr val="tx1"/>
                 </a:solidFill>
               </a:rPr>
-              <a:t>Pick 64 clips</a:t>
+              <a:t>Take 64 recordings</a:t>
             </a:r>
             <a:endParaRPr lang="en-US" sz="1500" dirty="0"/>
           </a:p>
@@ -13516,7 +13488,7 @@
                   <a:schemeClr val="accent6"/>
                 </a:solidFill>
               </a:rPr>
-              <a:t>similar lengths grouped together</a:t>
+              <a:t>with the text that was read</a:t>
             </a:r>
             <a:endParaRPr lang="en-US" sz="1200" dirty="0"/>
           </a:p>
@@ -13613,7 +13585,7 @@
                   <a:schemeClr val="tx1"/>
                 </a:solidFill>
               </a:rPr>
-              <a:t>Draw their mels</a:t>
+              <a:t>Draw their sound pictures</a:t>
             </a:r>
             <a:endParaRPr lang="en-US" sz="1500" dirty="0"/>
           </a:p>
@@ -13649,7 +13621,7 @@
                   <a:schemeClr val="accent6"/>
                 </a:solidFill>
               </a:rPr>
-              <a:t>decoder is shown the real previous frames (teacher forcing)</a:t>
+              <a:t>the model draws a picture for each sentence</a:t>
             </a:r>
             <a:endParaRPr lang="en-US" sz="1200" dirty="0"/>
           </a:p>
@@ -13746,7 +13718,7 @@
                   <a:schemeClr val="tx1"/>
                 </a:solidFill>
               </a:rPr>
-              <a:t>Measure 3 losses</a:t>
+              <a:t>Check the mistakes</a:t>
             </a:r>
             <a:endParaRPr lang="en-US" sz="1500" dirty="0"/>
           </a:p>
@@ -13782,7 +13754,7 @@
                   <a:schemeClr val="accent6"/>
                 </a:solidFill>
               </a:rPr>
-              <a:t>compare with the real recordings</a:t>
+              <a:t>compare with the real recordings (the 3 checks on the right)</a:t>
             </a:r>
             <a:endParaRPr lang="en-US" sz="1200" dirty="0"/>
           </a:p>
@@ -13879,7 +13851,7 @@
                   <a:schemeClr val="tx1"/>
                 </a:solidFill>
               </a:rPr>
-              <a:t>Update weights</a:t>
+              <a:t>Adjust the model</a:t>
             </a:r>
             <a:endParaRPr lang="en-US" sz="1500" dirty="0"/>
           </a:p>
@@ -13915,7 +13887,7 @@
                   <a:schemeClr val="accent6"/>
                 </a:solidFill>
               </a:rPr>
-              <a:t>backpropagation, Adam, gradient clipping</a:t>
+              <a:t>nudge its numbers to be a bit less wrong</a:t>
             </a:r>
             <a:endParaRPr lang="en-US" sz="1200" dirty="0"/>
           </a:p>
@@ -14017,7 +13989,7 @@
                   <a:schemeClr val="accent1"/>
                 </a:solidFill>
               </a:rPr>
-              <a:t>The 3 losses</a:t>
+              <a:t>The 3 checks</a:t>
             </a:r>
             <a:endParaRPr lang="en-US" sz="1300" dirty="0"/>
           </a:p>
@@ -14051,7 +14023,7 @@
                   <a:schemeClr val="tx1"/>
                 </a:solidFill>
               </a:rPr>
-              <a:t>Mel (L1 + MSE): </a:t>
+              <a:t>Picture: </a:t>
             </a:r>
             <a:pPr indent="0" marL="0">
               <a:spcAft>
@@ -14065,7 +14037,7 @@
                   <a:schemeClr val="tx1"/>
                 </a:solidFill>
               </a:rPr>
-              <a:t>is the picture right?</a:t>
+              <a:t>does it match the real one?</a:t>
             </a:r>
             <a:endParaRPr lang="en-US" sz="1300" dirty="0"/>
           </a:p>
@@ -14082,7 +14054,7 @@
                   <a:schemeClr val="tx1"/>
                 </a:solidFill>
               </a:rPr>
-              <a:t>Stop (BCE): </a:t>
+              <a:t>Stop: </a:t>
             </a:r>
             <a:pPr indent="0" marL="0">
               <a:spcAft>
@@ -14113,7 +14085,7 @@
                   <a:schemeClr val="accent2"/>
                 </a:solidFill>
               </a:rPr>
-              <a:t>Guided attention: </a:t>
+              <a:t>Reading order: </a:t>
             </a:r>
             <a:pPr indent="0" marL="0">
               <a:spcAft>
@@ -14127,7 +14099,7 @@
                   <a:schemeClr val="tx1"/>
                 </a:solidFill>
               </a:rPr>
-              <a:t>is it reading the text in order?</a:t>
+              <a:t>is the finger moving left to right?</a:t>
             </a:r>
             <a:endParaRPr lang="en-US" sz="1300" dirty="0"/>
           </a:p>
@@ -14156,12 +14128,12 @@
               <a:buNone/>
             </a:pPr>
             <a:r>
-              <a:rPr lang="en-US" sz="1100" dirty="0">
-                <a:solidFill>
-                  <a:schemeClr val="accent6"/>
-                </a:solidFill>
-              </a:rPr>
-              <a:t>Learning rate 0.001, halved every 8,000 steps after step 8,000</a:t>
+              <a:rPr lang="en-US" sz="1200" b="1" dirty="0">
+                <a:solidFill>
+                  <a:schemeClr val="accent2"/>
+                </a:solidFill>
+              </a:rPr>
+              <a:t>The reading-order check is what the 2018 project was missing.</a:t>
             </a:r>
             <a:endParaRPr lang="en-US" sz="1300" dirty="0"/>
           </a:p>
@@ -14395,7 +14367,7 @@
                   <a:schemeClr val="accent6"/>
                 </a:solidFill>
               </a:rPr>
-              <a:t>5.3 h in total. Every 1,000 steps: check the 100 validation clips, keep the best weights.</a:t>
+              <a:t>5.3 h in total. Every 1,000 rounds we test it on 100 unseen clips and keep the best version.</a:t>
             </a:r>
             <a:endParaRPr lang="en-US" sz="1100" dirty="0"/>
           </a:p>

</xml_diff>